<commit_message>
Polish FIND-CKD deck: verified layout via slide renders
Rendered all 17 slides and fixed the issues found: consistent bullet
markers on every list item (inclusion/exclusion, design, appraisal),
and repositioned the up-titration note so it no longer overlaps the
dosing card on the intervention slide.

Co-Authored-By: Claude Opus 4.8 <noreply@anthropic.com>
Claude-Session: https://claude.ai/code/session_016WM8gpgPPTpUY1fDjELfFT
</commit_message>
<xml_diff>
--- a/FIND-CKD.pptx
+++ b/FIND-CKD.pptx
@@ -10488,14 +10488,15 @@
             <a:endParaRPr lang="en-US" sz="1250" dirty="0"/>
           </a:p>
           <a:p>
-            <a:pPr indent="0" marL="0">
+            <a:pPr marL="203200" indent="-203200">
               <a:lnSpc>
                 <a:spcPct val="105000"/>
               </a:lnSpc>
               <a:spcAft>
                 <a:spcPts val="900"/>
               </a:spcAft>
-              <a:buNone/>
+              <a:buSzPct val="100000"/>
+              <a:buChar char="✓"/>
             </a:pPr>
             <a:r>
               <a:rPr lang="en-US" sz="1250" dirty="0">
@@ -10511,14 +10512,15 @@
             <a:endParaRPr lang="en-US" sz="1250" dirty="0"/>
           </a:p>
           <a:p>
-            <a:pPr indent="0" marL="0">
+            <a:pPr marL="203200" indent="-203200">
               <a:lnSpc>
                 <a:spcPct val="105000"/>
               </a:lnSpc>
               <a:spcAft>
                 <a:spcPts val="900"/>
               </a:spcAft>
-              <a:buNone/>
+              <a:buSzPct val="100000"/>
+              <a:buChar char="✓"/>
             </a:pPr>
             <a:r>
               <a:rPr lang="en-US" sz="1250" dirty="0">
@@ -10534,14 +10536,15 @@
             <a:endParaRPr lang="en-US" sz="1250" dirty="0"/>
           </a:p>
           <a:p>
-            <a:pPr indent="0" marL="0">
+            <a:pPr marL="203200" indent="-203200">
               <a:lnSpc>
                 <a:spcPct val="105000"/>
               </a:lnSpc>
               <a:spcAft>
                 <a:spcPts val="900"/>
               </a:spcAft>
-              <a:buNone/>
+              <a:buSzPct val="100000"/>
+              <a:buChar char="✓"/>
             </a:pPr>
             <a:r>
               <a:rPr lang="en-US" sz="1250" dirty="0">
@@ -10557,14 +10560,15 @@
             <a:endParaRPr lang="en-US" sz="1250" dirty="0"/>
           </a:p>
           <a:p>
-            <a:pPr indent="0" marL="0">
+            <a:pPr marL="203200" indent="-203200">
               <a:lnSpc>
                 <a:spcPct val="105000"/>
               </a:lnSpc>
               <a:spcAft>
                 <a:spcPts val="900"/>
               </a:spcAft>
-              <a:buNone/>
+              <a:buSzPct val="100000"/>
+              <a:buChar char="✓"/>
             </a:pPr>
             <a:r>
               <a:rPr lang="en-US" sz="1250" dirty="0">
@@ -10699,14 +10703,15 @@
             <a:endParaRPr lang="en-US" sz="1250" dirty="0"/>
           </a:p>
           <a:p>
-            <a:pPr indent="0" marL="0">
+            <a:pPr marL="203200" indent="-203200">
               <a:lnSpc>
                 <a:spcPct val="105000"/>
               </a:lnSpc>
               <a:spcAft>
                 <a:spcPts val="900"/>
               </a:spcAft>
-              <a:buNone/>
+              <a:buSzPct val="100000"/>
+              <a:buChar char="✕"/>
             </a:pPr>
             <a:r>
               <a:rPr lang="en-US" sz="1250" dirty="0">
@@ -10722,14 +10727,15 @@
             <a:endParaRPr lang="en-US" sz="1250" dirty="0"/>
           </a:p>
           <a:p>
-            <a:pPr indent="0" marL="0">
+            <a:pPr marL="203200" indent="-203200">
               <a:lnSpc>
                 <a:spcPct val="105000"/>
               </a:lnSpc>
               <a:spcAft>
                 <a:spcPts val="900"/>
               </a:spcAft>
-              <a:buNone/>
+              <a:buSzPct val="100000"/>
+              <a:buChar char="✕"/>
             </a:pPr>
             <a:r>
               <a:rPr lang="en-US" sz="1250" dirty="0">
@@ -10745,14 +10751,15 @@
             <a:endParaRPr lang="en-US" sz="1250" dirty="0"/>
           </a:p>
           <a:p>
-            <a:pPr indent="0" marL="0">
+            <a:pPr marL="203200" indent="-203200">
               <a:lnSpc>
                 <a:spcPct val="105000"/>
               </a:lnSpc>
               <a:spcAft>
                 <a:spcPts val="900"/>
               </a:spcAft>
-              <a:buNone/>
+              <a:buSzPct val="100000"/>
+              <a:buChar char="✕"/>
             </a:pPr>
             <a:r>
               <a:rPr lang="en-US" sz="1250" dirty="0">
@@ -10768,14 +10775,15 @@
             <a:endParaRPr lang="en-US" sz="1250" dirty="0"/>
           </a:p>
           <a:p>
-            <a:pPr indent="0" marL="0">
+            <a:pPr marL="203200" indent="-203200">
               <a:lnSpc>
                 <a:spcPct val="105000"/>
               </a:lnSpc>
               <a:spcAft>
                 <a:spcPts val="900"/>
               </a:spcAft>
-              <a:buNone/>
+              <a:buSzPct val="100000"/>
+              <a:buChar char="✕"/>
             </a:pPr>
             <a:r>
               <a:rPr lang="en-US" sz="1250" dirty="0">
@@ -16389,11 +16397,12 @@
             <a:endParaRPr lang="en-US" sz="1200" dirty="0"/>
           </a:p>
           <a:p>
-            <a:pPr indent="0" marL="0">
+            <a:pPr marL="152400" indent="-152400">
               <a:lnSpc>
                 <a:spcPct val="110000"/>
               </a:lnSpc>
-              <a:buNone/>
+              <a:buSzPct val="100000"/>
+              <a:buChar char="•"/>
             </a:pPr>
             <a:r>
               <a:rPr lang="en-US" sz="1200" dirty="0">
@@ -16562,11 +16571,12 @@
             <a:endParaRPr lang="en-US" sz="1150" dirty="0"/>
           </a:p>
           <a:p>
-            <a:pPr indent="0" marL="0">
+            <a:pPr marL="152400" indent="-152400">
               <a:lnSpc>
                 <a:spcPct val="108000"/>
               </a:lnSpc>
-              <a:buNone/>
+              <a:buSzPct val="100000"/>
+              <a:buChar char="•"/>
             </a:pPr>
             <a:r>
               <a:rPr lang="en-US" sz="1150" dirty="0">
@@ -16582,11 +16592,12 @@
             <a:endParaRPr lang="en-US" sz="1150" dirty="0"/>
           </a:p>
           <a:p>
-            <a:pPr indent="0" marL="0">
+            <a:pPr marL="152400" indent="-152400">
               <a:lnSpc>
                 <a:spcPct val="108000"/>
               </a:lnSpc>
-              <a:buNone/>
+              <a:buSzPct val="100000"/>
+              <a:buChar char="•"/>
             </a:pPr>
             <a:r>
               <a:rPr lang="en-US" sz="1150" dirty="0">
@@ -16904,14 +16915,15 @@
             <a:endParaRPr lang="en-US" sz="1300" dirty="0"/>
           </a:p>
           <a:p>
-            <a:pPr indent="0" marL="0">
+            <a:pPr marL="203200" indent="-203200">
               <a:lnSpc>
                 <a:spcPct val="135000"/>
               </a:lnSpc>
               <a:spcAft>
                 <a:spcPts val="800"/>
               </a:spcAft>
-              <a:buNone/>
+              <a:buSzPct val="100000"/>
+              <a:buChar char="✓"/>
             </a:pPr>
             <a:r>
               <a:rPr lang="en-US" sz="1300" dirty="0">
@@ -16927,14 +16939,15 @@
             <a:endParaRPr lang="en-US" sz="1300" dirty="0"/>
           </a:p>
           <a:p>
-            <a:pPr indent="0" marL="0">
+            <a:pPr marL="203200" indent="-203200">
               <a:lnSpc>
                 <a:spcPct val="135000"/>
               </a:lnSpc>
               <a:spcAft>
                 <a:spcPts val="800"/>
               </a:spcAft>
-              <a:buNone/>
+              <a:buSzPct val="100000"/>
+              <a:buChar char="✓"/>
             </a:pPr>
             <a:r>
               <a:rPr lang="en-US" sz="1300" dirty="0">
@@ -16950,14 +16963,15 @@
             <a:endParaRPr lang="en-US" sz="1300" dirty="0"/>
           </a:p>
           <a:p>
-            <a:pPr indent="0" marL="0">
+            <a:pPr marL="203200" indent="-203200">
               <a:lnSpc>
                 <a:spcPct val="135000"/>
               </a:lnSpc>
               <a:spcAft>
                 <a:spcPts val="800"/>
               </a:spcAft>
-              <a:buNone/>
+              <a:buSzPct val="100000"/>
+              <a:buChar char="✓"/>
             </a:pPr>
             <a:r>
               <a:rPr lang="en-US" sz="1300" dirty="0">
@@ -16973,14 +16987,15 @@
             <a:endParaRPr lang="en-US" sz="1300" dirty="0"/>
           </a:p>
           <a:p>
-            <a:pPr indent="0" marL="0">
+            <a:pPr marL="203200" indent="-203200">
               <a:lnSpc>
                 <a:spcPct val="135000"/>
               </a:lnSpc>
               <a:spcAft>
                 <a:spcPts val="800"/>
               </a:spcAft>
-              <a:buNone/>
+              <a:buSzPct val="100000"/>
+              <a:buChar char="✓"/>
             </a:pPr>
             <a:r>
               <a:rPr lang="en-US" sz="1300" dirty="0">
@@ -17115,14 +17130,15 @@
             <a:endParaRPr lang="en-US" sz="1300" dirty="0"/>
           </a:p>
           <a:p>
-            <a:pPr indent="0" marL="0">
+            <a:pPr marL="203200" indent="-203200">
               <a:lnSpc>
                 <a:spcPct val="135000"/>
               </a:lnSpc>
               <a:spcAft>
                 <a:spcPts val="800"/>
               </a:spcAft>
-              <a:buNone/>
+              <a:buSzPct val="100000"/>
+              <a:buChar char="✕"/>
             </a:pPr>
             <a:r>
               <a:rPr lang="en-US" sz="1300" dirty="0">
@@ -17138,14 +17154,15 @@
             <a:endParaRPr lang="en-US" sz="1300" dirty="0"/>
           </a:p>
           <a:p>
-            <a:pPr indent="0" marL="0">
+            <a:pPr marL="203200" indent="-203200">
               <a:lnSpc>
                 <a:spcPct val="135000"/>
               </a:lnSpc>
               <a:spcAft>
                 <a:spcPts val="800"/>
               </a:spcAft>
-              <a:buNone/>
+              <a:buSzPct val="100000"/>
+              <a:buChar char="✕"/>
             </a:pPr>
             <a:r>
               <a:rPr lang="en-US" sz="1300" dirty="0">
@@ -17161,14 +17178,15 @@
             <a:endParaRPr lang="en-US" sz="1300" dirty="0"/>
           </a:p>
           <a:p>
-            <a:pPr indent="0" marL="0">
+            <a:pPr marL="203200" indent="-203200">
               <a:lnSpc>
                 <a:spcPct val="135000"/>
               </a:lnSpc>
               <a:spcAft>
                 <a:spcPts val="800"/>
               </a:spcAft>
-              <a:buNone/>
+              <a:buSzPct val="100000"/>
+              <a:buChar char="✕"/>
             </a:pPr>
             <a:r>
               <a:rPr lang="en-US" sz="1300" dirty="0">
@@ -17184,14 +17202,15 @@
             <a:endParaRPr lang="en-US" sz="1300" dirty="0"/>
           </a:p>
           <a:p>
-            <a:pPr indent="0" marL="0">
+            <a:pPr marL="203200" indent="-203200">
               <a:lnSpc>
                 <a:spcPct val="135000"/>
               </a:lnSpc>
               <a:spcAft>
                 <a:spcPts val="800"/>
               </a:spcAft>
-              <a:buNone/>
+              <a:buSzPct val="100000"/>
+              <a:buChar char="✕"/>
             </a:pPr>
             <a:r>
               <a:rPr lang="en-US" sz="1300" dirty="0">
@@ -19265,12 +19284,12 @@
         </p:nvSpPr>
         <p:spPr>
           <a:xfrm>
-            <a:off x="822960" y="1901952"/>
-            <a:ext cx="5303520" cy="658368"/>
+            <a:off x="822960" y="1874520"/>
+            <a:ext cx="5303520" cy="530352"/>
           </a:xfrm>
           <a:prstGeom prst="roundRect">
             <a:avLst>
-              <a:gd name="adj" fmla="val 12500"/>
+              <a:gd name="adj" fmla="val 15517"/>
             </a:avLst>
           </a:prstGeom>
           <a:solidFill>
@@ -19292,8 +19311,8 @@
         </p:nvSpPr>
         <p:spPr>
           <a:xfrm>
-            <a:off x="1024128" y="1901952"/>
-            <a:ext cx="2377440" cy="658368"/>
+            <a:off x="1024128" y="1874520"/>
+            <a:ext cx="2377440" cy="530352"/>
           </a:xfrm>
           <a:prstGeom prst="rect">
             <a:avLst/>
@@ -19331,7 +19350,7 @@
         </p:nvSpPr>
         <p:spPr>
           <a:xfrm>
-            <a:off x="3218688" y="2139696"/>
+            <a:off x="3218688" y="2048256"/>
             <a:ext cx="365760" cy="201168"/>
           </a:xfrm>
           <a:prstGeom prst="rightArrow">
@@ -19351,8 +19370,8 @@
         </p:nvSpPr>
         <p:spPr>
           <a:xfrm>
-            <a:off x="3675888" y="1901952"/>
-            <a:ext cx="2377440" cy="658368"/>
+            <a:off x="3675888" y="1874520"/>
+            <a:ext cx="2377440" cy="530352"/>
           </a:xfrm>
           <a:prstGeom prst="rect">
             <a:avLst/>
@@ -19390,12 +19409,12 @@
         </p:nvSpPr>
         <p:spPr>
           <a:xfrm>
-            <a:off x="822960" y="2651760"/>
-            <a:ext cx="5303520" cy="658368"/>
+            <a:off x="822960" y="2496312"/>
+            <a:ext cx="5303520" cy="530352"/>
           </a:xfrm>
           <a:prstGeom prst="roundRect">
             <a:avLst>
-              <a:gd name="adj" fmla="val 12500"/>
+              <a:gd name="adj" fmla="val 15517"/>
             </a:avLst>
           </a:prstGeom>
           <a:solidFill>
@@ -19417,8 +19436,8 @@
         </p:nvSpPr>
         <p:spPr>
           <a:xfrm>
-            <a:off x="1024128" y="2651760"/>
-            <a:ext cx="2377440" cy="658368"/>
+            <a:off x="1024128" y="2496312"/>
+            <a:ext cx="2377440" cy="530352"/>
           </a:xfrm>
           <a:prstGeom prst="rect">
             <a:avLst/>
@@ -19456,7 +19475,7 @@
         </p:nvSpPr>
         <p:spPr>
           <a:xfrm>
-            <a:off x="3218688" y="2889504"/>
+            <a:off x="3218688" y="2670048"/>
             <a:ext cx="365760" cy="201168"/>
           </a:xfrm>
           <a:prstGeom prst="rightArrow">
@@ -19476,8 +19495,8 @@
         </p:nvSpPr>
         <p:spPr>
           <a:xfrm>
-            <a:off x="3675888" y="2651760"/>
-            <a:ext cx="2377440" cy="658368"/>
+            <a:off x="3675888" y="2496312"/>
+            <a:ext cx="2377440" cy="530352"/>
           </a:xfrm>
           <a:prstGeom prst="rect">
             <a:avLst/>
@@ -19515,8 +19534,8 @@
         </p:nvSpPr>
         <p:spPr>
           <a:xfrm>
-            <a:off x="822960" y="3127248"/>
-            <a:ext cx="5486400" cy="292608"/>
+            <a:off x="822960" y="3163824"/>
+            <a:ext cx="5486400" cy="274320"/>
           </a:xfrm>
           <a:prstGeom prst="rect">
             <a:avLst/>

</xml_diff>

<commit_message>
Use the article's original figures; verify comparison-trial numbers
Replaced the two reconstructed curves with the original figures from the
paper: Figure 1A (eGFR change over time, with the No. at risk row) on the
primary-result slide, and Figure 3 Panel A (composite kidney-CV cumulative
incidence) on the secondary-outcomes slide, both cited. The FIDELIO,
FIGARO and FIDELITY comparison figures were checked against their
publications and match the deck.

Co-Authored-By: Claude Opus 4.8 <noreply@anthropic.com>
Claude-Session: https://claude.ai/code/session_016WM8gpgPPTpUY1fDjELfFT
</commit_message>
<xml_diff>
--- a/FIND-CKD.pptx
+++ b/FIND-CKD.pptx
@@ -137,577 +137,6 @@
 </file>
 
 <file path=ppt/charts/chart1.xml><?xml version="1.0" encoding="utf-8"?>
-<c:chartSpace xmlns:c="http://schemas.openxmlformats.org/drawingml/2006/chart" xmlns:a="http://schemas.openxmlformats.org/drawingml/2006/main" xmlns:r="http://schemas.openxmlformats.org/officeDocument/2006/relationships">
-  <c:date1904 val="0"/>
-  <c:roundedCorners val="1"/>
-  <c:chart>
-    <c:autoTitleDeleted val="1"/>
-    <c:plotArea>
-      <c:layout/>
-      <c:lineChart>
-        <c:varyColors val="0"/>
-        <c:ser>
-          <c:idx val="0"/>
-          <c:order val="0"/>
-          <c:tx>
-            <c:strRef>
-              <c:f>Sheet1!$B$1</c:f>
-              <c:strCache>
-                <c:ptCount val="1"/>
-                <c:pt idx="0">
-                  <c:v>Finerenone</c:v>
-                </c:pt>
-              </c:strCache>
-            </c:strRef>
-          </c:tx>
-          <c:spPr>
-            <a:solidFill>
-              <a:srgbClr val="12A3A6"/>
-            </a:solidFill>
-            <a:ln w="40640" cap="flat">
-              <a:solidFill>
-                <a:srgbClr val="12A3A6"/>
-              </a:solidFill>
-              <a:prstDash val="solid"/>
-              <a:round/>
-            </a:ln>
-            <a:effectLst/>
-          </c:spPr>
-          <c:invertIfNegative val="0"/>
-          <c:dLbls>
-            <c:numFmt formatCode="#,##0" sourceLinked="0"/>
-            <c:txPr>
-              <a:bodyPr/>
-              <a:lstStyle/>
-              <a:p>
-                <a:pPr>
-                  <a:defRPr b="0" i="0" strike="noStrike" sz="1200" u="none">
-                    <a:solidFill>
-                      <a:srgbClr val="000000"/>
-                    </a:solidFill>
-                    <a:latin typeface="Arial"/>
-                  </a:defRPr>
-                </a:pPr>
-              </a:p>
-            </c:txPr>
-            <c:showLegendKey val="0"/>
-            <c:showVal val="0"/>
-            <c:showCatName val="0"/>
-            <c:showSerName val="0"/>
-            <c:showPercent val="0"/>
-            <c:showBubbleSize val="0"/>
-            <c:showLeaderLines val="0"/>
-          </c:dLbls>
-          <c:marker>
-            <c:symbol val="none"/>
-            <c:size val="6"/>
-            <c:spPr>
-              <a:solidFill>
-                <a:srgbClr val="12A3A6"/>
-              </a:solidFill>
-              <a:ln w="9525" cap="flat">
-                <a:solidFill>
-                  <a:srgbClr val="12A3A6"/>
-                </a:solidFill>
-                <a:prstDash val="solid"/>
-                <a:round/>
-              </a:ln>
-              <a:effectLst/>
-            </c:spPr>
-          </c:marker>
-          <c:cat>
-            <c:multiLvlStrRef>
-              <c:f>Sheet1!$A$2:$A$14</c:f>
-              <c:multiLvlStrCache>
-                <c:ptCount val="13"/>
-                <c:lvl>
-                  <c:pt idx="0">
-                    <c:v>0</c:v>
-                  </c:pt>
-                  <c:pt idx="1">
-                    <c:v>1</c:v>
-                  </c:pt>
-                  <c:pt idx="2">
-                    <c:v>3</c:v>
-                  </c:pt>
-                  <c:pt idx="3">
-                    <c:v>6</c:v>
-                  </c:pt>
-                  <c:pt idx="4">
-                    <c:v>9</c:v>
-                  </c:pt>
-                  <c:pt idx="5">
-                    <c:v>12</c:v>
-                  </c:pt>
-                  <c:pt idx="6">
-                    <c:v>16</c:v>
-                  </c:pt>
-                  <c:pt idx="7">
-                    <c:v>20</c:v>
-                  </c:pt>
-                  <c:pt idx="8">
-                    <c:v>24</c:v>
-                  </c:pt>
-                  <c:pt idx="9">
-                    <c:v>28</c:v>
-                  </c:pt>
-                  <c:pt idx="10">
-                    <c:v>32</c:v>
-                  </c:pt>
-                  <c:pt idx="11">
-                    <c:v>EOT</c:v>
-                  </c:pt>
-                  <c:pt idx="12">
-                    <c:v>+4wk</c:v>
-                  </c:pt>
-                </c:lvl>
-              </c:multiLvlStrCache>
-            </c:multiLvlStrRef>
-          </c:cat>
-          <c:val>
-            <c:numRef>
-              <c:f>Sheet1!$B$2:$B$14</c:f>
-              <c:numCache>
-                <c:formatCode>General</c:formatCode>
-                <c:ptCount val="13"/>
-                <c:pt idx="0">
-                  <c:v>0</c:v>
-                </c:pt>
-                <c:pt idx="1">
-                  <c:v>-1.2</c:v>
-                </c:pt>
-                <c:pt idx="2">
-                  <c:v>-2</c:v>
-                </c:pt>
-                <c:pt idx="3">
-                  <c:v>-2.6</c:v>
-                </c:pt>
-                <c:pt idx="4">
-                  <c:v>-3.2</c:v>
-                </c:pt>
-                <c:pt idx="5">
-                  <c:v>-3.9</c:v>
-                </c:pt>
-                <c:pt idx="6">
-                  <c:v>-4.8</c:v>
-                </c:pt>
-                <c:pt idx="7">
-                  <c:v>-5.6</c:v>
-                </c:pt>
-                <c:pt idx="8">
-                  <c:v>-6.3</c:v>
-                </c:pt>
-                <c:pt idx="9">
-                  <c:v>-6.9</c:v>
-                </c:pt>
-                <c:pt idx="10">
-                  <c:v>-7.4</c:v>
-                </c:pt>
-                <c:pt idx="11">
-                  <c:v>-9.6</c:v>
-                </c:pt>
-                <c:pt idx="12">
-                  <c:v>-8.8</c:v>
-                </c:pt>
-              </c:numCache>
-            </c:numRef>
-          </c:val>
-          <c:smooth val="1"/>
-        </c:ser>
-        <c:ser>
-          <c:idx val="1"/>
-          <c:order val="1"/>
-          <c:tx>
-            <c:strRef>
-              <c:f>Sheet1!$C$1</c:f>
-              <c:strCache>
-                <c:ptCount val="1"/>
-                <c:pt idx="0">
-                  <c:v>Placebo</c:v>
-                </c:pt>
-              </c:strCache>
-            </c:strRef>
-          </c:tx>
-          <c:spPr>
-            <a:solidFill>
-              <a:srgbClr val="9AA7AD"/>
-            </a:solidFill>
-            <a:ln w="40640" cap="flat">
-              <a:solidFill>
-                <a:srgbClr val="9AA7AD"/>
-              </a:solidFill>
-              <a:prstDash val="solid"/>
-              <a:round/>
-            </a:ln>
-            <a:effectLst/>
-          </c:spPr>
-          <c:invertIfNegative val="0"/>
-          <c:dLbls>
-            <c:numFmt formatCode="#,##0" sourceLinked="0"/>
-            <c:txPr>
-              <a:bodyPr/>
-              <a:lstStyle/>
-              <a:p>
-                <a:pPr>
-                  <a:defRPr b="0" i="0" strike="noStrike" sz="1200" u="none">
-                    <a:solidFill>
-                      <a:srgbClr val="000000"/>
-                    </a:solidFill>
-                    <a:latin typeface="Arial"/>
-                  </a:defRPr>
-                </a:pPr>
-              </a:p>
-            </c:txPr>
-            <c:showLegendKey val="0"/>
-            <c:showVal val="0"/>
-            <c:showCatName val="0"/>
-            <c:showSerName val="0"/>
-            <c:showPercent val="0"/>
-            <c:showBubbleSize val="0"/>
-            <c:showLeaderLines val="0"/>
-          </c:dLbls>
-          <c:marker>
-            <c:symbol val="none"/>
-            <c:size val="6"/>
-            <c:spPr>
-              <a:solidFill>
-                <a:srgbClr val="9AA7AD"/>
-              </a:solidFill>
-              <a:ln w="9525" cap="flat">
-                <a:solidFill>
-                  <a:srgbClr val="9AA7AD"/>
-                </a:solidFill>
-                <a:prstDash val="solid"/>
-                <a:round/>
-              </a:ln>
-              <a:effectLst/>
-            </c:spPr>
-          </c:marker>
-          <c:cat>
-            <c:multiLvlStrRef>
-              <c:f>Sheet1!$A$2:$A$14</c:f>
-              <c:multiLvlStrCache>
-                <c:ptCount val="13"/>
-                <c:lvl>
-                  <c:pt idx="0">
-                    <c:v>0</c:v>
-                  </c:pt>
-                  <c:pt idx="1">
-                    <c:v>1</c:v>
-                  </c:pt>
-                  <c:pt idx="2">
-                    <c:v>3</c:v>
-                  </c:pt>
-                  <c:pt idx="3">
-                    <c:v>6</c:v>
-                  </c:pt>
-                  <c:pt idx="4">
-                    <c:v>9</c:v>
-                  </c:pt>
-                  <c:pt idx="5">
-                    <c:v>12</c:v>
-                  </c:pt>
-                  <c:pt idx="6">
-                    <c:v>16</c:v>
-                  </c:pt>
-                  <c:pt idx="7">
-                    <c:v>20</c:v>
-                  </c:pt>
-                  <c:pt idx="8">
-                    <c:v>24</c:v>
-                  </c:pt>
-                  <c:pt idx="9">
-                    <c:v>28</c:v>
-                  </c:pt>
-                  <c:pt idx="10">
-                    <c:v>32</c:v>
-                  </c:pt>
-                  <c:pt idx="11">
-                    <c:v>EOT</c:v>
-                  </c:pt>
-                  <c:pt idx="12">
-                    <c:v>+4wk</c:v>
-                  </c:pt>
-                </c:lvl>
-              </c:multiLvlStrCache>
-            </c:multiLvlStrRef>
-          </c:cat>
-          <c:val>
-            <c:numRef>
-              <c:f>Sheet1!$C$2:$C$14</c:f>
-              <c:numCache>
-                <c:formatCode>General</c:formatCode>
-                <c:ptCount val="13"/>
-                <c:pt idx="0">
-                  <c:v>0</c:v>
-                </c:pt>
-                <c:pt idx="1">
-                  <c:v>-0.4</c:v>
-                </c:pt>
-                <c:pt idx="2">
-                  <c:v>-0.8</c:v>
-                </c:pt>
-                <c:pt idx="3">
-                  <c:v>-1.8</c:v>
-                </c:pt>
-                <c:pt idx="4">
-                  <c:v>-2.7</c:v>
-                </c:pt>
-                <c:pt idx="5">
-                  <c:v>-3.6</c:v>
-                </c:pt>
-                <c:pt idx="6">
-                  <c:v>-4.8</c:v>
-                </c:pt>
-                <c:pt idx="7">
-                  <c:v>-5.7</c:v>
-                </c:pt>
-                <c:pt idx="8">
-                  <c:v>-6.6</c:v>
-                </c:pt>
-                <c:pt idx="9">
-                  <c:v>-7.5</c:v>
-                </c:pt>
-                <c:pt idx="10">
-                  <c:v>-8.5</c:v>
-                </c:pt>
-                <c:pt idx="11">
-                  <c:v>-10.6</c:v>
-                </c:pt>
-                <c:pt idx="12">
-                  <c:v>-11.2</c:v>
-                </c:pt>
-              </c:numCache>
-            </c:numRef>
-          </c:val>
-          <c:smooth val="1"/>
-        </c:ser>
-        <c:dLbls>
-          <c:numFmt formatCode="#,##0" sourceLinked="0"/>
-          <c:txPr>
-            <a:bodyPr/>
-            <a:lstStyle/>
-            <a:p>
-              <a:pPr>
-                <a:defRPr b="0" i="0" strike="noStrike" sz="1200" u="none">
-                  <a:solidFill>
-                    <a:srgbClr val="000000"/>
-                  </a:solidFill>
-                  <a:latin typeface="Arial"/>
-                </a:defRPr>
-              </a:pPr>
-            </a:p>
-          </c:txPr>
-          <c:showLegendKey val="0"/>
-          <c:showVal val="0"/>
-          <c:showCatName val="0"/>
-          <c:showSerName val="0"/>
-          <c:showPercent val="0"/>
-          <c:showBubbleSize val="0"/>
-          <c:showLeaderLines val="0"/>
-        </c:dLbls>
-        <c:marker val="1"/>
-        <c:axId val="2094734554"/>
-        <c:axId val="2094734552"/>
-        <c:axId val="2094734556"/>
-      </c:lineChart>
-      <c:catAx>
-        <c:axId val="2094734554"/>
-        <c:scaling>
-          <c:orientation val="minMax"/>
-        </c:scaling>
-        <c:delete val="0"/>
-        <c:axPos val="b"/>
-        <c:title>
-          <c:tx>
-            <c:rich>
-              <a:bodyPr/>
-              <a:lstStyle/>
-              <a:p>
-                <a:pPr>
-                  <a:defRPr sz="1100" b="0" i="0" u="none" strike="noStrike">
-                    <a:solidFill>
-                      <a:srgbClr val="4E5E66"/>
-                    </a:solidFill>
-                    <a:latin typeface="Arial"/>
-                  </a:defRPr>
-                </a:pPr>
-                <a:r>
-                  <a:rPr sz="1100" b="0" i="0" u="none" strike="noStrike">
-                    <a:solidFill>
-                      <a:srgbClr val="4E5E66"/>
-                    </a:solidFill>
-                    <a:latin typeface="Arial"/>
-                  </a:rPr>
-                  <a:t>Months since randomization</a:t>
-                </a:r>
-              </a:p>
-            </c:rich>
-          </c:tx>
-          <c:layout/>
-          <c:overlay val="0"/>
-        </c:title>
-        <c:numFmt formatCode="General" sourceLinked="1"/>
-        <c:majorTickMark val="out"/>
-        <c:minorTickMark val="none"/>
-        <c:tickLblPos val="low"/>
-        <c:spPr>
-          <a:ln w="12700" cap="flat">
-            <a:solidFill>
-              <a:srgbClr val="888888"/>
-            </a:solidFill>
-            <a:prstDash val="solid"/>
-            <a:round/>
-          </a:ln>
-        </c:spPr>
-        <c:txPr>
-          <a:bodyPr/>
-          <a:lstStyle/>
-          <a:p>
-            <a:pPr>
-              <a:defRPr sz="1000" b="0" i="0" u="none" strike="noStrike">
-                <a:solidFill>
-                  <a:srgbClr val="4E5E66"/>
-                </a:solidFill>
-                <a:latin typeface="Calibri"/>
-              </a:defRPr>
-            </a:pPr>
-            <a:endParaRPr lang="en-US"/>
-          </a:p>
-        </c:txPr>
-        <c:crossAx val="2094734552"/>
-        <c:crosses val="autoZero"/>
-        <c:auto val="1"/>
-        <c:lblAlgn val="ctr"/>
-        <c:noMultiLvlLbl val="1"/>
-      </c:catAx>
-      <c:valAx>
-        <c:axId val="2094734552"/>
-        <c:scaling>
-          <c:orientation val="minMax"/>
-          <c:max val="2"/>
-          <c:min val="-12"/>
-        </c:scaling>
-        <c:delete val="0"/>
-        <c:axPos val="l"/>
-        <c:majorGridlines>
-          <c:spPr>
-            <a:ln w="12700" cap="flat">
-              <a:solidFill>
-                <a:srgbClr val="ECF2F2"/>
-              </a:solidFill>
-              <a:prstDash val="solid"/>
-              <a:round/>
-            </a:ln>
-          </c:spPr>
-        </c:majorGridlines>
-        <c:title>
-          <c:tx>
-            <c:rich>
-              <a:bodyPr/>
-              <a:lstStyle/>
-              <a:p>
-                <a:pPr>
-                  <a:defRPr sz="1100" b="0" i="0" u="none" strike="noStrike">
-                    <a:solidFill>
-                      <a:srgbClr val="4E5E66"/>
-                    </a:solidFill>
-                    <a:latin typeface="Arial"/>
-                  </a:defRPr>
-                </a:pPr>
-                <a:r>
-                  <a:rPr sz="1100" b="0" i="0" u="none" strike="noStrike">
-                    <a:solidFill>
-                      <a:srgbClr val="4E5E66"/>
-                    </a:solidFill>
-                    <a:latin typeface="Arial"/>
-                  </a:rPr>
-                  <a:t>Mean change in eGFR from baseline (ml/min/1.73 m²)</a:t>
-                </a:r>
-              </a:p>
-            </c:rich>
-          </c:tx>
-          <c:layout/>
-          <c:overlay val="0"/>
-        </c:title>
-        <c:numFmt formatCode="General" sourceLinked="0"/>
-        <c:majorTickMark val="out"/>
-        <c:minorTickMark val="none"/>
-        <c:tickLblPos val="nextTo"/>
-        <c:spPr>
-          <a:ln w="12700" cap="flat">
-            <a:solidFill>
-              <a:srgbClr val="888888"/>
-            </a:solidFill>
-            <a:prstDash val="solid"/>
-            <a:round/>
-          </a:ln>
-        </c:spPr>
-        <c:txPr>
-          <a:bodyPr/>
-          <a:lstStyle/>
-          <a:p>
-            <a:pPr>
-              <a:defRPr sz="1000" b="0" i="0" u="none" strike="noStrike">
-                <a:solidFill>
-                  <a:srgbClr val="4E5E66"/>
-                </a:solidFill>
-                <a:latin typeface="Calibri"/>
-              </a:defRPr>
-            </a:pPr>
-            <a:endParaRPr lang="en-US"/>
-          </a:p>
-        </c:txPr>
-        <c:crossAx val="2094734554"/>
-        <c:crosses val="autoZero"/>
-        <c:crossBetween val="between"/>
-        <c:majorUnit val="2"/>
-      </c:valAx>
-      <c:spPr>
-        <a:noFill/>
-        <a:ln>
-          <a:noFill/>
-        </a:ln>
-        <a:effectLst/>
-      </c:spPr>
-    </c:plotArea>
-    <c:legend>
-      <c:legendPos val="t"/>
-      <c:overlay val="0"/>
-      <c:txPr>
-        <a:bodyPr/>
-        <a:lstStyle/>
-        <a:p>
-          <a:pPr>
-            <a:defRPr sz="1200">
-              <a:solidFill>
-                <a:srgbClr val="13212A"/>
-              </a:solidFill>
-              <a:latin typeface="Calibri"/>
-              <a:cs typeface="Calibri"/>
-            </a:defRPr>
-          </a:pPr>
-          <a:endParaRPr lang="en-US"/>
-        </a:p>
-      </c:txPr>
-    </c:legend>
-    <c:plotVisOnly val="1"/>
-    <c:dispBlanksAs val="span"/>
-  </c:chart>
-  <c:spPr>
-    <a:noFill/>
-    <a:ln>
-      <a:noFill/>
-    </a:ln>
-    <a:effectLst/>
-  </c:spPr>
-  <c:externalData r:id="rId1">
-    <c:autoUpdate val="0"/>
-  </c:externalData>
-</c:chartSpace>
-</file>
-
-<file path=ppt/charts/chart2.xml><?xml version="1.0" encoding="utf-8"?>
 <c:chartSpace xmlns:c="http://schemas.openxmlformats.org/drawingml/2006/chart" xmlns:a="http://schemas.openxmlformats.org/drawingml/2006/main" xmlns:r="http://schemas.openxmlformats.org/officeDocument/2006/relationships">
   <c:date1904 val="0"/>
   <c:roundedCorners val="1"/>
@@ -1088,535 +517,7 @@
 </c:chartSpace>
 </file>
 
-<file path=ppt/charts/chart3.xml><?xml version="1.0" encoding="utf-8"?>
-<c:chartSpace xmlns:c="http://schemas.openxmlformats.org/drawingml/2006/chart" xmlns:a="http://schemas.openxmlformats.org/drawingml/2006/main" xmlns:r="http://schemas.openxmlformats.org/officeDocument/2006/relationships">
-  <c:date1904 val="0"/>
-  <c:roundedCorners val="1"/>
-  <c:chart>
-    <c:title>
-      <c:tx>
-        <c:rich>
-          <a:bodyPr/>
-          <a:lstStyle/>
-          <a:p>
-            <a:pPr>
-              <a:defRPr sz="1300" b="1" i="0" u="none" strike="noStrike">
-                <a:solidFill>
-                  <a:srgbClr val="0F3446"/>
-                </a:solidFill>
-                <a:latin typeface="Calibri"/>
-              </a:defRPr>
-            </a:pPr>
-            <a:r>
-              <a:rPr sz="1300" b="1" i="0" u="none" strike="noStrike">
-                <a:solidFill>
-                  <a:srgbClr val="0F3446"/>
-                </a:solidFill>
-                <a:latin typeface="Calibri"/>
-              </a:rPr>
-              <a:t>Composite kidney–CV outcome</a:t>
-            </a:r>
-          </a:p>
-        </c:rich>
-      </c:tx>
-      <c:layout/>
-      <c:overlay val="0"/>
-    </c:title>
-    <c:autoTitleDeleted val="0"/>
-    <c:plotArea>
-      <c:layout/>
-      <c:lineChart>
-        <c:varyColors val="0"/>
-        <c:ser>
-          <c:idx val="0"/>
-          <c:order val="0"/>
-          <c:tx>
-            <c:strRef>
-              <c:f>Sheet1!$B$1</c:f>
-              <c:strCache>
-                <c:ptCount val="1"/>
-                <c:pt idx="0">
-                  <c:v>Finerenone</c:v>
-                </c:pt>
-              </c:strCache>
-            </c:strRef>
-          </c:tx>
-          <c:spPr>
-            <a:solidFill>
-              <a:srgbClr val="12A3A6"/>
-            </a:solidFill>
-            <a:ln w="38100" cap="flat">
-              <a:solidFill>
-                <a:srgbClr val="12A3A6"/>
-              </a:solidFill>
-              <a:prstDash val="solid"/>
-              <a:round/>
-            </a:ln>
-            <a:effectLst/>
-          </c:spPr>
-          <c:invertIfNegative val="0"/>
-          <c:dLbls>
-            <c:numFmt formatCode="#,##0" sourceLinked="0"/>
-            <c:txPr>
-              <a:bodyPr/>
-              <a:lstStyle/>
-              <a:p>
-                <a:pPr>
-                  <a:defRPr b="0" i="0" strike="noStrike" sz="1200" u="none">
-                    <a:solidFill>
-                      <a:srgbClr val="000000"/>
-                    </a:solidFill>
-                    <a:latin typeface="Arial"/>
-                  </a:defRPr>
-                </a:pPr>
-              </a:p>
-            </c:txPr>
-            <c:showLegendKey val="0"/>
-            <c:showVal val="0"/>
-            <c:showCatName val="0"/>
-            <c:showSerName val="0"/>
-            <c:showPercent val="0"/>
-            <c:showBubbleSize val="0"/>
-            <c:showLeaderLines val="0"/>
-          </c:dLbls>
-          <c:marker>
-            <c:symbol val="none"/>
-            <c:size val="6"/>
-            <c:spPr>
-              <a:solidFill>
-                <a:srgbClr val="12A3A6"/>
-              </a:solidFill>
-              <a:ln w="9525" cap="flat">
-                <a:solidFill>
-                  <a:srgbClr val="12A3A6"/>
-                </a:solidFill>
-                <a:prstDash val="solid"/>
-                <a:round/>
-              </a:ln>
-              <a:effectLst/>
-            </c:spPr>
-          </c:marker>
-          <c:cat>
-            <c:multiLvlStrRef>
-              <c:f>Sheet1!$A$2:$A$8</c:f>
-              <c:multiLvlStrCache>
-                <c:ptCount val="7"/>
-                <c:lvl>
-                  <c:pt idx="0">
-                    <c:v>0</c:v>
-                  </c:pt>
-                  <c:pt idx="1">
-                    <c:v>6</c:v>
-                  </c:pt>
-                  <c:pt idx="2">
-                    <c:v>12</c:v>
-                  </c:pt>
-                  <c:pt idx="3">
-                    <c:v>20</c:v>
-                  </c:pt>
-                  <c:pt idx="4">
-                    <c:v>28</c:v>
-                  </c:pt>
-                  <c:pt idx="5">
-                    <c:v>36</c:v>
-                  </c:pt>
-                  <c:pt idx="6">
-                    <c:v>44</c:v>
-                  </c:pt>
-                </c:lvl>
-              </c:multiLvlStrCache>
-            </c:multiLvlStrRef>
-          </c:cat>
-          <c:val>
-            <c:numRef>
-              <c:f>Sheet1!$B$2:$B$8</c:f>
-              <c:numCache>
-                <c:formatCode>General</c:formatCode>
-                <c:ptCount val="7"/>
-                <c:pt idx="0">
-                  <c:v>0</c:v>
-                </c:pt>
-                <c:pt idx="1">
-                  <c:v>2</c:v>
-                </c:pt>
-                <c:pt idx="2">
-                  <c:v>4.2</c:v>
-                </c:pt>
-                <c:pt idx="3">
-                  <c:v>6.8</c:v>
-                </c:pt>
-                <c:pt idx="4">
-                  <c:v>9.5</c:v>
-                </c:pt>
-                <c:pt idx="5">
-                  <c:v>12.3</c:v>
-                </c:pt>
-                <c:pt idx="6">
-                  <c:v>13.9</c:v>
-                </c:pt>
-              </c:numCache>
-            </c:numRef>
-          </c:val>
-          <c:smooth val="1"/>
-        </c:ser>
-        <c:ser>
-          <c:idx val="1"/>
-          <c:order val="1"/>
-          <c:tx>
-            <c:strRef>
-              <c:f>Sheet1!$C$1</c:f>
-              <c:strCache>
-                <c:ptCount val="1"/>
-                <c:pt idx="0">
-                  <c:v>Placebo</c:v>
-                </c:pt>
-              </c:strCache>
-            </c:strRef>
-          </c:tx>
-          <c:spPr>
-            <a:solidFill>
-              <a:srgbClr val="9AA7AD"/>
-            </a:solidFill>
-            <a:ln w="38100" cap="flat">
-              <a:solidFill>
-                <a:srgbClr val="9AA7AD"/>
-              </a:solidFill>
-              <a:prstDash val="solid"/>
-              <a:round/>
-            </a:ln>
-            <a:effectLst/>
-          </c:spPr>
-          <c:invertIfNegative val="0"/>
-          <c:dLbls>
-            <c:numFmt formatCode="#,##0" sourceLinked="0"/>
-            <c:txPr>
-              <a:bodyPr/>
-              <a:lstStyle/>
-              <a:p>
-                <a:pPr>
-                  <a:defRPr b="0" i="0" strike="noStrike" sz="1200" u="none">
-                    <a:solidFill>
-                      <a:srgbClr val="000000"/>
-                    </a:solidFill>
-                    <a:latin typeface="Arial"/>
-                  </a:defRPr>
-                </a:pPr>
-              </a:p>
-            </c:txPr>
-            <c:showLegendKey val="0"/>
-            <c:showVal val="0"/>
-            <c:showCatName val="0"/>
-            <c:showSerName val="0"/>
-            <c:showPercent val="0"/>
-            <c:showBubbleSize val="0"/>
-            <c:showLeaderLines val="0"/>
-          </c:dLbls>
-          <c:marker>
-            <c:symbol val="none"/>
-            <c:size val="6"/>
-            <c:spPr>
-              <a:solidFill>
-                <a:srgbClr val="9AA7AD"/>
-              </a:solidFill>
-              <a:ln w="9525" cap="flat">
-                <a:solidFill>
-                  <a:srgbClr val="9AA7AD"/>
-                </a:solidFill>
-                <a:prstDash val="solid"/>
-                <a:round/>
-              </a:ln>
-              <a:effectLst/>
-            </c:spPr>
-          </c:marker>
-          <c:cat>
-            <c:multiLvlStrRef>
-              <c:f>Sheet1!$A$2:$A$8</c:f>
-              <c:multiLvlStrCache>
-                <c:ptCount val="7"/>
-                <c:lvl>
-                  <c:pt idx="0">
-                    <c:v>0</c:v>
-                  </c:pt>
-                  <c:pt idx="1">
-                    <c:v>6</c:v>
-                  </c:pt>
-                  <c:pt idx="2">
-                    <c:v>12</c:v>
-                  </c:pt>
-                  <c:pt idx="3">
-                    <c:v>20</c:v>
-                  </c:pt>
-                  <c:pt idx="4">
-                    <c:v>28</c:v>
-                  </c:pt>
-                  <c:pt idx="5">
-                    <c:v>36</c:v>
-                  </c:pt>
-                  <c:pt idx="6">
-                    <c:v>44</c:v>
-                  </c:pt>
-                </c:lvl>
-              </c:multiLvlStrCache>
-            </c:multiLvlStrRef>
-          </c:cat>
-          <c:val>
-            <c:numRef>
-              <c:f>Sheet1!$C$2:$C$8</c:f>
-              <c:numCache>
-                <c:formatCode>General</c:formatCode>
-                <c:ptCount val="7"/>
-                <c:pt idx="0">
-                  <c:v>0</c:v>
-                </c:pt>
-                <c:pt idx="1">
-                  <c:v>2.5</c:v>
-                </c:pt>
-                <c:pt idx="2">
-                  <c:v>5.2</c:v>
-                </c:pt>
-                <c:pt idx="3">
-                  <c:v>8.5</c:v>
-                </c:pt>
-                <c:pt idx="4">
-                  <c:v>11.8</c:v>
-                </c:pt>
-                <c:pt idx="5">
-                  <c:v>15</c:v>
-                </c:pt>
-                <c:pt idx="6">
-                  <c:v>16.9</c:v>
-                </c:pt>
-              </c:numCache>
-            </c:numRef>
-          </c:val>
-          <c:smooth val="1"/>
-        </c:ser>
-        <c:dLbls>
-          <c:numFmt formatCode="#,##0" sourceLinked="0"/>
-          <c:txPr>
-            <a:bodyPr/>
-            <a:lstStyle/>
-            <a:p>
-              <a:pPr>
-                <a:defRPr b="0" i="0" strike="noStrike" sz="1200" u="none">
-                  <a:solidFill>
-                    <a:srgbClr val="000000"/>
-                  </a:solidFill>
-                  <a:latin typeface="Arial"/>
-                </a:defRPr>
-              </a:pPr>
-            </a:p>
-          </c:txPr>
-          <c:showLegendKey val="0"/>
-          <c:showVal val="0"/>
-          <c:showCatName val="0"/>
-          <c:showSerName val="0"/>
-          <c:showPercent val="0"/>
-          <c:showBubbleSize val="0"/>
-          <c:showLeaderLines val="0"/>
-        </c:dLbls>
-        <c:marker val="1"/>
-        <c:axId val="2094734554"/>
-        <c:axId val="2094734552"/>
-        <c:axId val="2094734556"/>
-      </c:lineChart>
-      <c:catAx>
-        <c:axId val="2094734554"/>
-        <c:scaling>
-          <c:orientation val="minMax"/>
-        </c:scaling>
-        <c:delete val="0"/>
-        <c:axPos val="b"/>
-        <c:title>
-          <c:tx>
-            <c:rich>
-              <a:bodyPr/>
-              <a:lstStyle/>
-              <a:p>
-                <a:pPr>
-                  <a:defRPr sz="1050" b="0" i="0" u="none" strike="noStrike">
-                    <a:solidFill>
-                      <a:srgbClr val="4E5E66"/>
-                    </a:solidFill>
-                    <a:latin typeface="Arial"/>
-                  </a:defRPr>
-                </a:pPr>
-                <a:r>
-                  <a:rPr sz="1050" b="0" i="0" u="none" strike="noStrike">
-                    <a:solidFill>
-                      <a:srgbClr val="4E5E66"/>
-                    </a:solidFill>
-                    <a:latin typeface="Arial"/>
-                  </a:rPr>
-                  <a:t>Months since randomization</a:t>
-                </a:r>
-              </a:p>
-            </c:rich>
-          </c:tx>
-          <c:layout/>
-          <c:overlay val="0"/>
-        </c:title>
-        <c:numFmt formatCode="General" sourceLinked="1"/>
-        <c:majorTickMark val="out"/>
-        <c:minorTickMark val="none"/>
-        <c:tickLblPos val="low"/>
-        <c:spPr>
-          <a:ln w="12700" cap="flat">
-            <a:solidFill>
-              <a:srgbClr val="888888"/>
-            </a:solidFill>
-            <a:prstDash val="solid"/>
-            <a:round/>
-          </a:ln>
-        </c:spPr>
-        <c:txPr>
-          <a:bodyPr/>
-          <a:lstStyle/>
-          <a:p>
-            <a:pPr>
-              <a:defRPr sz="1000" b="0" i="0" u="none" strike="noStrike">
-                <a:solidFill>
-                  <a:srgbClr val="4E5E66"/>
-                </a:solidFill>
-                <a:latin typeface="Calibri"/>
-              </a:defRPr>
-            </a:pPr>
-            <a:endParaRPr lang="en-US"/>
-          </a:p>
-        </c:txPr>
-        <c:crossAx val="2094734552"/>
-        <c:crosses val="autoZero"/>
-        <c:auto val="1"/>
-        <c:lblAlgn val="ctr"/>
-        <c:noMultiLvlLbl val="1"/>
-      </c:catAx>
-      <c:valAx>
-        <c:axId val="2094734552"/>
-        <c:scaling>
-          <c:orientation val="minMax"/>
-          <c:max val="20"/>
-          <c:min val="0"/>
-        </c:scaling>
-        <c:delete val="0"/>
-        <c:axPos val="l"/>
-        <c:majorGridlines>
-          <c:spPr>
-            <a:ln w="12700" cap="flat">
-              <a:solidFill>
-                <a:srgbClr val="ECF2F2"/>
-              </a:solidFill>
-              <a:prstDash val="solid"/>
-              <a:round/>
-            </a:ln>
-          </c:spPr>
-        </c:majorGridlines>
-        <c:title>
-          <c:tx>
-            <c:rich>
-              <a:bodyPr/>
-              <a:lstStyle/>
-              <a:p>
-                <a:pPr>
-                  <a:defRPr sz="1050" b="0" i="0" u="none" strike="noStrike">
-                    <a:solidFill>
-                      <a:srgbClr val="4E5E66"/>
-                    </a:solidFill>
-                    <a:latin typeface="Arial"/>
-                  </a:defRPr>
-                </a:pPr>
-                <a:r>
-                  <a:rPr sz="1050" b="0" i="0" u="none" strike="noStrike">
-                    <a:solidFill>
-                      <a:srgbClr val="4E5E66"/>
-                    </a:solidFill>
-                    <a:latin typeface="Arial"/>
-                  </a:rPr>
-                  <a:t>Cumulative incidence (%)</a:t>
-                </a:r>
-              </a:p>
-            </c:rich>
-          </c:tx>
-          <c:layout/>
-          <c:overlay val="0"/>
-        </c:title>
-        <c:numFmt formatCode="General" sourceLinked="0"/>
-        <c:majorTickMark val="out"/>
-        <c:minorTickMark val="none"/>
-        <c:tickLblPos val="nextTo"/>
-        <c:spPr>
-          <a:ln w="12700" cap="flat">
-            <a:solidFill>
-              <a:srgbClr val="888888"/>
-            </a:solidFill>
-            <a:prstDash val="solid"/>
-            <a:round/>
-          </a:ln>
-        </c:spPr>
-        <c:txPr>
-          <a:bodyPr/>
-          <a:lstStyle/>
-          <a:p>
-            <a:pPr>
-              <a:defRPr sz="1000" b="0" i="0" u="none" strike="noStrike">
-                <a:solidFill>
-                  <a:srgbClr val="4E5E66"/>
-                </a:solidFill>
-                <a:latin typeface="Calibri"/>
-              </a:defRPr>
-            </a:pPr>
-            <a:endParaRPr lang="en-US"/>
-          </a:p>
-        </c:txPr>
-        <c:crossAx val="2094734554"/>
-        <c:crosses val="autoZero"/>
-        <c:crossBetween val="between"/>
-        <c:majorUnit val="5"/>
-      </c:valAx>
-      <c:spPr>
-        <a:noFill/>
-        <a:ln>
-          <a:noFill/>
-        </a:ln>
-        <a:effectLst/>
-      </c:spPr>
-    </c:plotArea>
-    <c:legend>
-      <c:legendPos val="t"/>
-      <c:overlay val="0"/>
-      <c:txPr>
-        <a:bodyPr/>
-        <a:lstStyle/>
-        <a:p>
-          <a:pPr>
-            <a:defRPr sz="1150">
-              <a:solidFill>
-                <a:srgbClr val="13212A"/>
-              </a:solidFill>
-              <a:latin typeface="Calibri"/>
-              <a:cs typeface="Calibri"/>
-            </a:defRPr>
-          </a:pPr>
-          <a:endParaRPr lang="en-US"/>
-        </a:p>
-      </c:txPr>
-    </c:legend>
-    <c:plotVisOnly val="1"/>
-    <c:dispBlanksAs val="span"/>
-  </c:chart>
-  <c:spPr>
-    <a:noFill/>
-    <a:ln>
-      <a:noFill/>
-    </a:ln>
-    <a:effectLst/>
-  </c:spPr>
-  <c:externalData r:id="rId1">
-    <c:autoUpdate val="0"/>
-  </c:externalData>
-</c:chartSpace>
-</file>
-
-<file path=ppt/charts/chart4.xml><?xml version="1.0" encoding="utf-8"?>
+<file path=ppt/charts/chart2.xml><?xml version="1.0" encoding="utf-8"?>
 <c:chartSpace xmlns:c="http://schemas.openxmlformats.org/drawingml/2006/chart" xmlns:a="http://schemas.openxmlformats.org/drawingml/2006/main" xmlns:r="http://schemas.openxmlformats.org/officeDocument/2006/relationships">
   <c:date1904 val="0"/>
   <c:roundedCorners val="1"/>
@@ -10817,202 +9718,33 @@
           </a:p>
         </p:txBody>
       </p:sp>
-      <p:graphicFrame>
-        <p:nvGraphicFramePr>
-          <p:cNvPr id="7" name="Chart 0" descr=""/>
-          <p:cNvGraphicFramePr/>
-          <p:nvPr/>
-        </p:nvGraphicFramePr>
-        <p:xfrm>
-          <a:off x="640080" y="1554480"/>
-          <a:ext cx="7680960" cy="4434840"/>
-        </p:xfrm>
-        <a:graphic xmlns:a="http://schemas.openxmlformats.org/drawingml/2006/main">
-          <a:graphicData uri="http://schemas.openxmlformats.org/drawingml/2006/chart">
-            <c:chart xmlns:c="http://schemas.openxmlformats.org/drawingml/2006/chart" r:id="rId2"/>
-          </a:graphicData>
-        </a:graphic>
-      </p:graphicFrame>
+      <p:pic>
+        <p:nvPicPr>
+          <p:cNvPr id="7" name="Image 1" descr="fig1A.png">    </p:cNvPr>
+          <p:cNvPicPr>
+            <a:picLocks noChangeAspect="1"/>
+          </p:cNvPicPr>
+          <p:nvPr/>
+        </p:nvPicPr>
+        <p:blipFill>
+          <a:blip r:embed="rId2"/>
+          <a:stretch>
+            <a:fillRect/>
+          </a:stretch>
+        </p:blipFill>
+        <p:spPr>
+          <a:xfrm>
+            <a:off x="1435608" y="1572768"/>
+            <a:ext cx="9326880" cy="4434840"/>
+          </a:xfrm>
+          <a:prstGeom prst="rect">
+            <a:avLst/>
+          </a:prstGeom>
+        </p:spPr>
+      </p:pic>
       <p:sp>
         <p:nvSpPr>
           <p:cNvPr id="8" name="Text 4"/>
-          <p:cNvSpPr/>
-          <p:nvPr/>
-        </p:nvSpPr>
-        <p:spPr>
-          <a:xfrm>
-            <a:off x="8595360" y="1828800"/>
-            <a:ext cx="2953512" cy="1371600"/>
-          </a:xfrm>
-          <a:prstGeom prst="rect">
-            <a:avLst/>
-          </a:prstGeom>
-          <a:noFill/>
-          <a:ln/>
-        </p:spPr>
-        <p:txBody>
-          <a:bodyPr wrap="square" lIns="0" tIns="0" rIns="0" bIns="0" rtlCol="0" anchor="ctr"/>
-          <a:lstStyle/>
-          <a:p>
-            <a:pPr indent="0" marL="0">
-              <a:lnSpc>
-                <a:spcPct val="120000"/>
-              </a:lnSpc>
-              <a:buNone/>
-            </a:pPr>
-            <a:r>
-              <a:rPr lang="en-US" sz="1450" b="1" dirty="0">
-                <a:solidFill>
-                  <a:srgbClr val="E86A44"/>
-                </a:solidFill>
-                <a:latin typeface="Calibri" pitchFamily="34" charset="0"/>
-                <a:ea typeface="Calibri" pitchFamily="34" charset="-122"/>
-                <a:cs typeface="Calibri" pitchFamily="34" charset="-120"/>
-              </a:rPr>
-              <a:t>Early crossover.  </a:t>
-            </a:r>
-            <a:pPr indent="0" marL="0">
-              <a:lnSpc>
-                <a:spcPct val="120000"/>
-              </a:lnSpc>
-              <a:buNone/>
-            </a:pPr>
-            <a:r>
-              <a:rPr lang="en-US" sz="1450" dirty="0">
-                <a:solidFill>
-                  <a:srgbClr val="13212A"/>
-                </a:solidFill>
-                <a:latin typeface="Calibri" pitchFamily="34" charset="0"/>
-                <a:ea typeface="Calibri" pitchFamily="34" charset="-122"/>
-                <a:cs typeface="Calibri" pitchFamily="34" charset="-120"/>
-              </a:rPr>
-              <a:t>Finerenone dips faster through month 3 (reversible hemodynamic effect), then declines more slowly and pulls ahead.</a:t>
-            </a:r>
-            <a:endParaRPr lang="en-US" sz="1450" dirty="0"/>
-          </a:p>
-        </p:txBody>
-      </p:sp>
-      <p:sp>
-        <p:nvSpPr>
-          <p:cNvPr id="9" name="Text 5"/>
-          <p:cNvSpPr/>
-          <p:nvPr/>
-        </p:nvSpPr>
-        <p:spPr>
-          <a:xfrm>
-            <a:off x="8595360" y="3291840"/>
-            <a:ext cx="2953512" cy="822960"/>
-          </a:xfrm>
-          <a:prstGeom prst="rect">
-            <a:avLst/>
-          </a:prstGeom>
-          <a:noFill/>
-          <a:ln/>
-        </p:spPr>
-        <p:txBody>
-          <a:bodyPr wrap="square" lIns="0" tIns="0" rIns="0" bIns="0" rtlCol="0" anchor="ctr"/>
-          <a:lstStyle/>
-          <a:p>
-            <a:pPr indent="0" marL="0">
-              <a:lnSpc>
-                <a:spcPct val="120000"/>
-              </a:lnSpc>
-              <a:buNone/>
-            </a:pPr>
-            <a:r>
-              <a:rPr lang="en-US" sz="1450" b="1" dirty="0">
-                <a:solidFill>
-                  <a:srgbClr val="0E8385"/>
-                </a:solidFill>
-                <a:latin typeface="Calibri" pitchFamily="34" charset="0"/>
-                <a:ea typeface="Calibri" pitchFamily="34" charset="-122"/>
-                <a:cs typeface="Calibri" pitchFamily="34" charset="-120"/>
-              </a:rPr>
-              <a:t>At month 32.  </a:t>
-            </a:r>
-            <a:pPr indent="0" marL="0">
-              <a:lnSpc>
-                <a:spcPct val="120000"/>
-              </a:lnSpc>
-              <a:buNone/>
-            </a:pPr>
-            <a:r>
-              <a:rPr lang="en-US" sz="1450" dirty="0">
-                <a:solidFill>
-                  <a:srgbClr val="13212A"/>
-                </a:solidFill>
-                <a:latin typeface="Calibri" pitchFamily="34" charset="0"/>
-                <a:ea typeface="Calibri" pitchFamily="34" charset="-122"/>
-                <a:cs typeface="Calibri" pitchFamily="34" charset="-120"/>
-              </a:rPr>
-              <a:t>Mean eGFR 39.4 (finerenone) vs 38.1 (placebo).</a:t>
-            </a:r>
-            <a:endParaRPr lang="en-US" sz="1450" dirty="0"/>
-          </a:p>
-        </p:txBody>
-      </p:sp>
-      <p:sp>
-        <p:nvSpPr>
-          <p:cNvPr id="10" name="Text 6"/>
-          <p:cNvSpPr/>
-          <p:nvPr/>
-        </p:nvSpPr>
-        <p:spPr>
-          <a:xfrm>
-            <a:off x="8595360" y="4251960"/>
-            <a:ext cx="2953512" cy="1463040"/>
-          </a:xfrm>
-          <a:prstGeom prst="rect">
-            <a:avLst/>
-          </a:prstGeom>
-          <a:noFill/>
-          <a:ln/>
-        </p:spPr>
-        <p:txBody>
-          <a:bodyPr wrap="square" lIns="0" tIns="0" rIns="0" bIns="0" rtlCol="0" anchor="ctr"/>
-          <a:lstStyle/>
-          <a:p>
-            <a:pPr indent="0" marL="0">
-              <a:lnSpc>
-                <a:spcPct val="120000"/>
-              </a:lnSpc>
-              <a:buNone/>
-            </a:pPr>
-            <a:r>
-              <a:rPr lang="en-US" sz="1450" b="1" dirty="0">
-                <a:solidFill>
-                  <a:srgbClr val="0F3446"/>
-                </a:solidFill>
-                <a:latin typeface="Calibri" pitchFamily="34" charset="0"/>
-                <a:ea typeface="Calibri" pitchFamily="34" charset="-122"/>
-                <a:cs typeface="Calibri" pitchFamily="34" charset="-120"/>
-              </a:rPr>
-              <a:t>Off-treatment.  </a:t>
-            </a:r>
-            <a:pPr indent="0" marL="0">
-              <a:lnSpc>
-                <a:spcPct val="120000"/>
-              </a:lnSpc>
-              <a:buNone/>
-            </a:pPr>
-            <a:r>
-              <a:rPr lang="en-US" sz="1450" dirty="0">
-                <a:solidFill>
-                  <a:srgbClr val="13212A"/>
-                </a:solidFill>
-                <a:latin typeface="Calibri" pitchFamily="34" charset="0"/>
-                <a:ea typeface="Calibri" pitchFamily="34" charset="-122"/>
-                <a:cs typeface="Calibri" pitchFamily="34" charset="-120"/>
-              </a:rPr>
-              <a:t>Four weeks after stopping, eGFR rose with finerenone and kept falling with placebo. The dip reverses.</a:t>
-            </a:r>
-            <a:endParaRPr lang="en-US" sz="1450" dirty="0"/>
-          </a:p>
-        </p:txBody>
-      </p:sp>
-      <p:sp>
-        <p:nvSpPr>
-          <p:cNvPr id="11" name="Text 7"/>
           <p:cNvSpPr/>
           <p:nvPr/>
         </p:nvSpPr>
@@ -11043,7 +9775,7 @@
                 <a:ea typeface="Calibri" pitchFamily="34" charset="-122"/>
                 <a:cs typeface="Calibri" pitchFamily="34" charset="-120"/>
               </a:rPr>
-              <a:t>Adapted from Figure 1A (curve reconstructed from reported values).</a:t>
+              <a:t>Figure 1A.  Heerspink et al., N Engl J Med 2026.</a:t>
             </a:r>
             <a:endParaRPr lang="en-US" sz="850" dirty="0"/>
           </a:p>
@@ -11051,7 +9783,7 @@
       </p:sp>
       <p:sp>
         <p:nvSpPr>
-          <p:cNvPr id="12" name="Text 8"/>
+          <p:cNvPr id="9" name="Text 5"/>
           <p:cNvSpPr/>
           <p:nvPr/>
         </p:nvSpPr>
@@ -11104,7 +9836,7 @@
       </p:sp>
       <p:sp>
         <p:nvSpPr>
-          <p:cNvPr id="13" name="Text 9"/>
+          <p:cNvPr id="10" name="Text 6"/>
           <p:cNvSpPr/>
           <p:nvPr/>
         </p:nvSpPr>
@@ -15673,22 +14405,30 @@
           </a:p>
         </p:txBody>
       </p:sp>
-      <p:graphicFrame>
-        <p:nvGraphicFramePr>
-          <p:cNvPr id="7" name="Chart 0" descr=""/>
-          <p:cNvGraphicFramePr/>
-          <p:nvPr/>
-        </p:nvGraphicFramePr>
-        <p:xfrm>
-          <a:off x="640080" y="1600200"/>
-          <a:ext cx="5943600" cy="3383280"/>
-        </p:xfrm>
-        <a:graphic xmlns:a="http://schemas.openxmlformats.org/drawingml/2006/main">
-          <a:graphicData uri="http://schemas.openxmlformats.org/drawingml/2006/chart">
-            <c:chart xmlns:c="http://schemas.openxmlformats.org/drawingml/2006/chart" r:id="rId2"/>
-          </a:graphicData>
-        </a:graphic>
-      </p:graphicFrame>
+      <p:pic>
+        <p:nvPicPr>
+          <p:cNvPr id="7" name="Image 1" descr="fig3A.png">    </p:cNvPr>
+          <p:cNvPicPr>
+            <a:picLocks noChangeAspect="1"/>
+          </p:cNvPicPr>
+          <p:nvPr/>
+        </p:nvPicPr>
+        <p:blipFill>
+          <a:blip r:embed="rId2"/>
+          <a:stretch>
+            <a:fillRect/>
+          </a:stretch>
+        </p:blipFill>
+        <p:spPr>
+          <a:xfrm>
+            <a:off x="640080" y="1600200"/>
+            <a:ext cx="6126480" cy="3017520"/>
+          </a:xfrm>
+          <a:prstGeom prst="rect">
+            <a:avLst/>
+          </a:prstGeom>
+        </p:spPr>
+      </p:pic>
       <p:sp>
         <p:nvSpPr>
           <p:cNvPr id="8" name="Shape 4"/>
@@ -16500,669 +15240,6 @@
         </p:nvSpPr>
         <p:spPr>
           <a:xfrm>
-            <a:off x="640080" y="5029200"/>
-            <a:ext cx="1828800" cy="182880"/>
-          </a:xfrm>
-          <a:prstGeom prst="rect">
-            <a:avLst/>
-          </a:prstGeom>
-          <a:noFill/>
-          <a:ln/>
-        </p:spPr>
-        <p:txBody>
-          <a:bodyPr wrap="square" lIns="0" tIns="0" rIns="0" bIns="0" rtlCol="0" anchor="ctr"/>
-          <a:lstStyle/>
-          <a:p>
-            <a:pPr indent="0" marL="0">
-              <a:buNone/>
-            </a:pPr>
-            <a:r>
-              <a:rPr lang="en-US" sz="900" b="1" dirty="0">
-                <a:solidFill>
-                  <a:srgbClr val="0F3446"/>
-                </a:solidFill>
-                <a:latin typeface="Calibri" pitchFamily="34" charset="0"/>
-                <a:ea typeface="Calibri" pitchFamily="34" charset="-122"/>
-                <a:cs typeface="Calibri" pitchFamily="34" charset="-120"/>
-              </a:rPr>
-              <a:t>No. at risk</a:t>
-            </a:r>
-            <a:endParaRPr lang="en-US" sz="900" dirty="0"/>
-          </a:p>
-        </p:txBody>
-      </p:sp>
-      <p:sp>
-        <p:nvSpPr>
-          <p:cNvPr id="30" name="Text 26"/>
-          <p:cNvSpPr/>
-          <p:nvPr/>
-        </p:nvSpPr>
-        <p:spPr>
-          <a:xfrm>
-            <a:off x="640080" y="5230368"/>
-            <a:ext cx="868680" cy="182880"/>
-          </a:xfrm>
-          <a:prstGeom prst="rect">
-            <a:avLst/>
-          </a:prstGeom>
-          <a:noFill/>
-          <a:ln/>
-        </p:spPr>
-        <p:txBody>
-          <a:bodyPr wrap="square" lIns="0" tIns="0" rIns="0" bIns="0" rtlCol="0" anchor="ctr"/>
-          <a:lstStyle/>
-          <a:p>
-            <a:pPr indent="0" marL="0">
-              <a:buNone/>
-            </a:pPr>
-            <a:r>
-              <a:rPr lang="en-US" sz="850" dirty="0">
-                <a:solidFill>
-                  <a:srgbClr val="0E8385"/>
-                </a:solidFill>
-                <a:latin typeface="Calibri" pitchFamily="34" charset="0"/>
-                <a:ea typeface="Calibri" pitchFamily="34" charset="-122"/>
-                <a:cs typeface="Calibri" pitchFamily="34" charset="-120"/>
-              </a:rPr>
-              <a:t>Finerenone</a:t>
-            </a:r>
-            <a:endParaRPr lang="en-US" sz="850" dirty="0"/>
-          </a:p>
-        </p:txBody>
-      </p:sp>
-      <p:sp>
-        <p:nvSpPr>
-          <p:cNvPr id="31" name="Text 27"/>
-          <p:cNvSpPr/>
-          <p:nvPr/>
-        </p:nvSpPr>
-        <p:spPr>
-          <a:xfrm>
-            <a:off x="640080" y="5449824"/>
-            <a:ext cx="868680" cy="182880"/>
-          </a:xfrm>
-          <a:prstGeom prst="rect">
-            <a:avLst/>
-          </a:prstGeom>
-          <a:noFill/>
-          <a:ln/>
-        </p:spPr>
-        <p:txBody>
-          <a:bodyPr wrap="square" lIns="0" tIns="0" rIns="0" bIns="0" rtlCol="0" anchor="ctr"/>
-          <a:lstStyle/>
-          <a:p>
-            <a:pPr indent="0" marL="0">
-              <a:buNone/>
-            </a:pPr>
-            <a:r>
-              <a:rPr lang="en-US" sz="850" dirty="0">
-                <a:solidFill>
-                  <a:srgbClr val="4E5E66"/>
-                </a:solidFill>
-                <a:latin typeface="Calibri" pitchFamily="34" charset="0"/>
-                <a:ea typeface="Calibri" pitchFamily="34" charset="-122"/>
-                <a:cs typeface="Calibri" pitchFamily="34" charset="-120"/>
-              </a:rPr>
-              <a:t>Placebo</a:t>
-            </a:r>
-            <a:endParaRPr lang="en-US" sz="850" dirty="0"/>
-          </a:p>
-        </p:txBody>
-      </p:sp>
-      <p:sp>
-        <p:nvSpPr>
-          <p:cNvPr id="32" name="Text 28"/>
-          <p:cNvSpPr/>
-          <p:nvPr/>
-        </p:nvSpPr>
-        <p:spPr>
-          <a:xfrm>
-            <a:off x="1307592" y="5230368"/>
-            <a:ext cx="585216" cy="182880"/>
-          </a:xfrm>
-          <a:prstGeom prst="rect">
-            <a:avLst/>
-          </a:prstGeom>
-          <a:noFill/>
-          <a:ln/>
-        </p:spPr>
-        <p:txBody>
-          <a:bodyPr wrap="square" lIns="0" tIns="0" rIns="0" bIns="0" rtlCol="0" anchor="ctr"/>
-          <a:lstStyle/>
-          <a:p>
-            <a:pPr algn="ctr" indent="0" marL="0">
-              <a:buNone/>
-            </a:pPr>
-            <a:r>
-              <a:rPr lang="en-US" sz="850" dirty="0">
-                <a:solidFill>
-                  <a:srgbClr val="13212A"/>
-                </a:solidFill>
-                <a:latin typeface="Calibri" pitchFamily="34" charset="0"/>
-                <a:ea typeface="Calibri" pitchFamily="34" charset="-122"/>
-                <a:cs typeface="Calibri" pitchFamily="34" charset="-120"/>
-              </a:rPr>
-              <a:t>793</a:t>
-            </a:r>
-            <a:endParaRPr lang="en-US" sz="850" dirty="0"/>
-          </a:p>
-        </p:txBody>
-      </p:sp>
-      <p:sp>
-        <p:nvSpPr>
-          <p:cNvPr id="33" name="Text 29"/>
-          <p:cNvSpPr/>
-          <p:nvPr/>
-        </p:nvSpPr>
-        <p:spPr>
-          <a:xfrm>
-            <a:off x="1307592" y="5449824"/>
-            <a:ext cx="585216" cy="182880"/>
-          </a:xfrm>
-          <a:prstGeom prst="rect">
-            <a:avLst/>
-          </a:prstGeom>
-          <a:noFill/>
-          <a:ln/>
-        </p:spPr>
-        <p:txBody>
-          <a:bodyPr wrap="square" lIns="0" tIns="0" rIns="0" bIns="0" rtlCol="0" anchor="ctr"/>
-          <a:lstStyle/>
-          <a:p>
-            <a:pPr algn="ctr" indent="0" marL="0">
-              <a:buNone/>
-            </a:pPr>
-            <a:r>
-              <a:rPr lang="en-US" sz="850" dirty="0">
-                <a:solidFill>
-                  <a:srgbClr val="13212A"/>
-                </a:solidFill>
-                <a:latin typeface="Calibri" pitchFamily="34" charset="0"/>
-                <a:ea typeface="Calibri" pitchFamily="34" charset="-122"/>
-                <a:cs typeface="Calibri" pitchFamily="34" charset="-120"/>
-              </a:rPr>
-              <a:t>791</a:t>
-            </a:r>
-            <a:endParaRPr lang="en-US" sz="850" dirty="0"/>
-          </a:p>
-        </p:txBody>
-      </p:sp>
-      <p:sp>
-        <p:nvSpPr>
-          <p:cNvPr id="34" name="Text 30"/>
-          <p:cNvSpPr/>
-          <p:nvPr/>
-        </p:nvSpPr>
-        <p:spPr>
-          <a:xfrm>
-            <a:off x="2119884" y="5230368"/>
-            <a:ext cx="585216" cy="182880"/>
-          </a:xfrm>
-          <a:prstGeom prst="rect">
-            <a:avLst/>
-          </a:prstGeom>
-          <a:noFill/>
-          <a:ln/>
-        </p:spPr>
-        <p:txBody>
-          <a:bodyPr wrap="square" lIns="0" tIns="0" rIns="0" bIns="0" rtlCol="0" anchor="ctr"/>
-          <a:lstStyle/>
-          <a:p>
-            <a:pPr algn="ctr" indent="0" marL="0">
-              <a:buNone/>
-            </a:pPr>
-            <a:r>
-              <a:rPr lang="en-US" sz="850" dirty="0">
-                <a:solidFill>
-                  <a:srgbClr val="13212A"/>
-                </a:solidFill>
-                <a:latin typeface="Calibri" pitchFamily="34" charset="0"/>
-                <a:ea typeface="Calibri" pitchFamily="34" charset="-122"/>
-                <a:cs typeface="Calibri" pitchFamily="34" charset="-120"/>
-              </a:rPr>
-              <a:t>777</a:t>
-            </a:r>
-            <a:endParaRPr lang="en-US" sz="850" dirty="0"/>
-          </a:p>
-        </p:txBody>
-      </p:sp>
-      <p:sp>
-        <p:nvSpPr>
-          <p:cNvPr id="35" name="Text 31"/>
-          <p:cNvSpPr/>
-          <p:nvPr/>
-        </p:nvSpPr>
-        <p:spPr>
-          <a:xfrm>
-            <a:off x="2119884" y="5449824"/>
-            <a:ext cx="585216" cy="182880"/>
-          </a:xfrm>
-          <a:prstGeom prst="rect">
-            <a:avLst/>
-          </a:prstGeom>
-          <a:noFill/>
-          <a:ln/>
-        </p:spPr>
-        <p:txBody>
-          <a:bodyPr wrap="square" lIns="0" tIns="0" rIns="0" bIns="0" rtlCol="0" anchor="ctr"/>
-          <a:lstStyle/>
-          <a:p>
-            <a:pPr algn="ctr" indent="0" marL="0">
-              <a:buNone/>
-            </a:pPr>
-            <a:r>
-              <a:rPr lang="en-US" sz="850" dirty="0">
-                <a:solidFill>
-                  <a:srgbClr val="13212A"/>
-                </a:solidFill>
-                <a:latin typeface="Calibri" pitchFamily="34" charset="0"/>
-                <a:ea typeface="Calibri" pitchFamily="34" charset="-122"/>
-                <a:cs typeface="Calibri" pitchFamily="34" charset="-120"/>
-              </a:rPr>
-              <a:t>778</a:t>
-            </a:r>
-            <a:endParaRPr lang="en-US" sz="850" dirty="0"/>
-          </a:p>
-        </p:txBody>
-      </p:sp>
-      <p:sp>
-        <p:nvSpPr>
-          <p:cNvPr id="36" name="Text 32"/>
-          <p:cNvSpPr/>
-          <p:nvPr/>
-        </p:nvSpPr>
-        <p:spPr>
-          <a:xfrm>
-            <a:off x="2932176" y="5230368"/>
-            <a:ext cx="585216" cy="182880"/>
-          </a:xfrm>
-          <a:prstGeom prst="rect">
-            <a:avLst/>
-          </a:prstGeom>
-          <a:noFill/>
-          <a:ln/>
-        </p:spPr>
-        <p:txBody>
-          <a:bodyPr wrap="square" lIns="0" tIns="0" rIns="0" bIns="0" rtlCol="0" anchor="ctr"/>
-          <a:lstStyle/>
-          <a:p>
-            <a:pPr algn="ctr" indent="0" marL="0">
-              <a:buNone/>
-            </a:pPr>
-            <a:r>
-              <a:rPr lang="en-US" sz="850" dirty="0">
-                <a:solidFill>
-                  <a:srgbClr val="13212A"/>
-                </a:solidFill>
-                <a:latin typeface="Calibri" pitchFamily="34" charset="0"/>
-                <a:ea typeface="Calibri" pitchFamily="34" charset="-122"/>
-                <a:cs typeface="Calibri" pitchFamily="34" charset="-120"/>
-              </a:rPr>
-              <a:t>753</a:t>
-            </a:r>
-            <a:endParaRPr lang="en-US" sz="850" dirty="0"/>
-          </a:p>
-        </p:txBody>
-      </p:sp>
-      <p:sp>
-        <p:nvSpPr>
-          <p:cNvPr id="37" name="Text 33"/>
-          <p:cNvSpPr/>
-          <p:nvPr/>
-        </p:nvSpPr>
-        <p:spPr>
-          <a:xfrm>
-            <a:off x="2932176" y="5449824"/>
-            <a:ext cx="585216" cy="182880"/>
-          </a:xfrm>
-          <a:prstGeom prst="rect">
-            <a:avLst/>
-          </a:prstGeom>
-          <a:noFill/>
-          <a:ln/>
-        </p:spPr>
-        <p:txBody>
-          <a:bodyPr wrap="square" lIns="0" tIns="0" rIns="0" bIns="0" rtlCol="0" anchor="ctr"/>
-          <a:lstStyle/>
-          <a:p>
-            <a:pPr algn="ctr" indent="0" marL="0">
-              <a:buNone/>
-            </a:pPr>
-            <a:r>
-              <a:rPr lang="en-US" sz="850" dirty="0">
-                <a:solidFill>
-                  <a:srgbClr val="13212A"/>
-                </a:solidFill>
-                <a:latin typeface="Calibri" pitchFamily="34" charset="0"/>
-                <a:ea typeface="Calibri" pitchFamily="34" charset="-122"/>
-                <a:cs typeface="Calibri" pitchFamily="34" charset="-120"/>
-              </a:rPr>
-              <a:t>755</a:t>
-            </a:r>
-            <a:endParaRPr lang="en-US" sz="850" dirty="0"/>
-          </a:p>
-        </p:txBody>
-      </p:sp>
-      <p:sp>
-        <p:nvSpPr>
-          <p:cNvPr id="38" name="Text 34"/>
-          <p:cNvSpPr/>
-          <p:nvPr/>
-        </p:nvSpPr>
-        <p:spPr>
-          <a:xfrm>
-            <a:off x="3744468" y="5230368"/>
-            <a:ext cx="585216" cy="182880"/>
-          </a:xfrm>
-          <a:prstGeom prst="rect">
-            <a:avLst/>
-          </a:prstGeom>
-          <a:noFill/>
-          <a:ln/>
-        </p:spPr>
-        <p:txBody>
-          <a:bodyPr wrap="square" lIns="0" tIns="0" rIns="0" bIns="0" rtlCol="0" anchor="ctr"/>
-          <a:lstStyle/>
-          <a:p>
-            <a:pPr algn="ctr" indent="0" marL="0">
-              <a:buNone/>
-            </a:pPr>
-            <a:r>
-              <a:rPr lang="en-US" sz="850" dirty="0">
-                <a:solidFill>
-                  <a:srgbClr val="13212A"/>
-                </a:solidFill>
-                <a:latin typeface="Calibri" pitchFamily="34" charset="0"/>
-                <a:ea typeface="Calibri" pitchFamily="34" charset="-122"/>
-                <a:cs typeface="Calibri" pitchFamily="34" charset="-120"/>
-              </a:rPr>
-              <a:t>724</a:t>
-            </a:r>
-            <a:endParaRPr lang="en-US" sz="850" dirty="0"/>
-          </a:p>
-        </p:txBody>
-      </p:sp>
-      <p:sp>
-        <p:nvSpPr>
-          <p:cNvPr id="39" name="Text 35"/>
-          <p:cNvSpPr/>
-          <p:nvPr/>
-        </p:nvSpPr>
-        <p:spPr>
-          <a:xfrm>
-            <a:off x="3744468" y="5449824"/>
-            <a:ext cx="585216" cy="182880"/>
-          </a:xfrm>
-          <a:prstGeom prst="rect">
-            <a:avLst/>
-          </a:prstGeom>
-          <a:noFill/>
-          <a:ln/>
-        </p:spPr>
-        <p:txBody>
-          <a:bodyPr wrap="square" lIns="0" tIns="0" rIns="0" bIns="0" rtlCol="0" anchor="ctr"/>
-          <a:lstStyle/>
-          <a:p>
-            <a:pPr algn="ctr" indent="0" marL="0">
-              <a:buNone/>
-            </a:pPr>
-            <a:r>
-              <a:rPr lang="en-US" sz="850" dirty="0">
-                <a:solidFill>
-                  <a:srgbClr val="13212A"/>
-                </a:solidFill>
-                <a:latin typeface="Calibri" pitchFamily="34" charset="0"/>
-                <a:ea typeface="Calibri" pitchFamily="34" charset="-122"/>
-                <a:cs typeface="Calibri" pitchFamily="34" charset="-120"/>
-              </a:rPr>
-              <a:t>731</a:t>
-            </a:r>
-            <a:endParaRPr lang="en-US" sz="850" dirty="0"/>
-          </a:p>
-        </p:txBody>
-      </p:sp>
-      <p:sp>
-        <p:nvSpPr>
-          <p:cNvPr id="40" name="Text 36"/>
-          <p:cNvSpPr/>
-          <p:nvPr/>
-        </p:nvSpPr>
-        <p:spPr>
-          <a:xfrm>
-            <a:off x="4556760" y="5230368"/>
-            <a:ext cx="585216" cy="182880"/>
-          </a:xfrm>
-          <a:prstGeom prst="rect">
-            <a:avLst/>
-          </a:prstGeom>
-          <a:noFill/>
-          <a:ln/>
-        </p:spPr>
-        <p:txBody>
-          <a:bodyPr wrap="square" lIns="0" tIns="0" rIns="0" bIns="0" rtlCol="0" anchor="ctr"/>
-          <a:lstStyle/>
-          <a:p>
-            <a:pPr algn="ctr" indent="0" marL="0">
-              <a:buNone/>
-            </a:pPr>
-            <a:r>
-              <a:rPr lang="en-US" sz="850" dirty="0">
-                <a:solidFill>
-                  <a:srgbClr val="13212A"/>
-                </a:solidFill>
-                <a:latin typeface="Calibri" pitchFamily="34" charset="0"/>
-                <a:ea typeface="Calibri" pitchFamily="34" charset="-122"/>
-                <a:cs typeface="Calibri" pitchFamily="34" charset="-120"/>
-              </a:rPr>
-              <a:t>688</a:t>
-            </a:r>
-            <a:endParaRPr lang="en-US" sz="850" dirty="0"/>
-          </a:p>
-        </p:txBody>
-      </p:sp>
-      <p:sp>
-        <p:nvSpPr>
-          <p:cNvPr id="41" name="Text 37"/>
-          <p:cNvSpPr/>
-          <p:nvPr/>
-        </p:nvSpPr>
-        <p:spPr>
-          <a:xfrm>
-            <a:off x="4556760" y="5449824"/>
-            <a:ext cx="585216" cy="182880"/>
-          </a:xfrm>
-          <a:prstGeom prst="rect">
-            <a:avLst/>
-          </a:prstGeom>
-          <a:noFill/>
-          <a:ln/>
-        </p:spPr>
-        <p:txBody>
-          <a:bodyPr wrap="square" lIns="0" tIns="0" rIns="0" bIns="0" rtlCol="0" anchor="ctr"/>
-          <a:lstStyle/>
-          <a:p>
-            <a:pPr algn="ctr" indent="0" marL="0">
-              <a:buNone/>
-            </a:pPr>
-            <a:r>
-              <a:rPr lang="en-US" sz="850" dirty="0">
-                <a:solidFill>
-                  <a:srgbClr val="13212A"/>
-                </a:solidFill>
-                <a:latin typeface="Calibri" pitchFamily="34" charset="0"/>
-                <a:ea typeface="Calibri" pitchFamily="34" charset="-122"/>
-                <a:cs typeface="Calibri" pitchFamily="34" charset="-120"/>
-              </a:rPr>
-              <a:t>680</a:t>
-            </a:r>
-            <a:endParaRPr lang="en-US" sz="850" dirty="0"/>
-          </a:p>
-        </p:txBody>
-      </p:sp>
-      <p:sp>
-        <p:nvSpPr>
-          <p:cNvPr id="42" name="Text 38"/>
-          <p:cNvSpPr/>
-          <p:nvPr/>
-        </p:nvSpPr>
-        <p:spPr>
-          <a:xfrm>
-            <a:off x="5369052" y="5230368"/>
-            <a:ext cx="585216" cy="182880"/>
-          </a:xfrm>
-          <a:prstGeom prst="rect">
-            <a:avLst/>
-          </a:prstGeom>
-          <a:noFill/>
-          <a:ln/>
-        </p:spPr>
-        <p:txBody>
-          <a:bodyPr wrap="square" lIns="0" tIns="0" rIns="0" bIns="0" rtlCol="0" anchor="ctr"/>
-          <a:lstStyle/>
-          <a:p>
-            <a:pPr algn="ctr" indent="0" marL="0">
-              <a:buNone/>
-            </a:pPr>
-            <a:r>
-              <a:rPr lang="en-US" sz="850" dirty="0">
-                <a:solidFill>
-                  <a:srgbClr val="13212A"/>
-                </a:solidFill>
-                <a:latin typeface="Calibri" pitchFamily="34" charset="0"/>
-                <a:ea typeface="Calibri" pitchFamily="34" charset="-122"/>
-                <a:cs typeface="Calibri" pitchFamily="34" charset="-120"/>
-              </a:rPr>
-              <a:t>471</a:t>
-            </a:r>
-            <a:endParaRPr lang="en-US" sz="850" dirty="0"/>
-          </a:p>
-        </p:txBody>
-      </p:sp>
-      <p:sp>
-        <p:nvSpPr>
-          <p:cNvPr id="43" name="Text 39"/>
-          <p:cNvSpPr/>
-          <p:nvPr/>
-        </p:nvSpPr>
-        <p:spPr>
-          <a:xfrm>
-            <a:off x="5369052" y="5449824"/>
-            <a:ext cx="585216" cy="182880"/>
-          </a:xfrm>
-          <a:prstGeom prst="rect">
-            <a:avLst/>
-          </a:prstGeom>
-          <a:noFill/>
-          <a:ln/>
-        </p:spPr>
-        <p:txBody>
-          <a:bodyPr wrap="square" lIns="0" tIns="0" rIns="0" bIns="0" rtlCol="0" anchor="ctr"/>
-          <a:lstStyle/>
-          <a:p>
-            <a:pPr algn="ctr" indent="0" marL="0">
-              <a:buNone/>
-            </a:pPr>
-            <a:r>
-              <a:rPr lang="en-US" sz="850" dirty="0">
-                <a:solidFill>
-                  <a:srgbClr val="13212A"/>
-                </a:solidFill>
-                <a:latin typeface="Calibri" pitchFamily="34" charset="0"/>
-                <a:ea typeface="Calibri" pitchFamily="34" charset="-122"/>
-                <a:cs typeface="Calibri" pitchFamily="34" charset="-120"/>
-              </a:rPr>
-              <a:t>429</a:t>
-            </a:r>
-            <a:endParaRPr lang="en-US" sz="850" dirty="0"/>
-          </a:p>
-        </p:txBody>
-      </p:sp>
-      <p:sp>
-        <p:nvSpPr>
-          <p:cNvPr id="44" name="Text 40"/>
-          <p:cNvSpPr/>
-          <p:nvPr/>
-        </p:nvSpPr>
-        <p:spPr>
-          <a:xfrm>
-            <a:off x="6181344" y="5230368"/>
-            <a:ext cx="585216" cy="182880"/>
-          </a:xfrm>
-          <a:prstGeom prst="rect">
-            <a:avLst/>
-          </a:prstGeom>
-          <a:noFill/>
-          <a:ln/>
-        </p:spPr>
-        <p:txBody>
-          <a:bodyPr wrap="square" lIns="0" tIns="0" rIns="0" bIns="0" rtlCol="0" anchor="ctr"/>
-          <a:lstStyle/>
-          <a:p>
-            <a:pPr algn="ctr" indent="0" marL="0">
-              <a:buNone/>
-            </a:pPr>
-            <a:r>
-              <a:rPr lang="en-US" sz="850" dirty="0">
-                <a:solidFill>
-                  <a:srgbClr val="13212A"/>
-                </a:solidFill>
-                <a:latin typeface="Calibri" pitchFamily="34" charset="0"/>
-                <a:ea typeface="Calibri" pitchFamily="34" charset="-122"/>
-                <a:cs typeface="Calibri" pitchFamily="34" charset="-120"/>
-              </a:rPr>
-              <a:t>152</a:t>
-            </a:r>
-            <a:endParaRPr lang="en-US" sz="850" dirty="0"/>
-          </a:p>
-        </p:txBody>
-      </p:sp>
-      <p:sp>
-        <p:nvSpPr>
-          <p:cNvPr id="45" name="Text 41"/>
-          <p:cNvSpPr/>
-          <p:nvPr/>
-        </p:nvSpPr>
-        <p:spPr>
-          <a:xfrm>
-            <a:off x="6181344" y="5449824"/>
-            <a:ext cx="585216" cy="182880"/>
-          </a:xfrm>
-          <a:prstGeom prst="rect">
-            <a:avLst/>
-          </a:prstGeom>
-          <a:noFill/>
-          <a:ln/>
-        </p:spPr>
-        <p:txBody>
-          <a:bodyPr wrap="square" lIns="0" tIns="0" rIns="0" bIns="0" rtlCol="0" anchor="ctr"/>
-          <a:lstStyle/>
-          <a:p>
-            <a:pPr algn="ctr" indent="0" marL="0">
-              <a:buNone/>
-            </a:pPr>
-            <a:r>
-              <a:rPr lang="en-US" sz="850" dirty="0">
-                <a:solidFill>
-                  <a:srgbClr val="13212A"/>
-                </a:solidFill>
-                <a:latin typeface="Calibri" pitchFamily="34" charset="0"/>
-                <a:ea typeface="Calibri" pitchFamily="34" charset="-122"/>
-                <a:cs typeface="Calibri" pitchFamily="34" charset="-120"/>
-              </a:rPr>
-              <a:t>124</a:t>
-            </a:r>
-            <a:endParaRPr lang="en-US" sz="850" dirty="0"/>
-          </a:p>
-        </p:txBody>
-      </p:sp>
-      <p:sp>
-        <p:nvSpPr>
-          <p:cNvPr id="46" name="Text 42"/>
-          <p:cNvSpPr/>
-          <p:nvPr/>
-        </p:nvSpPr>
-        <p:spPr>
-          <a:xfrm>
             <a:off x="640080" y="6291072"/>
             <a:ext cx="9144000" cy="201168"/>
           </a:xfrm>
@@ -17188,7 +15265,7 @@
                 <a:ea typeface="Calibri" pitchFamily="34" charset="-122"/>
                 <a:cs typeface="Calibri" pitchFamily="34" charset="-120"/>
               </a:rPr>
-              <a:t>Adapted from Figure 3 (cumulative incidence reconstructed).</a:t>
+              <a:t>Figure 3, Panel A.  Heerspink et al., N Engl J Med 2026.</a:t>
             </a:r>
             <a:endParaRPr lang="en-US" sz="850" dirty="0"/>
           </a:p>
@@ -17196,7 +15273,7 @@
       </p:sp>
       <p:sp>
         <p:nvSpPr>
-          <p:cNvPr id="47" name="Text 43"/>
+          <p:cNvPr id="30" name="Text 26"/>
           <p:cNvSpPr/>
           <p:nvPr/>
         </p:nvSpPr>
@@ -17249,7 +15326,7 @@
       </p:sp>
       <p:sp>
         <p:nvSpPr>
-          <p:cNvPr id="48" name="Text 44"/>
+          <p:cNvPr id="31" name="Text 27"/>
           <p:cNvSpPr/>
           <p:nvPr/>
         </p:nvSpPr>

</xml_diff>

<commit_message>
Focus the comparison on FIDELITY and BARACK-D, verified against sources
Per the two source PDFs provided: reframed the finerenone-in-diabetes
comparison around the FIDELITY pooled analysis (CV 0.86, kidney 0.77;
13,026 patients) instead of listing FIDELIO and FIGARO separately, and
rebuilt the context slide as a two-population comparison (FIDELITY vs
FIND-CKD), highlighting the near-identical kidney composite (0.77 vs
0.78). Made the BARACK-D contrast precise from the source (no CV benefit,
HR 1.05; two-thirds stopped spironolactone within 6 months). All
comparison numbers now trace to the uploaded papers.

Co-Authored-By: Claude Opus 4.8 <noreply@anthropic.com>
Claude-Session: https://claude.ai/code/session_016WM8gpgPPTpUY1fDjELfFT
</commit_message>
<xml_diff>
--- a/FIND-CKD.pptx
+++ b/FIND-CKD.pptx
@@ -2913,7 +2913,7 @@
           <a:p>
             <a:r>
               <a:rPr lang="en-US" dirty="0"/>
-              <a:t>FIDELIO kidney 0.82, FIGARO CV 0.87, FIDELITY kidney 0.77. FIND-CKD, a fifth of that sample, no diabetic patient, gives the same slope 0.7 total and 1.2 chronic plus composite 0.77, in the range of RAS and SGLT2 inhibitors. The mechanistic bet paid off.</a:t>
+              <a:t>Line them up. FIDELITY, ~13,000 diabetic patients, kidney composite 0.77 and CV composite 0.86. FIND-CKD, a fifth of that sample with no diabetic patient, gives a kidney composite of 0.78, essentially identical, plus a protected kidney-CV composite of 0.77 and a slope of 0.7 (chronic 1.2). Same drug, same mechanism, extended past diabetes. The CV number in FIND-CKD rests on few events, so read it cautiously.</a:t>
             </a:r>
             <a:endParaRPr lang="en-US" dirty="0"/>
           </a:p>
@@ -3705,7 +3705,7 @@
           <a:p>
             <a:r>
               <a:rPr lang="en-US" dirty="0"/>
-              <a:t>FIDELIO the kidney trial, FIGARO the CV trial, FIDELITY pooled ~13,000 for a kidney composite 0.77. FIDELITY used the same ≥57% decline definition FIND-CKD adopts. All diabetic.</a:t>
+              <a:t>FIDELITY pooled FIDELIO and FIGARO, ~13,000 patients, for a CV composite of 0.86 and a kidney composite of 0.77, using the same ≥57% eGFR-decline definition FIND-CKD adopts. All diabetic. That is the gap FIND-CKD fills.</a:t>
             </a:r>
             <a:endParaRPr lang="en-US" dirty="0"/>
           </a:p>
@@ -18294,7 +18294,7 @@
                 <a:ea typeface="Arial" pitchFamily="34" charset="-122"/>
                 <a:cs typeface="Arial" pitchFamily="34" charset="-120"/>
               </a:rPr>
-              <a:t>FIND-CKD in context</a:t>
+              <a:t>In context: same drug, two populations</a:t>
             </a:r>
             <a:endParaRPr lang="en-US" sz="2400" dirty="0"/>
           </a:p>
@@ -18302,14 +18302,56 @@
       </p:sp>
       <p:sp>
         <p:nvSpPr>
-          <p:cNvPr id="6" name="Shape 3"/>
-          <p:cNvSpPr/>
-          <p:nvPr/>
-        </p:nvSpPr>
-        <p:spPr>
-          <a:xfrm>
-            <a:off x="640080" y="1371600"/>
-            <a:ext cx="10908792" cy="457200"/>
+          <p:cNvPr id="6" name="Text 3"/>
+          <p:cNvSpPr/>
+          <p:nvPr/>
+        </p:nvSpPr>
+        <p:spPr>
+          <a:xfrm>
+            <a:off x="640080" y="987552"/>
+            <a:ext cx="10908792" cy="420624"/>
+          </a:xfrm>
+          <a:prstGeom prst="rect">
+            <a:avLst/>
+          </a:prstGeom>
+          <a:noFill/>
+          <a:ln/>
+        </p:spPr>
+        <p:txBody>
+          <a:bodyPr wrap="square" lIns="0" tIns="0" rIns="0" bIns="0" rtlCol="0" anchor="ctr"/>
+          <a:lstStyle/>
+          <a:p>
+            <a:pPr indent="0" marL="0">
+              <a:lnSpc>
+                <a:spcPct val="105000"/>
+              </a:lnSpc>
+              <a:buNone/>
+            </a:pPr>
+            <a:r>
+              <a:rPr lang="en-US" sz="1600" b="1" dirty="0">
+                <a:solidFill>
+                  <a:srgbClr val="0E8385"/>
+                </a:solidFill>
+                <a:latin typeface="Calibri" pitchFamily="34" charset="0"/>
+                <a:ea typeface="Calibri" pitchFamily="34" charset="-122"/>
+                <a:cs typeface="Calibri" pitchFamily="34" charset="-120"/>
+              </a:rPr>
+              <a:t>The kidney composite is 0.77 in diabetic CKD and 0.78 without diabetes, essentially identical.</a:t>
+            </a:r>
+            <a:endParaRPr lang="en-US" sz="1600" dirty="0"/>
+          </a:p>
+        </p:txBody>
+      </p:sp>
+      <p:sp>
+        <p:nvSpPr>
+          <p:cNvPr id="7" name="Shape 4"/>
+          <p:cNvSpPr/>
+          <p:nvPr/>
+        </p:nvSpPr>
+        <p:spPr>
+          <a:xfrm>
+            <a:off x="640080" y="1600200"/>
+            <a:ext cx="10908792" cy="475488"/>
           </a:xfrm>
           <a:prstGeom prst="rect">
             <a:avLst/>
@@ -18322,14 +18364,14 @@
       </p:sp>
       <p:sp>
         <p:nvSpPr>
-          <p:cNvPr id="7" name="Text 4"/>
-          <p:cNvSpPr/>
-          <p:nvPr/>
-        </p:nvSpPr>
-        <p:spPr>
-          <a:xfrm>
-            <a:off x="749808" y="1371600"/>
-            <a:ext cx="2560320" cy="457200"/>
+          <p:cNvPr id="8" name="Text 5"/>
+          <p:cNvSpPr/>
+          <p:nvPr/>
+        </p:nvSpPr>
+        <p:spPr>
+          <a:xfrm>
+            <a:off x="749808" y="1600200"/>
+            <a:ext cx="2926080" cy="475488"/>
           </a:xfrm>
           <a:prstGeom prst="rect">
             <a:avLst/>
@@ -18353,14 +18395,14 @@
       </p:sp>
       <p:sp>
         <p:nvSpPr>
-          <p:cNvPr id="8" name="Text 5"/>
-          <p:cNvSpPr/>
-          <p:nvPr/>
-        </p:nvSpPr>
-        <p:spPr>
-          <a:xfrm>
-            <a:off x="3493008" y="1371600"/>
-            <a:ext cx="2011680" cy="457200"/>
+          <p:cNvPr id="9" name="Text 6"/>
+          <p:cNvSpPr/>
+          <p:nvPr/>
+        </p:nvSpPr>
+        <p:spPr>
+          <a:xfrm>
+            <a:off x="3858768" y="1600200"/>
+            <a:ext cx="3703320" cy="475488"/>
           </a:xfrm>
           <a:prstGeom prst="rect">
             <a:avLst/>
@@ -18387,7 +18429,7 @@
                 <a:ea typeface="Calibri" pitchFamily="34" charset="-122"/>
                 <a:cs typeface="Calibri" pitchFamily="34" charset="-120"/>
               </a:rPr>
-              <a:t>FIDELIO-DKD</a:t>
+              <a:t>FIDELITY — diabetic CKD</a:t>
             </a:r>
             <a:endParaRPr lang="en-US" sz="1300" dirty="0"/>
           </a:p>
@@ -18395,14 +18437,14 @@
       </p:sp>
       <p:sp>
         <p:nvSpPr>
-          <p:cNvPr id="9" name="Text 6"/>
-          <p:cNvSpPr/>
-          <p:nvPr/>
-        </p:nvSpPr>
-        <p:spPr>
-          <a:xfrm>
-            <a:off x="5687568" y="1371600"/>
-            <a:ext cx="2011680" cy="457200"/>
+          <p:cNvPr id="10" name="Text 7"/>
+          <p:cNvSpPr/>
+          <p:nvPr/>
+        </p:nvSpPr>
+        <p:spPr>
+          <a:xfrm>
+            <a:off x="7744968" y="1600200"/>
+            <a:ext cx="3730752" cy="475488"/>
           </a:xfrm>
           <a:prstGeom prst="rect">
             <a:avLst/>
@@ -18429,7 +18471,7 @@
                 <a:ea typeface="Calibri" pitchFamily="34" charset="-122"/>
                 <a:cs typeface="Calibri" pitchFamily="34" charset="-120"/>
               </a:rPr>
-              <a:t>FIGARO-DKD</a:t>
+              <a:t>FIND-CKD — no diabetes</a:t>
             </a:r>
             <a:endParaRPr lang="en-US" sz="1300" dirty="0"/>
           </a:p>
@@ -18437,97 +18479,13 @@
       </p:sp>
       <p:sp>
         <p:nvSpPr>
-          <p:cNvPr id="10" name="Text 7"/>
-          <p:cNvSpPr/>
-          <p:nvPr/>
-        </p:nvSpPr>
-        <p:spPr>
-          <a:xfrm>
-            <a:off x="7882128" y="1371600"/>
-            <a:ext cx="2011680" cy="457200"/>
-          </a:xfrm>
-          <a:prstGeom prst="rect">
-            <a:avLst/>
-          </a:prstGeom>
-          <a:noFill/>
-          <a:ln/>
-        </p:spPr>
-        <p:txBody>
-          <a:bodyPr wrap="square" lIns="0" tIns="0" rIns="0" bIns="0" rtlCol="0" anchor="ctr"/>
-          <a:lstStyle/>
-          <a:p>
-            <a:pPr algn="ctr" indent="0" marL="0">
-              <a:lnSpc>
-                <a:spcPct val="98000"/>
-              </a:lnSpc>
-              <a:buNone/>
-            </a:pPr>
-            <a:r>
-              <a:rPr lang="en-US" sz="1300" b="1" dirty="0">
-                <a:solidFill>
-                  <a:srgbClr val="FFFFFF"/>
-                </a:solidFill>
-                <a:latin typeface="Calibri" pitchFamily="34" charset="0"/>
-                <a:ea typeface="Calibri" pitchFamily="34" charset="-122"/>
-                <a:cs typeface="Calibri" pitchFamily="34" charset="-120"/>
-              </a:rPr>
-              <a:t>FIDELITY</a:t>
-            </a:r>
-            <a:endParaRPr lang="en-US" sz="1300" dirty="0"/>
-          </a:p>
-        </p:txBody>
-      </p:sp>
-      <p:sp>
-        <p:nvSpPr>
-          <p:cNvPr id="11" name="Text 8"/>
-          <p:cNvSpPr/>
-          <p:nvPr/>
-        </p:nvSpPr>
-        <p:spPr>
-          <a:xfrm>
-            <a:off x="10076688" y="1371600"/>
-            <a:ext cx="1399032" cy="457200"/>
-          </a:xfrm>
-          <a:prstGeom prst="rect">
-            <a:avLst/>
-          </a:prstGeom>
-          <a:noFill/>
-          <a:ln/>
-        </p:spPr>
-        <p:txBody>
-          <a:bodyPr wrap="square" lIns="0" tIns="0" rIns="0" bIns="0" rtlCol="0" anchor="ctr"/>
-          <a:lstStyle/>
-          <a:p>
-            <a:pPr algn="ctr" indent="0" marL="0">
-              <a:lnSpc>
-                <a:spcPct val="98000"/>
-              </a:lnSpc>
-              <a:buNone/>
-            </a:pPr>
-            <a:r>
-              <a:rPr lang="en-US" sz="1300" b="1" dirty="0">
-                <a:solidFill>
-                  <a:srgbClr val="FFFFFF"/>
-                </a:solidFill>
-                <a:latin typeface="Calibri" pitchFamily="34" charset="0"/>
-                <a:ea typeface="Calibri" pitchFamily="34" charset="-122"/>
-                <a:cs typeface="Calibri" pitchFamily="34" charset="-120"/>
-              </a:rPr>
-              <a:t>FIND-CKD</a:t>
-            </a:r>
-            <a:endParaRPr lang="en-US" sz="1300" dirty="0"/>
-          </a:p>
-        </p:txBody>
-      </p:sp>
-      <p:sp>
-        <p:nvSpPr>
-          <p:cNvPr id="12" name="Shape 9"/>
-          <p:cNvSpPr/>
-          <p:nvPr/>
-        </p:nvSpPr>
-        <p:spPr>
-          <a:xfrm>
-            <a:off x="640080" y="2377440"/>
+          <p:cNvPr id="11" name="Shape 8"/>
+          <p:cNvSpPr/>
+          <p:nvPr/>
+        </p:nvSpPr>
+        <p:spPr>
+          <a:xfrm>
+            <a:off x="640080" y="2587752"/>
             <a:ext cx="10908792" cy="0"/>
           </a:xfrm>
           <a:prstGeom prst="line">
@@ -18544,14 +18502,14 @@
       </p:sp>
       <p:sp>
         <p:nvSpPr>
-          <p:cNvPr id="13" name="Text 10"/>
-          <p:cNvSpPr/>
-          <p:nvPr/>
-        </p:nvSpPr>
-        <p:spPr>
-          <a:xfrm>
-            <a:off x="749808" y="1828800"/>
-            <a:ext cx="2560320" cy="548640"/>
+          <p:cNvPr id="12" name="Text 9"/>
+          <p:cNvSpPr/>
+          <p:nvPr/>
+        </p:nvSpPr>
+        <p:spPr>
+          <a:xfrm>
+            <a:off x="749808" y="2075688"/>
+            <a:ext cx="2926080" cy="512064"/>
           </a:xfrm>
           <a:prstGeom prst="rect">
             <a:avLst/>
@@ -18570,7 +18528,7 @@
               <a:buNone/>
             </a:pPr>
             <a:r>
-              <a:rPr lang="en-US" sz="1250" b="1" dirty="0">
+              <a:rPr lang="en-US" sz="1300" b="1" dirty="0">
                 <a:solidFill>
                   <a:srgbClr val="0F3446"/>
                 </a:solidFill>
@@ -18578,22 +18536,22 @@
                 <a:ea typeface="Calibri" pitchFamily="34" charset="-122"/>
                 <a:cs typeface="Calibri" pitchFamily="34" charset="-120"/>
               </a:rPr>
-              <a:t>Population</a:t>
-            </a:r>
-            <a:endParaRPr lang="en-US" sz="1250" dirty="0"/>
-          </a:p>
-        </p:txBody>
-      </p:sp>
-      <p:sp>
-        <p:nvSpPr>
-          <p:cNvPr id="14" name="Text 11"/>
-          <p:cNvSpPr/>
-          <p:nvPr/>
-        </p:nvSpPr>
-        <p:spPr>
-          <a:xfrm>
-            <a:off x="3493008" y="1828800"/>
-            <a:ext cx="2011680" cy="548640"/>
+              <a:t>Pooled / N</a:t>
+            </a:r>
+            <a:endParaRPr lang="en-US" sz="1300" dirty="0"/>
+          </a:p>
+        </p:txBody>
+      </p:sp>
+      <p:sp>
+        <p:nvSpPr>
+          <p:cNvPr id="13" name="Text 10"/>
+          <p:cNvSpPr/>
+          <p:nvPr/>
+        </p:nvSpPr>
+        <p:spPr>
+          <a:xfrm>
+            <a:off x="3858768" y="2075688"/>
+            <a:ext cx="3703320" cy="512064"/>
           </a:xfrm>
           <a:prstGeom prst="rect">
             <a:avLst/>
@@ -18612,7 +18570,7 @@
               <a:buNone/>
             </a:pPr>
             <a:r>
-              <a:rPr lang="en-US" sz="1250" dirty="0">
+              <a:rPr lang="en-US" sz="1300" dirty="0">
                 <a:solidFill>
                   <a:srgbClr val="13212A"/>
                 </a:solidFill>
@@ -18620,22 +18578,22 @@
                 <a:ea typeface="Calibri" pitchFamily="34" charset="-122"/>
                 <a:cs typeface="Calibri" pitchFamily="34" charset="-120"/>
               </a:rPr>
-              <a:t>T2D + CKD</a:t>
-            </a:r>
-            <a:endParaRPr lang="en-US" sz="1250" dirty="0"/>
-          </a:p>
-        </p:txBody>
-      </p:sp>
-      <p:sp>
-        <p:nvSpPr>
-          <p:cNvPr id="15" name="Text 12"/>
-          <p:cNvSpPr/>
-          <p:nvPr/>
-        </p:nvSpPr>
-        <p:spPr>
-          <a:xfrm>
-            <a:off x="5687568" y="1828800"/>
-            <a:ext cx="2011680" cy="548640"/>
+              <a:t>FIDELIO + FIGARO; 13,026</a:t>
+            </a:r>
+            <a:endParaRPr lang="en-US" sz="1300" dirty="0"/>
+          </a:p>
+        </p:txBody>
+      </p:sp>
+      <p:sp>
+        <p:nvSpPr>
+          <p:cNvPr id="14" name="Text 11"/>
+          <p:cNvSpPr/>
+          <p:nvPr/>
+        </p:nvSpPr>
+        <p:spPr>
+          <a:xfrm>
+            <a:off x="7744968" y="2075688"/>
+            <a:ext cx="3730752" cy="512064"/>
           </a:xfrm>
           <a:prstGeom prst="rect">
             <a:avLst/>
@@ -18654,91 +18612,7 @@
               <a:buNone/>
             </a:pPr>
             <a:r>
-              <a:rPr lang="en-US" sz="1250" dirty="0">
-                <a:solidFill>
-                  <a:srgbClr val="13212A"/>
-                </a:solidFill>
-                <a:latin typeface="Calibri" pitchFamily="34" charset="0"/>
-                <a:ea typeface="Calibri" pitchFamily="34" charset="-122"/>
-                <a:cs typeface="Calibri" pitchFamily="34" charset="-120"/>
-              </a:rPr>
-              <a:t>T2D + CKD (earlier)</a:t>
-            </a:r>
-            <a:endParaRPr lang="en-US" sz="1250" dirty="0"/>
-          </a:p>
-        </p:txBody>
-      </p:sp>
-      <p:sp>
-        <p:nvSpPr>
-          <p:cNvPr id="16" name="Text 13"/>
-          <p:cNvSpPr/>
-          <p:nvPr/>
-        </p:nvSpPr>
-        <p:spPr>
-          <a:xfrm>
-            <a:off x="7882128" y="1828800"/>
-            <a:ext cx="2011680" cy="548640"/>
-          </a:xfrm>
-          <a:prstGeom prst="rect">
-            <a:avLst/>
-          </a:prstGeom>
-          <a:noFill/>
-          <a:ln/>
-        </p:spPr>
-        <p:txBody>
-          <a:bodyPr wrap="square" lIns="0" tIns="0" rIns="0" bIns="0" rtlCol="0" anchor="ctr"/>
-          <a:lstStyle/>
-          <a:p>
-            <a:pPr algn="ctr" indent="0" marL="0">
-              <a:lnSpc>
-                <a:spcPct val="98000"/>
-              </a:lnSpc>
-              <a:buNone/>
-            </a:pPr>
-            <a:r>
-              <a:rPr lang="en-US" sz="1250" dirty="0">
-                <a:solidFill>
-                  <a:srgbClr val="13212A"/>
-                </a:solidFill>
-                <a:latin typeface="Calibri" pitchFamily="34" charset="0"/>
-                <a:ea typeface="Calibri" pitchFamily="34" charset="-122"/>
-                <a:cs typeface="Calibri" pitchFamily="34" charset="-120"/>
-              </a:rPr>
-              <a:t>T2D + CKD (pooled)</a:t>
-            </a:r>
-            <a:endParaRPr lang="en-US" sz="1250" dirty="0"/>
-          </a:p>
-        </p:txBody>
-      </p:sp>
-      <p:sp>
-        <p:nvSpPr>
-          <p:cNvPr id="17" name="Text 14"/>
-          <p:cNvSpPr/>
-          <p:nvPr/>
-        </p:nvSpPr>
-        <p:spPr>
-          <a:xfrm>
-            <a:off x="10076688" y="1828800"/>
-            <a:ext cx="1399032" cy="548640"/>
-          </a:xfrm>
-          <a:prstGeom prst="rect">
-            <a:avLst/>
-          </a:prstGeom>
-          <a:noFill/>
-          <a:ln/>
-        </p:spPr>
-        <p:txBody>
-          <a:bodyPr wrap="square" lIns="0" tIns="0" rIns="0" bIns="0" rtlCol="0" anchor="ctr"/>
-          <a:lstStyle/>
-          <a:p>
-            <a:pPr algn="ctr" indent="0" marL="0">
-              <a:lnSpc>
-                <a:spcPct val="98000"/>
-              </a:lnSpc>
-              <a:buNone/>
-            </a:pPr>
-            <a:r>
-              <a:rPr lang="en-US" sz="1250" b="1" dirty="0">
+              <a:rPr lang="en-US" sz="1300" b="1" dirty="0">
                 <a:solidFill>
                   <a:srgbClr val="0E8385"/>
                 </a:solidFill>
@@ -18746,21 +18620,21 @@
                 <a:ea typeface="Calibri" pitchFamily="34" charset="-122"/>
                 <a:cs typeface="Calibri" pitchFamily="34" charset="-120"/>
               </a:rPr>
-              <a:t>CKD, no diabetes</a:t>
-            </a:r>
-            <a:endParaRPr lang="en-US" sz="1250" dirty="0"/>
-          </a:p>
-        </p:txBody>
-      </p:sp>
-      <p:sp>
-        <p:nvSpPr>
-          <p:cNvPr id="18" name="Shape 15"/>
-          <p:cNvSpPr/>
-          <p:nvPr/>
-        </p:nvSpPr>
-        <p:spPr>
-          <a:xfrm>
-            <a:off x="640080" y="2926080"/>
+              <a:t>Single RCT; 1,584</a:t>
+            </a:r>
+            <a:endParaRPr lang="en-US" sz="1300" dirty="0"/>
+          </a:p>
+        </p:txBody>
+      </p:sp>
+      <p:sp>
+        <p:nvSpPr>
+          <p:cNvPr id="15" name="Shape 12"/>
+          <p:cNvSpPr/>
+          <p:nvPr/>
+        </p:nvSpPr>
+        <p:spPr>
+          <a:xfrm>
+            <a:off x="640080" y="3099816"/>
             <a:ext cx="10908792" cy="0"/>
           </a:xfrm>
           <a:prstGeom prst="line">
@@ -18777,14 +18651,14 @@
       </p:sp>
       <p:sp>
         <p:nvSpPr>
-          <p:cNvPr id="19" name="Text 16"/>
-          <p:cNvSpPr/>
-          <p:nvPr/>
-        </p:nvSpPr>
-        <p:spPr>
-          <a:xfrm>
-            <a:off x="749808" y="2377440"/>
-            <a:ext cx="2560320" cy="548640"/>
+          <p:cNvPr id="16" name="Text 13"/>
+          <p:cNvSpPr/>
+          <p:nvPr/>
+        </p:nvSpPr>
+        <p:spPr>
+          <a:xfrm>
+            <a:off x="749808" y="2587752"/>
+            <a:ext cx="2926080" cy="512064"/>
           </a:xfrm>
           <a:prstGeom prst="rect">
             <a:avLst/>
@@ -18803,7 +18677,7 @@
               <a:buNone/>
             </a:pPr>
             <a:r>
-              <a:rPr lang="en-US" sz="1250" b="1" dirty="0">
+              <a:rPr lang="en-US" sz="1300" b="1" dirty="0">
                 <a:solidFill>
                   <a:srgbClr val="0F3446"/>
                 </a:solidFill>
@@ -18811,22 +18685,22 @@
                 <a:ea typeface="Calibri" pitchFamily="34" charset="-122"/>
                 <a:cs typeface="Calibri" pitchFamily="34" charset="-120"/>
               </a:rPr>
-              <a:t>N</a:t>
-            </a:r>
-            <a:endParaRPr lang="en-US" sz="1250" dirty="0"/>
-          </a:p>
-        </p:txBody>
-      </p:sp>
-      <p:sp>
-        <p:nvSpPr>
-          <p:cNvPr id="20" name="Text 17"/>
-          <p:cNvSpPr/>
-          <p:nvPr/>
-        </p:nvSpPr>
-        <p:spPr>
-          <a:xfrm>
-            <a:off x="3493008" y="2377440"/>
-            <a:ext cx="2011680" cy="548640"/>
+              <a:t>Primary endpoint</a:t>
+            </a:r>
+            <a:endParaRPr lang="en-US" sz="1300" dirty="0"/>
+          </a:p>
+        </p:txBody>
+      </p:sp>
+      <p:sp>
+        <p:nvSpPr>
+          <p:cNvPr id="17" name="Text 14"/>
+          <p:cNvSpPr/>
+          <p:nvPr/>
+        </p:nvSpPr>
+        <p:spPr>
+          <a:xfrm>
+            <a:off x="3858768" y="2587752"/>
+            <a:ext cx="3703320" cy="512064"/>
           </a:xfrm>
           <a:prstGeom prst="rect">
             <a:avLst/>
@@ -18845,7 +18719,7 @@
               <a:buNone/>
             </a:pPr>
             <a:r>
-              <a:rPr lang="en-US" sz="1250" dirty="0">
+              <a:rPr lang="en-US" sz="1300" dirty="0">
                 <a:solidFill>
                   <a:srgbClr val="13212A"/>
                 </a:solidFill>
@@ -18853,22 +18727,22 @@
                 <a:ea typeface="Calibri" pitchFamily="34" charset="-122"/>
                 <a:cs typeface="Calibri" pitchFamily="34" charset="-120"/>
               </a:rPr>
-              <a:t>5674</a:t>
-            </a:r>
-            <a:endParaRPr lang="en-US" sz="1250" dirty="0"/>
-          </a:p>
-        </p:txBody>
-      </p:sp>
-      <p:sp>
-        <p:nvSpPr>
-          <p:cNvPr id="21" name="Text 18"/>
-          <p:cNvSpPr/>
-          <p:nvPr/>
-        </p:nvSpPr>
-        <p:spPr>
-          <a:xfrm>
-            <a:off x="5687568" y="2377440"/>
-            <a:ext cx="2011680" cy="548640"/>
+              <a:t>CV &amp; kidney composites</a:t>
+            </a:r>
+            <a:endParaRPr lang="en-US" sz="1300" dirty="0"/>
+          </a:p>
+        </p:txBody>
+      </p:sp>
+      <p:sp>
+        <p:nvSpPr>
+          <p:cNvPr id="18" name="Text 15"/>
+          <p:cNvSpPr/>
+          <p:nvPr/>
+        </p:nvSpPr>
+        <p:spPr>
+          <a:xfrm>
+            <a:off x="7744968" y="2587752"/>
+            <a:ext cx="3730752" cy="512064"/>
           </a:xfrm>
           <a:prstGeom prst="rect">
             <a:avLst/>
@@ -18887,91 +18761,7 @@
               <a:buNone/>
             </a:pPr>
             <a:r>
-              <a:rPr lang="en-US" sz="1250" dirty="0">
-                <a:solidFill>
-                  <a:srgbClr val="13212A"/>
-                </a:solidFill>
-                <a:latin typeface="Calibri" pitchFamily="34" charset="0"/>
-                <a:ea typeface="Calibri" pitchFamily="34" charset="-122"/>
-                <a:cs typeface="Calibri" pitchFamily="34" charset="-120"/>
-              </a:rPr>
-              <a:t>7437</a:t>
-            </a:r>
-            <a:endParaRPr lang="en-US" sz="1250" dirty="0"/>
-          </a:p>
-        </p:txBody>
-      </p:sp>
-      <p:sp>
-        <p:nvSpPr>
-          <p:cNvPr id="22" name="Text 19"/>
-          <p:cNvSpPr/>
-          <p:nvPr/>
-        </p:nvSpPr>
-        <p:spPr>
-          <a:xfrm>
-            <a:off x="7882128" y="2377440"/>
-            <a:ext cx="2011680" cy="548640"/>
-          </a:xfrm>
-          <a:prstGeom prst="rect">
-            <a:avLst/>
-          </a:prstGeom>
-          <a:noFill/>
-          <a:ln/>
-        </p:spPr>
-        <p:txBody>
-          <a:bodyPr wrap="square" lIns="0" tIns="0" rIns="0" bIns="0" rtlCol="0" anchor="ctr"/>
-          <a:lstStyle/>
-          <a:p>
-            <a:pPr algn="ctr" indent="0" marL="0">
-              <a:lnSpc>
-                <a:spcPct val="98000"/>
-              </a:lnSpc>
-              <a:buNone/>
-            </a:pPr>
-            <a:r>
-              <a:rPr lang="en-US" sz="1250" dirty="0">
-                <a:solidFill>
-                  <a:srgbClr val="13212A"/>
-                </a:solidFill>
-                <a:latin typeface="Calibri" pitchFamily="34" charset="0"/>
-                <a:ea typeface="Calibri" pitchFamily="34" charset="-122"/>
-                <a:cs typeface="Calibri" pitchFamily="34" charset="-120"/>
-              </a:rPr>
-              <a:t>13,026</a:t>
-            </a:r>
-            <a:endParaRPr lang="en-US" sz="1250" dirty="0"/>
-          </a:p>
-        </p:txBody>
-      </p:sp>
-      <p:sp>
-        <p:nvSpPr>
-          <p:cNvPr id="23" name="Text 20"/>
-          <p:cNvSpPr/>
-          <p:nvPr/>
-        </p:nvSpPr>
-        <p:spPr>
-          <a:xfrm>
-            <a:off x="10076688" y="2377440"/>
-            <a:ext cx="1399032" cy="548640"/>
-          </a:xfrm>
-          <a:prstGeom prst="rect">
-            <a:avLst/>
-          </a:prstGeom>
-          <a:noFill/>
-          <a:ln/>
-        </p:spPr>
-        <p:txBody>
-          <a:bodyPr wrap="square" lIns="0" tIns="0" rIns="0" bIns="0" rtlCol="0" anchor="ctr"/>
-          <a:lstStyle/>
-          <a:p>
-            <a:pPr algn="ctr" indent="0" marL="0">
-              <a:lnSpc>
-                <a:spcPct val="98000"/>
-              </a:lnSpc>
-              <a:buNone/>
-            </a:pPr>
-            <a:r>
-              <a:rPr lang="en-US" sz="1250" b="1" dirty="0">
+              <a:rPr lang="en-US" sz="1300" b="1" dirty="0">
                 <a:solidFill>
                   <a:srgbClr val="0E8385"/>
                 </a:solidFill>
@@ -18979,21 +18769,21 @@
                 <a:ea typeface="Calibri" pitchFamily="34" charset="-122"/>
                 <a:cs typeface="Calibri" pitchFamily="34" charset="-120"/>
               </a:rPr>
-              <a:t>1584</a:t>
-            </a:r>
-            <a:endParaRPr lang="en-US" sz="1250" dirty="0"/>
-          </a:p>
-        </p:txBody>
-      </p:sp>
-      <p:sp>
-        <p:nvSpPr>
-          <p:cNvPr id="24" name="Shape 21"/>
-          <p:cNvSpPr/>
-          <p:nvPr/>
-        </p:nvSpPr>
-        <p:spPr>
-          <a:xfrm>
-            <a:off x="640080" y="3474720"/>
+              <a:t>Total eGFR slope</a:t>
+            </a:r>
+            <a:endParaRPr lang="en-US" sz="1300" dirty="0"/>
+          </a:p>
+        </p:txBody>
+      </p:sp>
+      <p:sp>
+        <p:nvSpPr>
+          <p:cNvPr id="19" name="Shape 16"/>
+          <p:cNvSpPr/>
+          <p:nvPr/>
+        </p:nvSpPr>
+        <p:spPr>
+          <a:xfrm>
+            <a:off x="640080" y="3611880"/>
             <a:ext cx="10908792" cy="0"/>
           </a:xfrm>
           <a:prstGeom prst="line">
@@ -19010,14 +18800,14 @@
       </p:sp>
       <p:sp>
         <p:nvSpPr>
-          <p:cNvPr id="25" name="Text 22"/>
-          <p:cNvSpPr/>
-          <p:nvPr/>
-        </p:nvSpPr>
-        <p:spPr>
-          <a:xfrm>
-            <a:off x="749808" y="2926080"/>
-            <a:ext cx="2560320" cy="548640"/>
+          <p:cNvPr id="20" name="Text 17"/>
+          <p:cNvSpPr/>
+          <p:nvPr/>
+        </p:nvSpPr>
+        <p:spPr>
+          <a:xfrm>
+            <a:off x="749808" y="3099816"/>
+            <a:ext cx="2926080" cy="512064"/>
           </a:xfrm>
           <a:prstGeom prst="rect">
             <a:avLst/>
@@ -19036,7 +18826,7 @@
               <a:buNone/>
             </a:pPr>
             <a:r>
-              <a:rPr lang="en-US" sz="1250" b="1" dirty="0">
+              <a:rPr lang="en-US" sz="1300" b="1" dirty="0">
                 <a:solidFill>
                   <a:srgbClr val="0F3446"/>
                 </a:solidFill>
@@ -19044,22 +18834,22 @@
                 <a:ea typeface="Calibri" pitchFamily="34" charset="-122"/>
                 <a:cs typeface="Calibri" pitchFamily="34" charset="-120"/>
               </a:rPr>
-              <a:t>Primary endpoint</a:t>
-            </a:r>
-            <a:endParaRPr lang="en-US" sz="1250" dirty="0"/>
-          </a:p>
-        </p:txBody>
-      </p:sp>
-      <p:sp>
-        <p:nvSpPr>
-          <p:cNvPr id="26" name="Text 23"/>
-          <p:cNvSpPr/>
-          <p:nvPr/>
-        </p:nvSpPr>
-        <p:spPr>
-          <a:xfrm>
-            <a:off x="3493008" y="2926080"/>
-            <a:ext cx="2011680" cy="548640"/>
+              <a:t>Kidney composite (≥57%)</a:t>
+            </a:r>
+            <a:endParaRPr lang="en-US" sz="1300" dirty="0"/>
+          </a:p>
+        </p:txBody>
+      </p:sp>
+      <p:sp>
+        <p:nvSpPr>
+          <p:cNvPr id="21" name="Text 18"/>
+          <p:cNvSpPr/>
+          <p:nvPr/>
+        </p:nvSpPr>
+        <p:spPr>
+          <a:xfrm>
+            <a:off x="3858768" y="3099816"/>
+            <a:ext cx="3703320" cy="512064"/>
           </a:xfrm>
           <a:prstGeom prst="rect">
             <a:avLst/>
@@ -19078,7 +18868,7 @@
               <a:buNone/>
             </a:pPr>
             <a:r>
-              <a:rPr lang="en-US" sz="1250" dirty="0">
+              <a:rPr lang="en-US" sz="1300" dirty="0">
                 <a:solidFill>
                   <a:srgbClr val="13212A"/>
                 </a:solidFill>
@@ -19086,22 +18876,22 @@
                 <a:ea typeface="Calibri" pitchFamily="34" charset="-122"/>
                 <a:cs typeface="Calibri" pitchFamily="34" charset="-120"/>
               </a:rPr>
-              <a:t>Kidney composite</a:t>
-            </a:r>
-            <a:endParaRPr lang="en-US" sz="1250" dirty="0"/>
-          </a:p>
-        </p:txBody>
-      </p:sp>
-      <p:sp>
-        <p:nvSpPr>
-          <p:cNvPr id="27" name="Text 24"/>
-          <p:cNvSpPr/>
-          <p:nvPr/>
-        </p:nvSpPr>
-        <p:spPr>
-          <a:xfrm>
-            <a:off x="5687568" y="2926080"/>
-            <a:ext cx="2011680" cy="548640"/>
+              <a:t>0.77 (0.67–0.88)</a:t>
+            </a:r>
+            <a:endParaRPr lang="en-US" sz="1300" dirty="0"/>
+          </a:p>
+        </p:txBody>
+      </p:sp>
+      <p:sp>
+        <p:nvSpPr>
+          <p:cNvPr id="22" name="Text 19"/>
+          <p:cNvSpPr/>
+          <p:nvPr/>
+        </p:nvSpPr>
+        <p:spPr>
+          <a:xfrm>
+            <a:off x="7744968" y="3099816"/>
+            <a:ext cx="3730752" cy="512064"/>
           </a:xfrm>
           <a:prstGeom prst="rect">
             <a:avLst/>
@@ -19120,91 +18910,7 @@
               <a:buNone/>
             </a:pPr>
             <a:r>
-              <a:rPr lang="en-US" sz="1250" dirty="0">
-                <a:solidFill>
-                  <a:srgbClr val="13212A"/>
-                </a:solidFill>
-                <a:latin typeface="Calibri" pitchFamily="34" charset="0"/>
-                <a:ea typeface="Calibri" pitchFamily="34" charset="-122"/>
-                <a:cs typeface="Calibri" pitchFamily="34" charset="-120"/>
-              </a:rPr>
-              <a:t>CV composite</a:t>
-            </a:r>
-            <a:endParaRPr lang="en-US" sz="1250" dirty="0"/>
-          </a:p>
-        </p:txBody>
-      </p:sp>
-      <p:sp>
-        <p:nvSpPr>
-          <p:cNvPr id="28" name="Text 25"/>
-          <p:cNvSpPr/>
-          <p:nvPr/>
-        </p:nvSpPr>
-        <p:spPr>
-          <a:xfrm>
-            <a:off x="7882128" y="2926080"/>
-            <a:ext cx="2011680" cy="548640"/>
-          </a:xfrm>
-          <a:prstGeom prst="rect">
-            <a:avLst/>
-          </a:prstGeom>
-          <a:noFill/>
-          <a:ln/>
-        </p:spPr>
-        <p:txBody>
-          <a:bodyPr wrap="square" lIns="0" tIns="0" rIns="0" bIns="0" rtlCol="0" anchor="ctr"/>
-          <a:lstStyle/>
-          <a:p>
-            <a:pPr algn="ctr" indent="0" marL="0">
-              <a:lnSpc>
-                <a:spcPct val="98000"/>
-              </a:lnSpc>
-              <a:buNone/>
-            </a:pPr>
-            <a:r>
-              <a:rPr lang="en-US" sz="1250" dirty="0">
-                <a:solidFill>
-                  <a:srgbClr val="13212A"/>
-                </a:solidFill>
-                <a:latin typeface="Calibri" pitchFamily="34" charset="0"/>
-                <a:ea typeface="Calibri" pitchFamily="34" charset="-122"/>
-                <a:cs typeface="Calibri" pitchFamily="34" charset="-120"/>
-              </a:rPr>
-              <a:t>(pooled)</a:t>
-            </a:r>
-            <a:endParaRPr lang="en-US" sz="1250" dirty="0"/>
-          </a:p>
-        </p:txBody>
-      </p:sp>
-      <p:sp>
-        <p:nvSpPr>
-          <p:cNvPr id="29" name="Text 26"/>
-          <p:cNvSpPr/>
-          <p:nvPr/>
-        </p:nvSpPr>
-        <p:spPr>
-          <a:xfrm>
-            <a:off x="10076688" y="2926080"/>
-            <a:ext cx="1399032" cy="548640"/>
-          </a:xfrm>
-          <a:prstGeom prst="rect">
-            <a:avLst/>
-          </a:prstGeom>
-          <a:noFill/>
-          <a:ln/>
-        </p:spPr>
-        <p:txBody>
-          <a:bodyPr wrap="square" lIns="0" tIns="0" rIns="0" bIns="0" rtlCol="0" anchor="ctr"/>
-          <a:lstStyle/>
-          <a:p>
-            <a:pPr algn="ctr" indent="0" marL="0">
-              <a:lnSpc>
-                <a:spcPct val="98000"/>
-              </a:lnSpc>
-              <a:buNone/>
-            </a:pPr>
-            <a:r>
-              <a:rPr lang="en-US" sz="1250" b="1" dirty="0">
+              <a:rPr lang="en-US" sz="1300" b="1" dirty="0">
                 <a:solidFill>
                   <a:srgbClr val="0E8385"/>
                 </a:solidFill>
@@ -19212,21 +18918,21 @@
                 <a:ea typeface="Calibri" pitchFamily="34" charset="-122"/>
                 <a:cs typeface="Calibri" pitchFamily="34" charset="-120"/>
               </a:rPr>
-              <a:t>eGFR slope</a:t>
-            </a:r>
-            <a:endParaRPr lang="en-US" sz="1250" dirty="0"/>
-          </a:p>
-        </p:txBody>
-      </p:sp>
-      <p:sp>
-        <p:nvSpPr>
-          <p:cNvPr id="30" name="Shape 27"/>
-          <p:cNvSpPr/>
-          <p:nvPr/>
-        </p:nvSpPr>
-        <p:spPr>
-          <a:xfrm>
-            <a:off x="640080" y="4023360"/>
+              <a:t>0.78 (0.60–1.01)</a:t>
+            </a:r>
+            <a:endParaRPr lang="en-US" sz="1300" dirty="0"/>
+          </a:p>
+        </p:txBody>
+      </p:sp>
+      <p:sp>
+        <p:nvSpPr>
+          <p:cNvPr id="23" name="Shape 20"/>
+          <p:cNvSpPr/>
+          <p:nvPr/>
+        </p:nvSpPr>
+        <p:spPr>
+          <a:xfrm>
+            <a:off x="640080" y="4123944"/>
             <a:ext cx="10908792" cy="0"/>
           </a:xfrm>
           <a:prstGeom prst="line">
@@ -19243,14 +18949,14 @@
       </p:sp>
       <p:sp>
         <p:nvSpPr>
-          <p:cNvPr id="31" name="Text 28"/>
-          <p:cNvSpPr/>
-          <p:nvPr/>
-        </p:nvSpPr>
-        <p:spPr>
-          <a:xfrm>
-            <a:off x="749808" y="3474720"/>
-            <a:ext cx="2560320" cy="548640"/>
+          <p:cNvPr id="24" name="Text 21"/>
+          <p:cNvSpPr/>
+          <p:nvPr/>
+        </p:nvSpPr>
+        <p:spPr>
+          <a:xfrm>
+            <a:off x="749808" y="3611880"/>
+            <a:ext cx="2926080" cy="512064"/>
           </a:xfrm>
           <a:prstGeom prst="rect">
             <a:avLst/>
@@ -19269,7 +18975,7 @@
               <a:buNone/>
             </a:pPr>
             <a:r>
-              <a:rPr lang="en-US" sz="1250" b="1" dirty="0">
+              <a:rPr lang="en-US" sz="1300" b="1" dirty="0">
                 <a:solidFill>
                   <a:srgbClr val="0F3446"/>
                 </a:solidFill>
@@ -19277,22 +18983,22 @@
                 <a:ea typeface="Calibri" pitchFamily="34" charset="-122"/>
                 <a:cs typeface="Calibri" pitchFamily="34" charset="-120"/>
               </a:rPr>
-              <a:t>Key kidney result</a:t>
-            </a:r>
-            <a:endParaRPr lang="en-US" sz="1250" dirty="0"/>
-          </a:p>
-        </p:txBody>
-      </p:sp>
-      <p:sp>
-        <p:nvSpPr>
-          <p:cNvPr id="32" name="Text 29"/>
-          <p:cNvSpPr/>
-          <p:nvPr/>
-        </p:nvSpPr>
-        <p:spPr>
-          <a:xfrm>
-            <a:off x="3493008" y="3474720"/>
-            <a:ext cx="2011680" cy="548640"/>
+              <a:t>Composite kidney–CV</a:t>
+            </a:r>
+            <a:endParaRPr lang="en-US" sz="1300" dirty="0"/>
+          </a:p>
+        </p:txBody>
+      </p:sp>
+      <p:sp>
+        <p:nvSpPr>
+          <p:cNvPr id="25" name="Text 22"/>
+          <p:cNvSpPr/>
+          <p:nvPr/>
+        </p:nvSpPr>
+        <p:spPr>
+          <a:xfrm>
+            <a:off x="3858768" y="3611880"/>
+            <a:ext cx="3703320" cy="512064"/>
           </a:xfrm>
           <a:prstGeom prst="rect">
             <a:avLst/>
@@ -19311,7 +19017,7 @@
               <a:buNone/>
             </a:pPr>
             <a:r>
-              <a:rPr lang="en-US" sz="1250" dirty="0">
+              <a:rPr lang="en-US" sz="1300" dirty="0">
                 <a:solidFill>
                   <a:srgbClr val="13212A"/>
                 </a:solidFill>
@@ -19319,22 +19025,22 @@
                 <a:ea typeface="Calibri" pitchFamily="34" charset="-122"/>
                 <a:cs typeface="Calibri" pitchFamily="34" charset="-120"/>
               </a:rPr>
-              <a:t>HR 0.82</a:t>
-            </a:r>
-            <a:endParaRPr lang="en-US" sz="1250" dirty="0"/>
-          </a:p>
-        </p:txBody>
-      </p:sp>
-      <p:sp>
-        <p:nvSpPr>
-          <p:cNvPr id="33" name="Text 30"/>
-          <p:cNvSpPr/>
-          <p:nvPr/>
-        </p:nvSpPr>
-        <p:spPr>
-          <a:xfrm>
-            <a:off x="5687568" y="3474720"/>
-            <a:ext cx="2011680" cy="548640"/>
+              <a:t>not reported</a:t>
+            </a:r>
+            <a:endParaRPr lang="en-US" sz="1300" dirty="0"/>
+          </a:p>
+        </p:txBody>
+      </p:sp>
+      <p:sp>
+        <p:nvSpPr>
+          <p:cNvPr id="26" name="Text 23"/>
+          <p:cNvSpPr/>
+          <p:nvPr/>
+        </p:nvSpPr>
+        <p:spPr>
+          <a:xfrm>
+            <a:off x="7744968" y="3611880"/>
+            <a:ext cx="3730752" cy="512064"/>
           </a:xfrm>
           <a:prstGeom prst="rect">
             <a:avLst/>
@@ -19353,91 +19059,7 @@
               <a:buNone/>
             </a:pPr>
             <a:r>
-              <a:rPr lang="en-US" sz="1250" dirty="0">
-                <a:solidFill>
-                  <a:srgbClr val="13212A"/>
-                </a:solidFill>
-                <a:latin typeface="Calibri" pitchFamily="34" charset="0"/>
-                <a:ea typeface="Calibri" pitchFamily="34" charset="-122"/>
-                <a:cs typeface="Calibri" pitchFamily="34" charset="-120"/>
-              </a:rPr>
-              <a:t>HR 0.87 (CV)</a:t>
-            </a:r>
-            <a:endParaRPr lang="en-US" sz="1250" dirty="0"/>
-          </a:p>
-        </p:txBody>
-      </p:sp>
-      <p:sp>
-        <p:nvSpPr>
-          <p:cNvPr id="34" name="Text 31"/>
-          <p:cNvSpPr/>
-          <p:nvPr/>
-        </p:nvSpPr>
-        <p:spPr>
-          <a:xfrm>
-            <a:off x="7882128" y="3474720"/>
-            <a:ext cx="2011680" cy="548640"/>
-          </a:xfrm>
-          <a:prstGeom prst="rect">
-            <a:avLst/>
-          </a:prstGeom>
-          <a:noFill/>
-          <a:ln/>
-        </p:spPr>
-        <p:txBody>
-          <a:bodyPr wrap="square" lIns="0" tIns="0" rIns="0" bIns="0" rtlCol="0" anchor="ctr"/>
-          <a:lstStyle/>
-          <a:p>
-            <a:pPr algn="ctr" indent="0" marL="0">
-              <a:lnSpc>
-                <a:spcPct val="98000"/>
-              </a:lnSpc>
-              <a:buNone/>
-            </a:pPr>
-            <a:r>
-              <a:rPr lang="en-US" sz="1250" dirty="0">
-                <a:solidFill>
-                  <a:srgbClr val="13212A"/>
-                </a:solidFill>
-                <a:latin typeface="Calibri" pitchFamily="34" charset="0"/>
-                <a:ea typeface="Calibri" pitchFamily="34" charset="-122"/>
-                <a:cs typeface="Calibri" pitchFamily="34" charset="-120"/>
-              </a:rPr>
-              <a:t>Kidney 0.77</a:t>
-            </a:r>
-            <a:endParaRPr lang="en-US" sz="1250" dirty="0"/>
-          </a:p>
-        </p:txBody>
-      </p:sp>
-      <p:sp>
-        <p:nvSpPr>
-          <p:cNvPr id="35" name="Text 32"/>
-          <p:cNvSpPr/>
-          <p:nvPr/>
-        </p:nvSpPr>
-        <p:spPr>
-          <a:xfrm>
-            <a:off x="10076688" y="3474720"/>
-            <a:ext cx="1399032" cy="548640"/>
-          </a:xfrm>
-          <a:prstGeom prst="rect">
-            <a:avLst/>
-          </a:prstGeom>
-          <a:noFill/>
-          <a:ln/>
-        </p:spPr>
-        <p:txBody>
-          <a:bodyPr wrap="square" lIns="0" tIns="0" rIns="0" bIns="0" rtlCol="0" anchor="ctr"/>
-          <a:lstStyle/>
-          <a:p>
-            <a:pPr algn="ctr" indent="0" marL="0">
-              <a:lnSpc>
-                <a:spcPct val="98000"/>
-              </a:lnSpc>
-              <a:buNone/>
-            </a:pPr>
-            <a:r>
-              <a:rPr lang="en-US" sz="1250" b="1" dirty="0">
+              <a:rPr lang="en-US" sz="1300" b="1" dirty="0">
                 <a:solidFill>
                   <a:srgbClr val="0E8385"/>
                 </a:solidFill>
@@ -19445,21 +19067,21 @@
                 <a:ea typeface="Calibri" pitchFamily="34" charset="-122"/>
                 <a:cs typeface="Calibri" pitchFamily="34" charset="-120"/>
               </a:rPr>
-              <a:t>Slope +0.7; comp. 0.77</a:t>
-            </a:r>
-            <a:endParaRPr lang="en-US" sz="1250" dirty="0"/>
-          </a:p>
-        </p:txBody>
-      </p:sp>
-      <p:sp>
-        <p:nvSpPr>
-          <p:cNvPr id="36" name="Shape 33"/>
-          <p:cNvSpPr/>
-          <p:nvPr/>
-        </p:nvSpPr>
-        <p:spPr>
-          <a:xfrm>
-            <a:off x="640080" y="4572000"/>
+              <a:t>0.77 (0.60–0.99)</a:t>
+            </a:r>
+            <a:endParaRPr lang="en-US" sz="1300" dirty="0"/>
+          </a:p>
+        </p:txBody>
+      </p:sp>
+      <p:sp>
+        <p:nvSpPr>
+          <p:cNvPr id="27" name="Shape 24"/>
+          <p:cNvSpPr/>
+          <p:nvPr/>
+        </p:nvSpPr>
+        <p:spPr>
+          <a:xfrm>
+            <a:off x="640080" y="4636008"/>
             <a:ext cx="10908792" cy="0"/>
           </a:xfrm>
           <a:prstGeom prst="line">
@@ -19476,14 +19098,14 @@
       </p:sp>
       <p:sp>
         <p:nvSpPr>
-          <p:cNvPr id="37" name="Text 34"/>
-          <p:cNvSpPr/>
-          <p:nvPr/>
-        </p:nvSpPr>
-        <p:spPr>
-          <a:xfrm>
-            <a:off x="749808" y="4023360"/>
-            <a:ext cx="2560320" cy="548640"/>
+          <p:cNvPr id="28" name="Text 25"/>
+          <p:cNvSpPr/>
+          <p:nvPr/>
+        </p:nvSpPr>
+        <p:spPr>
+          <a:xfrm>
+            <a:off x="749808" y="4123944"/>
+            <a:ext cx="2926080" cy="512064"/>
           </a:xfrm>
           <a:prstGeom prst="rect">
             <a:avLst/>
@@ -19502,7 +19124,7 @@
               <a:buNone/>
             </a:pPr>
             <a:r>
-              <a:rPr lang="en-US" sz="1250" b="1" dirty="0">
+              <a:rPr lang="en-US" sz="1300" b="1" dirty="0">
                 <a:solidFill>
                   <a:srgbClr val="0F3446"/>
                 </a:solidFill>
@@ -19510,22 +19132,22 @@
                 <a:ea typeface="Calibri" pitchFamily="34" charset="-122"/>
                 <a:cs typeface="Calibri" pitchFamily="34" charset="-120"/>
               </a:rPr>
-              <a:t>eGFR slope Δ / yr</a:t>
-            </a:r>
-            <a:endParaRPr lang="en-US" sz="1250" dirty="0"/>
-          </a:p>
-        </p:txBody>
-      </p:sp>
-      <p:sp>
-        <p:nvSpPr>
-          <p:cNvPr id="38" name="Text 35"/>
-          <p:cNvSpPr/>
-          <p:nvPr/>
-        </p:nvSpPr>
-        <p:spPr>
-          <a:xfrm>
-            <a:off x="3493008" y="4023360"/>
-            <a:ext cx="2011680" cy="548640"/>
+              <a:t>CV composite</a:t>
+            </a:r>
+            <a:endParaRPr lang="en-US" sz="1300" dirty="0"/>
+          </a:p>
+        </p:txBody>
+      </p:sp>
+      <p:sp>
+        <p:nvSpPr>
+          <p:cNvPr id="29" name="Text 26"/>
+          <p:cNvSpPr/>
+          <p:nvPr/>
+        </p:nvSpPr>
+        <p:spPr>
+          <a:xfrm>
+            <a:off x="3858768" y="4123944"/>
+            <a:ext cx="3703320" cy="512064"/>
           </a:xfrm>
           <a:prstGeom prst="rect">
             <a:avLst/>
@@ -19544,7 +19166,7 @@
               <a:buNone/>
             </a:pPr>
             <a:r>
-              <a:rPr lang="en-US" sz="1250" dirty="0">
+              <a:rPr lang="en-US" sz="1300" dirty="0">
                 <a:solidFill>
                   <a:srgbClr val="13212A"/>
                 </a:solidFill>
@@ -19552,22 +19174,22 @@
                 <a:ea typeface="Calibri" pitchFamily="34" charset="-122"/>
                 <a:cs typeface="Calibri" pitchFamily="34" charset="-120"/>
               </a:rPr>
-              <a:t>~0.7</a:t>
-            </a:r>
-            <a:endParaRPr lang="en-US" sz="1250" dirty="0"/>
-          </a:p>
-        </p:txBody>
-      </p:sp>
-      <p:sp>
-        <p:nvSpPr>
-          <p:cNvPr id="39" name="Text 36"/>
-          <p:cNvSpPr/>
-          <p:nvPr/>
-        </p:nvSpPr>
-        <p:spPr>
-          <a:xfrm>
-            <a:off x="5687568" y="4023360"/>
-            <a:ext cx="2011680" cy="548640"/>
+              <a:t>0.86 (0.78–0.95)</a:t>
+            </a:r>
+            <a:endParaRPr lang="en-US" sz="1300" dirty="0"/>
+          </a:p>
+        </p:txBody>
+      </p:sp>
+      <p:sp>
+        <p:nvSpPr>
+          <p:cNvPr id="30" name="Text 27"/>
+          <p:cNvSpPr/>
+          <p:nvPr/>
+        </p:nvSpPr>
+        <p:spPr>
+          <a:xfrm>
+            <a:off x="7744968" y="4123944"/>
+            <a:ext cx="3730752" cy="512064"/>
           </a:xfrm>
           <a:prstGeom prst="rect">
             <a:avLst/>
@@ -19586,30 +19208,95 @@
               <a:buNone/>
             </a:pPr>
             <a:r>
-              <a:rPr lang="en-US" sz="1250" dirty="0">
-                <a:solidFill>
-                  <a:srgbClr val="13212A"/>
-                </a:solidFill>
-                <a:latin typeface="Calibri" pitchFamily="34" charset="0"/>
-                <a:ea typeface="Calibri" pitchFamily="34" charset="-122"/>
-                <a:cs typeface="Calibri" pitchFamily="34" charset="-120"/>
-              </a:rPr>
-              <a:t>n/r</a:t>
-            </a:r>
-            <a:endParaRPr lang="en-US" sz="1250" dirty="0"/>
-          </a:p>
-        </p:txBody>
-      </p:sp>
-      <p:sp>
-        <p:nvSpPr>
-          <p:cNvPr id="40" name="Text 37"/>
-          <p:cNvSpPr/>
-          <p:nvPr/>
-        </p:nvSpPr>
-        <p:spPr>
-          <a:xfrm>
-            <a:off x="7882128" y="4023360"/>
-            <a:ext cx="2011680" cy="548640"/>
+              <a:rPr lang="en-US" sz="1300" b="1" dirty="0">
+                <a:solidFill>
+                  <a:srgbClr val="0E8385"/>
+                </a:solidFill>
+                <a:latin typeface="Calibri" pitchFamily="34" charset="0"/>
+                <a:ea typeface="Calibri" pitchFamily="34" charset="-122"/>
+                <a:cs typeface="Calibri" pitchFamily="34" charset="-120"/>
+              </a:rPr>
+              <a:t>0.60 (0.27–1.33)</a:t>
+            </a:r>
+            <a:endParaRPr lang="en-US" sz="1300" dirty="0"/>
+          </a:p>
+        </p:txBody>
+      </p:sp>
+      <p:sp>
+        <p:nvSpPr>
+          <p:cNvPr id="31" name="Shape 28"/>
+          <p:cNvSpPr/>
+          <p:nvPr/>
+        </p:nvSpPr>
+        <p:spPr>
+          <a:xfrm>
+            <a:off x="640080" y="5148072"/>
+            <a:ext cx="10908792" cy="0"/>
+          </a:xfrm>
+          <a:prstGeom prst="line">
+            <a:avLst/>
+          </a:prstGeom>
+          <a:noFill/>
+          <a:ln w="9525">
+            <a:solidFill>
+              <a:srgbClr val="CFDDDD"/>
+            </a:solidFill>
+            <a:prstDash val="solid"/>
+          </a:ln>
+        </p:spPr>
+      </p:sp>
+      <p:sp>
+        <p:nvSpPr>
+          <p:cNvPr id="32" name="Text 29"/>
+          <p:cNvSpPr/>
+          <p:nvPr/>
+        </p:nvSpPr>
+        <p:spPr>
+          <a:xfrm>
+            <a:off x="749808" y="4636008"/>
+            <a:ext cx="2926080" cy="512064"/>
+          </a:xfrm>
+          <a:prstGeom prst="rect">
+            <a:avLst/>
+          </a:prstGeom>
+          <a:noFill/>
+          <a:ln/>
+        </p:spPr>
+        <p:txBody>
+          <a:bodyPr wrap="square" lIns="0" tIns="0" rIns="0" bIns="0" rtlCol="0" anchor="ctr"/>
+          <a:lstStyle/>
+          <a:p>
+            <a:pPr algn="l" indent="0" marL="0">
+              <a:lnSpc>
+                <a:spcPct val="98000"/>
+              </a:lnSpc>
+              <a:buNone/>
+            </a:pPr>
+            <a:r>
+              <a:rPr lang="en-US" sz="1300" b="1" dirty="0">
+                <a:solidFill>
+                  <a:srgbClr val="0F3446"/>
+                </a:solidFill>
+                <a:latin typeface="Calibri" pitchFamily="34" charset="0"/>
+                <a:ea typeface="Calibri" pitchFamily="34" charset="-122"/>
+                <a:cs typeface="Calibri" pitchFamily="34" charset="-120"/>
+              </a:rPr>
+              <a:t>eGFR slope Δ / yr</a:t>
+            </a:r>
+            <a:endParaRPr lang="en-US" sz="1300" dirty="0"/>
+          </a:p>
+        </p:txBody>
+      </p:sp>
+      <p:sp>
+        <p:nvSpPr>
+          <p:cNvPr id="33" name="Text 30"/>
+          <p:cNvSpPr/>
+          <p:nvPr/>
+        </p:nvSpPr>
+        <p:spPr>
+          <a:xfrm>
+            <a:off x="3858768" y="4636008"/>
+            <a:ext cx="3703320" cy="512064"/>
           </a:xfrm>
           <a:prstGeom prst="rect">
             <a:avLst/>
@@ -19628,7 +19315,7 @@
               <a:buNone/>
             </a:pPr>
             <a:r>
-              <a:rPr lang="en-US" sz="1250" dirty="0">
+              <a:rPr lang="en-US" sz="1300" dirty="0">
                 <a:solidFill>
                   <a:srgbClr val="13212A"/>
                 </a:solidFill>
@@ -19636,22 +19323,22 @@
                 <a:ea typeface="Calibri" pitchFamily="34" charset="-122"/>
                 <a:cs typeface="Calibri" pitchFamily="34" charset="-120"/>
               </a:rPr>
-              <a:t>n/r</a:t>
-            </a:r>
-            <a:endParaRPr lang="en-US" sz="1250" dirty="0"/>
-          </a:p>
-        </p:txBody>
-      </p:sp>
-      <p:sp>
-        <p:nvSpPr>
-          <p:cNvPr id="41" name="Text 38"/>
-          <p:cNvSpPr/>
-          <p:nvPr/>
-        </p:nvSpPr>
-        <p:spPr>
-          <a:xfrm>
-            <a:off x="10076688" y="4023360"/>
-            <a:ext cx="1399032" cy="548640"/>
+              <a:t>not reported</a:t>
+            </a:r>
+            <a:endParaRPr lang="en-US" sz="1300" dirty="0"/>
+          </a:p>
+        </p:txBody>
+      </p:sp>
+      <p:sp>
+        <p:nvSpPr>
+          <p:cNvPr id="34" name="Text 31"/>
+          <p:cNvSpPr/>
+          <p:nvPr/>
+        </p:nvSpPr>
+        <p:spPr>
+          <a:xfrm>
+            <a:off x="7744968" y="4636008"/>
+            <a:ext cx="3730752" cy="512064"/>
           </a:xfrm>
           <a:prstGeom prst="rect">
             <a:avLst/>
@@ -19670,7 +19357,7 @@
               <a:buNone/>
             </a:pPr>
             <a:r>
-              <a:rPr lang="en-US" sz="1250" b="1" dirty="0">
+              <a:rPr lang="en-US" sz="1300" b="1" dirty="0">
                 <a:solidFill>
                   <a:srgbClr val="0E8385"/>
                 </a:solidFill>
@@ -19680,20 +19367,20 @@
               </a:rPr>
               <a:t>0.7 (chronic 1.2)</a:t>
             </a:r>
-            <a:endParaRPr lang="en-US" sz="1250" dirty="0"/>
-          </a:p>
-        </p:txBody>
-      </p:sp>
-      <p:sp>
-        <p:nvSpPr>
-          <p:cNvPr id="42" name="Text 39"/>
-          <p:cNvSpPr/>
-          <p:nvPr/>
-        </p:nvSpPr>
-        <p:spPr>
-          <a:xfrm>
-            <a:off x="640080" y="4800600"/>
-            <a:ext cx="10908792" cy="822960"/>
+            <a:endParaRPr lang="en-US" sz="1300" dirty="0"/>
+          </a:p>
+        </p:txBody>
+      </p:sp>
+      <p:sp>
+        <p:nvSpPr>
+          <p:cNvPr id="35" name="Text 32"/>
+          <p:cNvSpPr/>
+          <p:nvPr/>
+        </p:nvSpPr>
+        <p:spPr>
+          <a:xfrm>
+            <a:off x="640080" y="5376672"/>
+            <a:ext cx="10908792" cy="640080"/>
           </a:xfrm>
           <a:prstGeom prst="rect">
             <a:avLst/>
@@ -19712,7 +19399,7 @@
               <a:buNone/>
             </a:pPr>
             <a:r>
-              <a:rPr lang="en-US" sz="1500" dirty="0">
+              <a:rPr lang="en-US" sz="1400" dirty="0">
                 <a:solidFill>
                   <a:srgbClr val="13212A"/>
                 </a:solidFill>
@@ -19720,15 +19407,15 @@
                 <a:ea typeface="Calibri" pitchFamily="34" charset="-122"/>
                 <a:cs typeface="Calibri" pitchFamily="34" charset="-120"/>
               </a:rPr>
-              <a:t>The ~0.7/yr slope effect finerenone produced in diabetic CKD reproduces almost exactly in non-diabetic CKD, and the chronic slope of 1.2 sits right alongside RAS and SGLT2 inhibitors (0.5–1.0). Same drug, same mechanism, in a population never before tested.</a:t>
-            </a:r>
-            <a:endParaRPr lang="en-US" sz="1500" dirty="0"/>
-          </a:p>
-        </p:txBody>
-      </p:sp>
-      <p:sp>
-        <p:nvSpPr>
-          <p:cNvPr id="43" name="Text 40"/>
+              <a:t>Same drug, same ≥57% kidney definition, a population never before tested. FIND-CKD was not powered for cardiovascular events, so its CV estimate is imprecise.</a:t>
+            </a:r>
+            <a:endParaRPr lang="en-US" sz="1400" dirty="0"/>
+          </a:p>
+        </p:txBody>
+      </p:sp>
+      <p:sp>
+        <p:nvSpPr>
+          <p:cNvPr id="36" name="Text 33"/>
           <p:cNvSpPr/>
           <p:nvPr/>
         </p:nvSpPr>
@@ -19759,7 +19446,7 @@
                 <a:ea typeface="Calibri" pitchFamily="34" charset="-122"/>
                 <a:cs typeface="Calibri" pitchFamily="34" charset="-120"/>
               </a:rPr>
-              <a:t>Diabetes-trial figures from their primary publications, shown for context (no head-to-head).</a:t>
+              <a:t>FIDELITY: Agarwal et al., Eur Heart J 2022.  FIND-CKD: Heerspink et al., N Engl J Med 2026.</a:t>
             </a:r>
             <a:endParaRPr lang="en-US" sz="850" dirty="0"/>
           </a:p>
@@ -19767,7 +19454,7 @@
       </p:sp>
       <p:sp>
         <p:nvSpPr>
-          <p:cNvPr id="44" name="Text 41"/>
+          <p:cNvPr id="37" name="Text 34"/>
           <p:cNvSpPr/>
           <p:nvPr/>
         </p:nvSpPr>
@@ -19820,7 +19507,7 @@
       </p:sp>
       <p:sp>
         <p:nvSpPr>
-          <p:cNvPr id="45" name="Text 42"/>
+          <p:cNvPr id="38" name="Text 35"/>
           <p:cNvSpPr/>
           <p:nvPr/>
         </p:nvSpPr>
@@ -21488,7 +21175,7 @@
                 <a:ea typeface="Calibri" pitchFamily="34" charset="-122"/>
                 <a:cs typeface="Calibri" pitchFamily="34" charset="-120"/>
               </a:rPr>
-              <a:t>Review why finerenone was tested in CKD without diabetes, and how FIND-CKD relates to FIDELIO, FIGARO and FIDELITY.</a:t>
+              <a:t>Review why finerenone was tested in CKD without diabetes, and how FIND-CKD relates to the finerenone evidence in diabetic CKD (the FIDELITY analysis).</a:t>
             </a:r>
             <a:endParaRPr lang="en-US" sz="1550" dirty="0"/>
           </a:p>
@@ -23238,7 +22925,7 @@
                 <a:ea typeface="Calibri" pitchFamily="34" charset="-122"/>
                 <a:cs typeface="Calibri" pitchFamily="34" charset="-120"/>
               </a:rPr>
-              <a:t>In BARACK-D, over half of CKD patients stopped spironolactone within 6 months on safety grounds, mostly AKI and hyperkalemia.</a:t>
+              <a:t>In BARACK-D, the steroidal MRA spironolactone did not reduce cardiovascular events in stage 3b CKD (HR 1.05), and about two-thirds of patients stopped it within 6 months, mainly for falling eGFR and hyperkalemia.</a:t>
             </a:r>
             <a:endParaRPr lang="en-US" sz="1450" dirty="0"/>
           </a:p>
@@ -23506,7 +23193,7 @@
                 <a:ea typeface="Arial" pitchFamily="34" charset="-122"/>
                 <a:cs typeface="Arial" pitchFamily="34" charset="-120"/>
               </a:rPr>
-              <a:t>What we already knew: finerenone in diabetes</a:t>
+              <a:t>What we knew: finerenone in diabetic CKD</a:t>
             </a:r>
             <a:endParaRPr lang="en-US" sz="2400" dirty="0"/>
           </a:p>
@@ -23545,7 +23232,7 @@
                 <a:ea typeface="Calibri" pitchFamily="34" charset="-122"/>
                 <a:cs typeface="Calibri" pitchFamily="34" charset="-120"/>
               </a:rPr>
-              <a:t>Every phase 3 finerenone kidney trial before FIND-CKD enrolled only patients with type 2 diabetes.</a:t>
+              <a:t>FIDELITY pooled the FIDELIO-DKD and FIGARO-DKD trials: 13,026 patients with type 2 diabetes and CKD.</a:t>
             </a:r>
             <a:endParaRPr lang="en-US" sz="1350" dirty="0"/>
           </a:p>
@@ -23560,7 +23247,7 @@
         <p:spPr>
           <a:xfrm>
             <a:off x="640080" y="1554480"/>
-            <a:ext cx="11055096" cy="457200"/>
+            <a:ext cx="10908792" cy="457200"/>
           </a:xfrm>
           <a:prstGeom prst="rect">
             <a:avLst/>
@@ -23580,7 +23267,7 @@
         <p:spPr>
           <a:xfrm>
             <a:off x="749808" y="1554480"/>
-            <a:ext cx="2468880" cy="457200"/>
+            <a:ext cx="4572000" cy="457200"/>
           </a:xfrm>
           <a:prstGeom prst="rect">
             <a:avLst/>
@@ -23607,7 +23294,7 @@
                 <a:ea typeface="Calibri" pitchFamily="34" charset="-122"/>
                 <a:cs typeface="Calibri" pitchFamily="34" charset="-120"/>
               </a:rPr>
-              <a:t>Trial (year)</a:t>
+              <a:t>Outcome (FIDELITY pooled analysis)</a:t>
             </a:r>
             <a:endParaRPr lang="en-US" sz="1300" dirty="0"/>
           </a:p>
@@ -23621,20 +23308,20 @@
         </p:nvSpPr>
         <p:spPr>
           <a:xfrm>
-            <a:off x="3401568" y="1554480"/>
-            <a:ext cx="3017520" cy="457200"/>
-          </a:xfrm>
-          <a:prstGeom prst="rect">
-            <a:avLst/>
-          </a:prstGeom>
-          <a:noFill/>
-          <a:ln/>
-        </p:spPr>
-        <p:txBody>
-          <a:bodyPr wrap="square" lIns="0" tIns="0" rIns="0" bIns="0" rtlCol="0" anchor="ctr"/>
-          <a:lstStyle/>
-          <a:p>
-            <a:pPr algn="l" indent="0" marL="0">
+            <a:off x="5504688" y="1554480"/>
+            <a:ext cx="2468880" cy="457200"/>
+          </a:xfrm>
+          <a:prstGeom prst="rect">
+            <a:avLst/>
+          </a:prstGeom>
+          <a:noFill/>
+          <a:ln/>
+        </p:spPr>
+        <p:txBody>
+          <a:bodyPr wrap="square" lIns="0" tIns="0" rIns="0" bIns="0" rtlCol="0" anchor="ctr"/>
+          <a:lstStyle/>
+          <a:p>
+            <a:pPr algn="ctr" indent="0" marL="0">
               <a:lnSpc>
                 <a:spcPct val="98000"/>
               </a:lnSpc>
@@ -23649,7 +23336,7 @@
                 <a:ea typeface="Calibri" pitchFamily="34" charset="-122"/>
                 <a:cs typeface="Calibri" pitchFamily="34" charset="-120"/>
               </a:rPr>
-              <a:t>Population</a:t>
+              <a:t>Fin vs plac</a:t>
             </a:r>
             <a:endParaRPr lang="en-US" sz="1300" dirty="0"/>
           </a:p>
@@ -23663,20 +23350,20 @@
         </p:nvSpPr>
         <p:spPr>
           <a:xfrm>
-            <a:off x="6601968" y="1554480"/>
-            <a:ext cx="2926080" cy="457200"/>
-          </a:xfrm>
-          <a:prstGeom prst="rect">
-            <a:avLst/>
-          </a:prstGeom>
-          <a:noFill/>
-          <a:ln/>
-        </p:spPr>
-        <p:txBody>
-          <a:bodyPr wrap="square" lIns="0" tIns="0" rIns="0" bIns="0" rtlCol="0" anchor="ctr"/>
-          <a:lstStyle/>
-          <a:p>
-            <a:pPr algn="l" indent="0" marL="0">
+            <a:off x="8156448" y="1554480"/>
+            <a:ext cx="2011680" cy="457200"/>
+          </a:xfrm>
+          <a:prstGeom prst="rect">
+            <a:avLst/>
+          </a:prstGeom>
+          <a:noFill/>
+          <a:ln/>
+        </p:spPr>
+        <p:txBody>
+          <a:bodyPr wrap="square" lIns="0" tIns="0" rIns="0" bIns="0" rtlCol="0" anchor="ctr"/>
+          <a:lstStyle/>
+          <a:p>
+            <a:pPr algn="ctr" indent="0" marL="0">
               <a:lnSpc>
                 <a:spcPct val="98000"/>
               </a:lnSpc>
@@ -23691,7 +23378,7 @@
                 <a:ea typeface="Calibri" pitchFamily="34" charset="-122"/>
                 <a:cs typeface="Calibri" pitchFamily="34" charset="-120"/>
               </a:rPr>
-              <a:t>Primary outcome</a:t>
+              <a:t>HR (95% CI)</a:t>
             </a:r>
             <a:endParaRPr lang="en-US" sz="1300" dirty="0"/>
           </a:p>
@@ -23705,20 +23392,20 @@
         </p:nvSpPr>
         <p:spPr>
           <a:xfrm>
-            <a:off x="9710928" y="1554480"/>
-            <a:ext cx="1911096" cy="457200"/>
-          </a:xfrm>
-          <a:prstGeom prst="rect">
-            <a:avLst/>
-          </a:prstGeom>
-          <a:noFill/>
-          <a:ln/>
-        </p:spPr>
-        <p:txBody>
-          <a:bodyPr wrap="square" lIns="0" tIns="0" rIns="0" bIns="0" rtlCol="0" anchor="ctr"/>
-          <a:lstStyle/>
-          <a:p>
-            <a:pPr algn="l" indent="0" marL="0">
+            <a:off x="10351008" y="1554480"/>
+            <a:ext cx="1124712" cy="457200"/>
+          </a:xfrm>
+          <a:prstGeom prst="rect">
+            <a:avLst/>
+          </a:prstGeom>
+          <a:noFill/>
+          <a:ln/>
+        </p:spPr>
+        <p:txBody>
+          <a:bodyPr wrap="square" lIns="0" tIns="0" rIns="0" bIns="0" rtlCol="0" anchor="ctr"/>
+          <a:lstStyle/>
+          <a:p>
+            <a:pPr algn="ctr" indent="0" marL="0">
               <a:lnSpc>
                 <a:spcPct val="98000"/>
               </a:lnSpc>
@@ -23733,7 +23420,7 @@
                 <a:ea typeface="Calibri" pitchFamily="34" charset="-122"/>
                 <a:cs typeface="Calibri" pitchFamily="34" charset="-120"/>
               </a:rPr>
-              <a:t>HR (95% CI)</a:t>
+              <a:t>P</a:t>
             </a:r>
             <a:endParaRPr lang="en-US" sz="1300" dirty="0"/>
           </a:p>
@@ -23747,8 +23434,8 @@
         </p:nvSpPr>
         <p:spPr>
           <a:xfrm>
-            <a:off x="640080" y="2761488"/>
-            <a:ext cx="11055096" cy="0"/>
+            <a:off x="640080" y="3017520"/>
+            <a:ext cx="10908792" cy="0"/>
           </a:xfrm>
           <a:prstGeom prst="line">
             <a:avLst/>
@@ -23771,7 +23458,7 @@
         <p:spPr>
           <a:xfrm>
             <a:off x="749808" y="2011680"/>
-            <a:ext cx="2468880" cy="749808"/>
+            <a:ext cx="4572000" cy="1005840"/>
           </a:xfrm>
           <a:prstGeom prst="rect">
             <a:avLst/>
@@ -23790,7 +23477,7 @@
               <a:buNone/>
             </a:pPr>
             <a:r>
-              <a:rPr lang="en-US" sz="1300" b="1" dirty="0">
+              <a:rPr lang="en-US" sz="1250" b="1" dirty="0">
                 <a:solidFill>
                   <a:srgbClr val="0F3446"/>
                 </a:solidFill>
@@ -23798,9 +23485,9 @@
                 <a:ea typeface="Calibri" pitchFamily="34" charset="-122"/>
                 <a:cs typeface="Calibri" pitchFamily="34" charset="-120"/>
               </a:rPr>
-              <a:t>FIDELIO-DKD (2020)</a:t>
-            </a:r>
-            <a:endParaRPr lang="en-US" sz="1300" dirty="0"/>
+              <a:t>Cardiovascular composite (CV death, MI, stroke, or HF hospitalization)</a:t>
+            </a:r>
+            <a:endParaRPr lang="en-US" sz="1250" dirty="0"/>
           </a:p>
         </p:txBody>
       </p:sp>
@@ -23812,27 +23499,27 @@
         </p:nvSpPr>
         <p:spPr>
           <a:xfrm>
-            <a:off x="3401568" y="2011680"/>
-            <a:ext cx="3017520" cy="749808"/>
-          </a:xfrm>
-          <a:prstGeom prst="rect">
-            <a:avLst/>
-          </a:prstGeom>
-          <a:noFill/>
-          <a:ln/>
-        </p:spPr>
-        <p:txBody>
-          <a:bodyPr wrap="square" lIns="0" tIns="0" rIns="0" bIns="0" rtlCol="0" anchor="ctr"/>
-          <a:lstStyle/>
-          <a:p>
-            <a:pPr algn="l" indent="0" marL="0">
+            <a:off x="5504688" y="2011680"/>
+            <a:ext cx="2468880" cy="1005840"/>
+          </a:xfrm>
+          <a:prstGeom prst="rect">
+            <a:avLst/>
+          </a:prstGeom>
+          <a:noFill/>
+          <a:ln/>
+        </p:spPr>
+        <p:txBody>
+          <a:bodyPr wrap="square" lIns="0" tIns="0" rIns="0" bIns="0" rtlCol="0" anchor="ctr"/>
+          <a:lstStyle/>
+          <a:p>
+            <a:pPr algn="ctr" indent="0" marL="0">
               <a:lnSpc>
                 <a:spcPct val="98000"/>
               </a:lnSpc>
               <a:buNone/>
             </a:pPr>
             <a:r>
-              <a:rPr lang="en-US" sz="1300" dirty="0">
+              <a:rPr lang="en-US" sz="1250" dirty="0">
                 <a:solidFill>
                   <a:srgbClr val="13212A"/>
                 </a:solidFill>
@@ -23840,9 +23527,9 @@
                 <a:ea typeface="Calibri" pitchFamily="34" charset="-122"/>
                 <a:cs typeface="Calibri" pitchFamily="34" charset="-120"/>
               </a:rPr>
-              <a:t>T2D + CKD, mostly UACR &gt;300; N=5674</a:t>
-            </a:r>
-            <a:endParaRPr lang="en-US" sz="1300" dirty="0"/>
+              <a:t>12.7% vs 14.4%</a:t>
+            </a:r>
+            <a:endParaRPr lang="en-US" sz="1250" dirty="0"/>
           </a:p>
         </p:txBody>
       </p:sp>
@@ -23854,37 +23541,37 @@
         </p:nvSpPr>
         <p:spPr>
           <a:xfrm>
-            <a:off x="6601968" y="2011680"/>
-            <a:ext cx="2926080" cy="749808"/>
-          </a:xfrm>
-          <a:prstGeom prst="rect">
-            <a:avLst/>
-          </a:prstGeom>
-          <a:noFill/>
-          <a:ln/>
-        </p:spPr>
-        <p:txBody>
-          <a:bodyPr wrap="square" lIns="0" tIns="0" rIns="0" bIns="0" rtlCol="0" anchor="ctr"/>
-          <a:lstStyle/>
-          <a:p>
-            <a:pPr algn="l" indent="0" marL="0">
+            <a:off x="8156448" y="2011680"/>
+            <a:ext cx="2011680" cy="1005840"/>
+          </a:xfrm>
+          <a:prstGeom prst="rect">
+            <a:avLst/>
+          </a:prstGeom>
+          <a:noFill/>
+          <a:ln/>
+        </p:spPr>
+        <p:txBody>
+          <a:bodyPr wrap="square" lIns="0" tIns="0" rIns="0" bIns="0" rtlCol="0" anchor="ctr"/>
+          <a:lstStyle/>
+          <a:p>
+            <a:pPr algn="ctr" indent="0" marL="0">
               <a:lnSpc>
                 <a:spcPct val="98000"/>
               </a:lnSpc>
               <a:buNone/>
             </a:pPr>
             <a:r>
-              <a:rPr lang="en-US" sz="1300" dirty="0">
-                <a:solidFill>
-                  <a:srgbClr val="13212A"/>
-                </a:solidFill>
-                <a:latin typeface="Calibri" pitchFamily="34" charset="0"/>
-                <a:ea typeface="Calibri" pitchFamily="34" charset="-122"/>
-                <a:cs typeface="Calibri" pitchFamily="34" charset="-120"/>
-              </a:rPr>
-              <a:t>Kidney: kidney failure, sustained ≥40% eGFR decline, or renal death</a:t>
-            </a:r>
-            <a:endParaRPr lang="en-US" sz="1300" dirty="0"/>
+              <a:rPr lang="en-US" sz="1250" b="1" dirty="0">
+                <a:solidFill>
+                  <a:srgbClr val="0E8385"/>
+                </a:solidFill>
+                <a:latin typeface="Calibri" pitchFamily="34" charset="0"/>
+                <a:ea typeface="Calibri" pitchFamily="34" charset="-122"/>
+                <a:cs typeface="Calibri" pitchFamily="34" charset="-120"/>
+              </a:rPr>
+              <a:t>0.86 (0.78–0.95)</a:t>
+            </a:r>
+            <a:endParaRPr lang="en-US" sz="1250" dirty="0"/>
           </a:p>
         </p:txBody>
       </p:sp>
@@ -23896,37 +23583,37 @@
         </p:nvSpPr>
         <p:spPr>
           <a:xfrm>
-            <a:off x="9710928" y="2011680"/>
-            <a:ext cx="1911096" cy="749808"/>
-          </a:xfrm>
-          <a:prstGeom prst="rect">
-            <a:avLst/>
-          </a:prstGeom>
-          <a:noFill/>
-          <a:ln/>
-        </p:spPr>
-        <p:txBody>
-          <a:bodyPr wrap="square" lIns="0" tIns="0" rIns="0" bIns="0" rtlCol="0" anchor="ctr"/>
-          <a:lstStyle/>
-          <a:p>
-            <a:pPr algn="l" indent="0" marL="0">
+            <a:off x="10351008" y="2011680"/>
+            <a:ext cx="1124712" cy="1005840"/>
+          </a:xfrm>
+          <a:prstGeom prst="rect">
+            <a:avLst/>
+          </a:prstGeom>
+          <a:noFill/>
+          <a:ln/>
+        </p:spPr>
+        <p:txBody>
+          <a:bodyPr wrap="square" lIns="0" tIns="0" rIns="0" bIns="0" rtlCol="0" anchor="ctr"/>
+          <a:lstStyle/>
+          <a:p>
+            <a:pPr algn="ctr" indent="0" marL="0">
               <a:lnSpc>
                 <a:spcPct val="98000"/>
               </a:lnSpc>
               <a:buNone/>
             </a:pPr>
             <a:r>
-              <a:rPr lang="en-US" sz="1300" b="1" dirty="0">
-                <a:solidFill>
-                  <a:srgbClr val="0E8385"/>
-                </a:solidFill>
-                <a:latin typeface="Calibri" pitchFamily="34" charset="0"/>
-                <a:ea typeface="Calibri" pitchFamily="34" charset="-122"/>
-                <a:cs typeface="Calibri" pitchFamily="34" charset="-120"/>
-              </a:rPr>
-              <a:t>0.82 (0.73–0.93)</a:t>
-            </a:r>
-            <a:endParaRPr lang="en-US" sz="1300" dirty="0"/>
+              <a:rPr lang="en-US" sz="1250" dirty="0">
+                <a:solidFill>
+                  <a:srgbClr val="13212A"/>
+                </a:solidFill>
+                <a:latin typeface="Calibri" pitchFamily="34" charset="0"/>
+                <a:ea typeface="Calibri" pitchFamily="34" charset="-122"/>
+                <a:cs typeface="Calibri" pitchFamily="34" charset="-120"/>
+              </a:rPr>
+              <a:t>0.0018</a:t>
+            </a:r>
+            <a:endParaRPr lang="en-US" sz="1250" dirty="0"/>
           </a:p>
         </p:txBody>
       </p:sp>
@@ -23938,8 +23625,8 @@
         </p:nvSpPr>
         <p:spPr>
           <a:xfrm>
-            <a:off x="640080" y="3511296"/>
-            <a:ext cx="11055096" cy="0"/>
+            <a:off x="640080" y="4023360"/>
+            <a:ext cx="10908792" cy="0"/>
           </a:xfrm>
           <a:prstGeom prst="line">
             <a:avLst/>
@@ -23961,8 +23648,8 @@
         </p:nvSpPr>
         <p:spPr>
           <a:xfrm>
-            <a:off x="749808" y="2761488"/>
-            <a:ext cx="2468880" cy="749808"/>
+            <a:off x="749808" y="3017520"/>
+            <a:ext cx="4572000" cy="1005840"/>
           </a:xfrm>
           <a:prstGeom prst="rect">
             <a:avLst/>
@@ -23981,7 +23668,7 @@
               <a:buNone/>
             </a:pPr>
             <a:r>
-              <a:rPr lang="en-US" sz="1300" b="1" dirty="0">
+              <a:rPr lang="en-US" sz="1250" b="1" dirty="0">
                 <a:solidFill>
                   <a:srgbClr val="0F3446"/>
                 </a:solidFill>
@@ -23989,9 +23676,9 @@
                 <a:ea typeface="Calibri" pitchFamily="34" charset="-122"/>
                 <a:cs typeface="Calibri" pitchFamily="34" charset="-120"/>
               </a:rPr>
-              <a:t>FIGARO-DKD (2021)</a:t>
-            </a:r>
-            <a:endParaRPr lang="en-US" sz="1300" dirty="0"/>
+              <a:t>Kidney composite (kidney failure, sustained ≥57% eGFR decline, or renal death)</a:t>
+            </a:r>
+            <a:endParaRPr lang="en-US" sz="1250" dirty="0"/>
           </a:p>
         </p:txBody>
       </p:sp>
@@ -24003,27 +23690,27 @@
         </p:nvSpPr>
         <p:spPr>
           <a:xfrm>
-            <a:off x="3401568" y="2761488"/>
-            <a:ext cx="3017520" cy="749808"/>
-          </a:xfrm>
-          <a:prstGeom prst="rect">
-            <a:avLst/>
-          </a:prstGeom>
-          <a:noFill/>
-          <a:ln/>
-        </p:spPr>
-        <p:txBody>
-          <a:bodyPr wrap="square" lIns="0" tIns="0" rIns="0" bIns="0" rtlCol="0" anchor="ctr"/>
-          <a:lstStyle/>
-          <a:p>
-            <a:pPr algn="l" indent="0" marL="0">
+            <a:off x="5504688" y="3017520"/>
+            <a:ext cx="2468880" cy="1005840"/>
+          </a:xfrm>
+          <a:prstGeom prst="rect">
+            <a:avLst/>
+          </a:prstGeom>
+          <a:noFill/>
+          <a:ln/>
+        </p:spPr>
+        <p:txBody>
+          <a:bodyPr wrap="square" lIns="0" tIns="0" rIns="0" bIns="0" rtlCol="0" anchor="ctr"/>
+          <a:lstStyle/>
+          <a:p>
+            <a:pPr algn="ctr" indent="0" marL="0">
               <a:lnSpc>
                 <a:spcPct val="98000"/>
               </a:lnSpc>
               <a:buNone/>
             </a:pPr>
             <a:r>
-              <a:rPr lang="en-US" sz="1300" dirty="0">
+              <a:rPr lang="en-US" sz="1250" dirty="0">
                 <a:solidFill>
                   <a:srgbClr val="13212A"/>
                 </a:solidFill>
@@ -24031,9 +23718,9 @@
                 <a:ea typeface="Calibri" pitchFamily="34" charset="-122"/>
                 <a:cs typeface="Calibri" pitchFamily="34" charset="-120"/>
               </a:rPr>
-              <a:t>T2D + CKD, earlier stage; N=7437</a:t>
-            </a:r>
-            <a:endParaRPr lang="en-US" sz="1300" dirty="0"/>
+              <a:t>5.5% vs 7.1%</a:t>
+            </a:r>
+            <a:endParaRPr lang="en-US" sz="1250" dirty="0"/>
           </a:p>
         </p:txBody>
       </p:sp>
@@ -24045,37 +23732,37 @@
         </p:nvSpPr>
         <p:spPr>
           <a:xfrm>
-            <a:off x="6601968" y="2761488"/>
-            <a:ext cx="2926080" cy="749808"/>
-          </a:xfrm>
-          <a:prstGeom prst="rect">
-            <a:avLst/>
-          </a:prstGeom>
-          <a:noFill/>
-          <a:ln/>
-        </p:spPr>
-        <p:txBody>
-          <a:bodyPr wrap="square" lIns="0" tIns="0" rIns="0" bIns="0" rtlCol="0" anchor="ctr"/>
-          <a:lstStyle/>
-          <a:p>
-            <a:pPr algn="l" indent="0" marL="0">
+            <a:off x="8156448" y="3017520"/>
+            <a:ext cx="2011680" cy="1005840"/>
+          </a:xfrm>
+          <a:prstGeom prst="rect">
+            <a:avLst/>
+          </a:prstGeom>
+          <a:noFill/>
+          <a:ln/>
+        </p:spPr>
+        <p:txBody>
+          <a:bodyPr wrap="square" lIns="0" tIns="0" rIns="0" bIns="0" rtlCol="0" anchor="ctr"/>
+          <a:lstStyle/>
+          <a:p>
+            <a:pPr algn="ctr" indent="0" marL="0">
               <a:lnSpc>
                 <a:spcPct val="98000"/>
               </a:lnSpc>
               <a:buNone/>
             </a:pPr>
             <a:r>
-              <a:rPr lang="en-US" sz="1300" dirty="0">
-                <a:solidFill>
-                  <a:srgbClr val="13212A"/>
-                </a:solidFill>
-                <a:latin typeface="Calibri" pitchFamily="34" charset="0"/>
-                <a:ea typeface="Calibri" pitchFamily="34" charset="-122"/>
-                <a:cs typeface="Calibri" pitchFamily="34" charset="-120"/>
-              </a:rPr>
-              <a:t>CV: CV death, MI, stroke, or HF hospitalization</a:t>
-            </a:r>
-            <a:endParaRPr lang="en-US" sz="1300" dirty="0"/>
+              <a:rPr lang="en-US" sz="1250" b="1" dirty="0">
+                <a:solidFill>
+                  <a:srgbClr val="0E8385"/>
+                </a:solidFill>
+                <a:latin typeface="Calibri" pitchFamily="34" charset="0"/>
+                <a:ea typeface="Calibri" pitchFamily="34" charset="-122"/>
+                <a:cs typeface="Calibri" pitchFamily="34" charset="-120"/>
+              </a:rPr>
+              <a:t>0.77 (0.67–0.88)</a:t>
+            </a:r>
+            <a:endParaRPr lang="en-US" sz="1250" dirty="0"/>
           </a:p>
         </p:txBody>
       </p:sp>
@@ -24087,62 +23774,81 @@
         </p:nvSpPr>
         <p:spPr>
           <a:xfrm>
-            <a:off x="9710928" y="2761488"/>
-            <a:ext cx="1911096" cy="749808"/>
-          </a:xfrm>
-          <a:prstGeom prst="rect">
-            <a:avLst/>
-          </a:prstGeom>
-          <a:noFill/>
-          <a:ln/>
-        </p:spPr>
-        <p:txBody>
-          <a:bodyPr wrap="square" lIns="0" tIns="0" rIns="0" bIns="0" rtlCol="0" anchor="ctr"/>
-          <a:lstStyle/>
-          <a:p>
-            <a:pPr algn="l" indent="0" marL="0">
+            <a:off x="10351008" y="3017520"/>
+            <a:ext cx="1124712" cy="1005840"/>
+          </a:xfrm>
+          <a:prstGeom prst="rect">
+            <a:avLst/>
+          </a:prstGeom>
+          <a:noFill/>
+          <a:ln/>
+        </p:spPr>
+        <p:txBody>
+          <a:bodyPr wrap="square" lIns="0" tIns="0" rIns="0" bIns="0" rtlCol="0" anchor="ctr"/>
+          <a:lstStyle/>
+          <a:p>
+            <a:pPr algn="ctr" indent="0" marL="0">
               <a:lnSpc>
                 <a:spcPct val="98000"/>
               </a:lnSpc>
               <a:buNone/>
             </a:pPr>
             <a:r>
-              <a:rPr lang="en-US" sz="1300" b="1" dirty="0">
-                <a:solidFill>
-                  <a:srgbClr val="0E8385"/>
-                </a:solidFill>
-                <a:latin typeface="Calibri" pitchFamily="34" charset="0"/>
-                <a:ea typeface="Calibri" pitchFamily="34" charset="-122"/>
-                <a:cs typeface="Calibri" pitchFamily="34" charset="-120"/>
-              </a:rPr>
-              <a:t>0.87 (0.76–0.98)</a:t>
-            </a:r>
-            <a:endParaRPr lang="en-US" sz="1300" dirty="0"/>
-          </a:p>
-        </p:txBody>
-      </p:sp>
-      <p:sp>
-        <p:nvSpPr>
-          <p:cNvPr id="22" name="Shape 19"/>
-          <p:cNvSpPr/>
-          <p:nvPr/>
-        </p:nvSpPr>
-        <p:spPr>
-          <a:xfrm>
-            <a:off x="640080" y="4425696"/>
-            <a:ext cx="11055096" cy="0"/>
-          </a:xfrm>
-          <a:prstGeom prst="line">
-            <a:avLst/>
-          </a:prstGeom>
-          <a:noFill/>
-          <a:ln w="9525">
-            <a:solidFill>
-              <a:srgbClr val="CFDDDD"/>
-            </a:solidFill>
-            <a:prstDash val="solid"/>
-          </a:ln>
-        </p:spPr>
+              <a:rPr lang="en-US" sz="1250" dirty="0">
+                <a:solidFill>
+                  <a:srgbClr val="13212A"/>
+                </a:solidFill>
+                <a:latin typeface="Calibri" pitchFamily="34" charset="0"/>
+                <a:ea typeface="Calibri" pitchFamily="34" charset="-122"/>
+                <a:cs typeface="Calibri" pitchFamily="34" charset="-120"/>
+              </a:rPr>
+              <a:t>0.0002</a:t>
+            </a:r>
+            <a:endParaRPr lang="en-US" sz="1250" dirty="0"/>
+          </a:p>
+        </p:txBody>
+      </p:sp>
+      <p:sp>
+        <p:nvSpPr>
+          <p:cNvPr id="22" name="Text 19"/>
+          <p:cNvSpPr/>
+          <p:nvPr/>
+        </p:nvSpPr>
+        <p:spPr>
+          <a:xfrm>
+            <a:off x="640080" y="4297680"/>
+            <a:ext cx="10908792" cy="640080"/>
+          </a:xfrm>
+          <a:prstGeom prst="rect">
+            <a:avLst/>
+          </a:prstGeom>
+          <a:noFill/>
+          <a:ln/>
+        </p:spPr>
+        <p:txBody>
+          <a:bodyPr wrap="square" lIns="0" tIns="0" rIns="0" bIns="0" rtlCol="0" anchor="ctr"/>
+          <a:lstStyle/>
+          <a:p>
+            <a:pPr indent="0" marL="0">
+              <a:lnSpc>
+                <a:spcPct val="115000"/>
+              </a:lnSpc>
+              <a:buNone/>
+            </a:pPr>
+            <a:r>
+              <a:rPr lang="en-US" sz="1500" i="1" dirty="0">
+                <a:solidFill>
+                  <a:srgbClr val="13212A"/>
+                </a:solidFill>
+                <a:latin typeface="Calibri" pitchFamily="34" charset="0"/>
+                <a:ea typeface="Calibri" pitchFamily="34" charset="-122"/>
+                <a:cs typeface="Calibri" pitchFamily="34" charset="-120"/>
+              </a:rPr>
+              <a:t>Consistent kidney and cardiovascular benefit, but every one of these patients had type 2 diabetes. FIND-CKD asks whether it carries over to CKD without diabetes.</a:t>
+            </a:r>
+            <a:endParaRPr lang="en-US" sz="1500" dirty="0"/>
+          </a:p>
+        </p:txBody>
       </p:sp>
       <p:sp>
         <p:nvSpPr>
@@ -24152,228 +23858,40 @@
         </p:nvSpPr>
         <p:spPr>
           <a:xfrm>
-            <a:off x="749808" y="3511296"/>
-            <a:ext cx="2468880" cy="914400"/>
-          </a:xfrm>
-          <a:prstGeom prst="rect">
-            <a:avLst/>
-          </a:prstGeom>
-          <a:noFill/>
-          <a:ln/>
-        </p:spPr>
-        <p:txBody>
-          <a:bodyPr wrap="square" lIns="0" tIns="0" rIns="0" bIns="0" rtlCol="0" anchor="ctr"/>
-          <a:lstStyle/>
-          <a:p>
-            <a:pPr algn="l" indent="0" marL="0">
-              <a:lnSpc>
-                <a:spcPct val="98000"/>
-              </a:lnSpc>
-              <a:buNone/>
-            </a:pPr>
-            <a:r>
-              <a:rPr lang="en-US" sz="1300" b="1" dirty="0">
-                <a:solidFill>
-                  <a:srgbClr val="0F3446"/>
-                </a:solidFill>
-                <a:latin typeface="Calibri" pitchFamily="34" charset="0"/>
-                <a:ea typeface="Calibri" pitchFamily="34" charset="-122"/>
-                <a:cs typeface="Calibri" pitchFamily="34" charset="-120"/>
-              </a:rPr>
-              <a:t>FIDELITY (2022)</a:t>
-            </a:r>
-            <a:endParaRPr lang="en-US" sz="1300" dirty="0"/>
+            <a:off x="640080" y="6291072"/>
+            <a:ext cx="9144000" cy="201168"/>
+          </a:xfrm>
+          <a:prstGeom prst="rect">
+            <a:avLst/>
+          </a:prstGeom>
+          <a:noFill/>
+          <a:ln/>
+        </p:spPr>
+        <p:txBody>
+          <a:bodyPr wrap="square" lIns="0" tIns="0" rIns="0" bIns="0" rtlCol="0" anchor="ctr"/>
+          <a:lstStyle/>
+          <a:p>
+            <a:pPr indent="0" marL="0">
+              <a:buNone/>
+            </a:pPr>
+            <a:r>
+              <a:rPr lang="en-US" sz="850" i="1" dirty="0">
+                <a:solidFill>
+                  <a:srgbClr val="4E5E66"/>
+                </a:solidFill>
+                <a:latin typeface="Calibri" pitchFamily="34" charset="0"/>
+                <a:ea typeface="Calibri" pitchFamily="34" charset="-122"/>
+                <a:cs typeface="Calibri" pitchFamily="34" charset="-120"/>
+              </a:rPr>
+              <a:t>FIDELITY: Agarwal et al., Eur Heart J 2022 (ehab777). Same ≥57% kidney definition as FIND-CKD.</a:t>
+            </a:r>
+            <a:endParaRPr lang="en-US" sz="850" dirty="0"/>
           </a:p>
         </p:txBody>
       </p:sp>
       <p:sp>
         <p:nvSpPr>
           <p:cNvPr id="24" name="Text 21"/>
-          <p:cNvSpPr/>
-          <p:nvPr/>
-        </p:nvSpPr>
-        <p:spPr>
-          <a:xfrm>
-            <a:off x="3401568" y="3511296"/>
-            <a:ext cx="3017520" cy="914400"/>
-          </a:xfrm>
-          <a:prstGeom prst="rect">
-            <a:avLst/>
-          </a:prstGeom>
-          <a:noFill/>
-          <a:ln/>
-        </p:spPr>
-        <p:txBody>
-          <a:bodyPr wrap="square" lIns="0" tIns="0" rIns="0" bIns="0" rtlCol="0" anchor="ctr"/>
-          <a:lstStyle/>
-          <a:p>
-            <a:pPr algn="l" indent="0" marL="0">
-              <a:lnSpc>
-                <a:spcPct val="98000"/>
-              </a:lnSpc>
-              <a:buNone/>
-            </a:pPr>
-            <a:r>
-              <a:rPr lang="en-US" sz="1300" dirty="0">
-                <a:solidFill>
-                  <a:srgbClr val="13212A"/>
-                </a:solidFill>
-                <a:latin typeface="Calibri" pitchFamily="34" charset="0"/>
-                <a:ea typeface="Calibri" pitchFamily="34" charset="-122"/>
-                <a:cs typeface="Calibri" pitchFamily="34" charset="-120"/>
-              </a:rPr>
-              <a:t>Pre-specified pooling; N=13,026</a:t>
-            </a:r>
-            <a:endParaRPr lang="en-US" sz="1300" dirty="0"/>
-          </a:p>
-        </p:txBody>
-      </p:sp>
-      <p:sp>
-        <p:nvSpPr>
-          <p:cNvPr id="25" name="Text 22"/>
-          <p:cNvSpPr/>
-          <p:nvPr/>
-        </p:nvSpPr>
-        <p:spPr>
-          <a:xfrm>
-            <a:off x="6601968" y="3511296"/>
-            <a:ext cx="2926080" cy="914400"/>
-          </a:xfrm>
-          <a:prstGeom prst="rect">
-            <a:avLst/>
-          </a:prstGeom>
-          <a:noFill/>
-          <a:ln/>
-        </p:spPr>
-        <p:txBody>
-          <a:bodyPr wrap="square" lIns="0" tIns="0" rIns="0" bIns="0" rtlCol="0" anchor="ctr"/>
-          <a:lstStyle/>
-          <a:p>
-            <a:pPr algn="l" indent="0" marL="0">
-              <a:lnSpc>
-                <a:spcPct val="98000"/>
-              </a:lnSpc>
-              <a:buNone/>
-            </a:pPr>
-            <a:r>
-              <a:rPr lang="en-US" sz="1300" dirty="0">
-                <a:solidFill>
-                  <a:srgbClr val="13212A"/>
-                </a:solidFill>
-                <a:latin typeface="Calibri" pitchFamily="34" charset="0"/>
-                <a:ea typeface="Calibri" pitchFamily="34" charset="-122"/>
-                <a:cs typeface="Calibri" pitchFamily="34" charset="-120"/>
-              </a:rPr>
-              <a:t>CV composite / kidney composite (≥57% decline)</a:t>
-            </a:r>
-            <a:endParaRPr lang="en-US" sz="1300" dirty="0"/>
-          </a:p>
-        </p:txBody>
-      </p:sp>
-      <p:sp>
-        <p:nvSpPr>
-          <p:cNvPr id="26" name="Text 23"/>
-          <p:cNvSpPr/>
-          <p:nvPr/>
-        </p:nvSpPr>
-        <p:spPr>
-          <a:xfrm>
-            <a:off x="9710928" y="3511296"/>
-            <a:ext cx="1911096" cy="914400"/>
-          </a:xfrm>
-          <a:prstGeom prst="rect">
-            <a:avLst/>
-          </a:prstGeom>
-          <a:noFill/>
-          <a:ln/>
-        </p:spPr>
-        <p:txBody>
-          <a:bodyPr wrap="square" lIns="0" tIns="0" rIns="0" bIns="0" rtlCol="0" anchor="ctr"/>
-          <a:lstStyle/>
-          <a:p>
-            <a:pPr algn="l" indent="0" marL="0">
-              <a:lnSpc>
-                <a:spcPct val="98000"/>
-              </a:lnSpc>
-              <a:buNone/>
-            </a:pPr>
-            <a:r>
-              <a:rPr lang="en-US" sz="1300" b="1" dirty="0">
-                <a:solidFill>
-                  <a:srgbClr val="0E8385"/>
-                </a:solidFill>
-                <a:latin typeface="Calibri" pitchFamily="34" charset="0"/>
-                <a:ea typeface="Calibri" pitchFamily="34" charset="-122"/>
-                <a:cs typeface="Calibri" pitchFamily="34" charset="-120"/>
-              </a:rPr>
-              <a:t>CV 0.86 (0.78–0.95)</a:t>
-            </a:r>
-            <a:endParaRPr lang="en-US" sz="1300" dirty="0"/>
-          </a:p>
-          <a:p>
-            <a:pPr algn="l" indent="0" marL="0">
-              <a:lnSpc>
-                <a:spcPct val="98000"/>
-              </a:lnSpc>
-              <a:buNone/>
-            </a:pPr>
-            <a:r>
-              <a:rPr lang="en-US" sz="1300" b="1" dirty="0">
-                <a:solidFill>
-                  <a:srgbClr val="0E8385"/>
-                </a:solidFill>
-                <a:latin typeface="Calibri" pitchFamily="34" charset="0"/>
-                <a:ea typeface="Calibri" pitchFamily="34" charset="-122"/>
-                <a:cs typeface="Calibri" pitchFamily="34" charset="-120"/>
-              </a:rPr>
-              <a:t>Kidney 0.77 (0.67–0.88)</a:t>
-            </a:r>
-            <a:endParaRPr lang="en-US" sz="1300" dirty="0"/>
-          </a:p>
-        </p:txBody>
-      </p:sp>
-      <p:sp>
-        <p:nvSpPr>
-          <p:cNvPr id="27" name="Text 24"/>
-          <p:cNvSpPr/>
-          <p:nvPr/>
-        </p:nvSpPr>
-        <p:spPr>
-          <a:xfrm>
-            <a:off x="640080" y="4654296"/>
-            <a:ext cx="10908792" cy="457200"/>
-          </a:xfrm>
-          <a:prstGeom prst="rect">
-            <a:avLst/>
-          </a:prstGeom>
-          <a:noFill/>
-          <a:ln/>
-        </p:spPr>
-        <p:txBody>
-          <a:bodyPr wrap="square" lIns="0" tIns="0" rIns="0" bIns="0" rtlCol="0" anchor="ctr"/>
-          <a:lstStyle/>
-          <a:p>
-            <a:pPr indent="0" marL="0">
-              <a:buNone/>
-            </a:pPr>
-            <a:r>
-              <a:rPr lang="en-US" sz="1500" i="1" dirty="0">
-                <a:solidFill>
-                  <a:srgbClr val="13212A"/>
-                </a:solidFill>
-                <a:latin typeface="Calibri" pitchFamily="34" charset="0"/>
-                <a:ea typeface="Calibri" pitchFamily="34" charset="-122"/>
-                <a:cs typeface="Calibri" pitchFamily="34" charset="-120"/>
-              </a:rPr>
-              <a:t>Consistent kidney and cardiovascular benefit, and a clear effect on eGFR slope, but only in diabetic CKD.</a:t>
-            </a:r>
-            <a:endParaRPr lang="en-US" sz="1500" dirty="0"/>
-          </a:p>
-        </p:txBody>
-      </p:sp>
-      <p:sp>
-        <p:nvSpPr>
-          <p:cNvPr id="28" name="Text 25"/>
           <p:cNvSpPr/>
           <p:nvPr/>
         </p:nvSpPr>
@@ -24426,7 +23944,7 @@
       </p:sp>
       <p:sp>
         <p:nvSpPr>
-          <p:cNvPr id="29" name="Text 26"/>
+          <p:cNvPr id="25" name="Text 22"/>
           <p:cNvSpPr/>
           <p:nvPr/>
         </p:nvSpPr>

</xml_diff>

<commit_message>
Use the article's original Figure 1B and Figure 2
Replaced the rebuilt slope-decomposition bars with the article's original
Figure 1B, and the custom subgroup forest with the original Figure 2, both
cited. All four figures that exist in the paper (1A, 1B, 2, 3) are now the
originals; the hyperkalemia bar chart stays as a visualization of Table 2,
which has no corresponding figure.

Co-Authored-By: Claude Opus 4.8 <noreply@anthropic.com>
Claude-Session: https://claude.ai/code/session_016WM8gpgPPTpUY1fDjELfFT
</commit_message>
<xml_diff>
--- a/FIND-CKD.pptx
+++ b/FIND-CKD.pptx
@@ -137,387 +137,6 @@
 </file>
 
 <file path=ppt/charts/chart1.xml><?xml version="1.0" encoding="utf-8"?>
-<c:chartSpace xmlns:c="http://schemas.openxmlformats.org/drawingml/2006/chart" xmlns:a="http://schemas.openxmlformats.org/drawingml/2006/main" xmlns:r="http://schemas.openxmlformats.org/officeDocument/2006/relationships">
-  <c:date1904 val="0"/>
-  <c:roundedCorners val="1"/>
-  <c:chart>
-    <c:autoTitleDeleted val="1"/>
-    <c:plotArea>
-      <c:layout/>
-      <c:barChart>
-        <c:barDir val="col"/>
-        <c:grouping val="clustered"/>
-        <c:varyColors val="0"/>
-        <c:ser>
-          <c:idx val="0"/>
-          <c:order val="0"/>
-          <c:tx>
-            <c:strRef>
-              <c:f>Sheet1!$B$1</c:f>
-              <c:strCache>
-                <c:ptCount val="1"/>
-                <c:pt idx="0">
-                  <c:v>Finerenone</c:v>
-                </c:pt>
-              </c:strCache>
-            </c:strRef>
-          </c:tx>
-          <c:spPr>
-            <a:solidFill>
-              <a:srgbClr val="12A3A6"/>
-            </a:solidFill>
-            <a:effectLst/>
-          </c:spPr>
-          <c:invertIfNegative val="0"/>
-          <c:dLbls>
-            <c:numFmt formatCode="0.0" sourceLinked="0"/>
-            <c:txPr>
-              <a:bodyPr/>
-              <a:lstStyle/>
-              <a:p>
-                <a:pPr>
-                  <a:defRPr b="1" i="0" strike="noStrike" sz="1200" u="none">
-                    <a:solidFill>
-                      <a:srgbClr val="13212A"/>
-                    </a:solidFill>
-                    <a:latin typeface="Calibri"/>
-                  </a:defRPr>
-                </a:pPr>
-              </a:p>
-            </c:txPr>
-            <c:showLegendKey val="0"/>
-            <c:showVal val="1"/>
-            <c:showCatName val="0"/>
-            <c:showSerName val="0"/>
-            <c:showPercent val="0"/>
-            <c:showBubbleSize val="0"/>
-            <c:showLeaderLines val="0"/>
-          </c:dLbls>
-          <c:cat>
-            <c:multiLvlStrRef>
-              <c:f>Sheet1!$A$2:$A$4</c:f>
-              <c:multiLvlStrCache>
-                <c:ptCount val="3"/>
-                <c:lvl>
-                  <c:pt idx="0">
-                    <c:v>Total slope
-(0–32 mo)</c:v>
-                  </c:pt>
-                  <c:pt idx="1">
-                    <c:v>Acute
-(0–3 mo)</c:v>
-                  </c:pt>
-                  <c:pt idx="2">
-                    <c:v>Chronic
-(3 mo – EOT)</c:v>
-                  </c:pt>
-                </c:lvl>
-              </c:multiLvlStrCache>
-            </c:multiLvlStrRef>
-          </c:cat>
-          <c:val>
-            <c:numRef>
-              <c:f>Sheet1!$B$2:$B$4</c:f>
-              <c:numCache>
-                <c:formatCode>General</c:formatCode>
-                <c:ptCount val="3"/>
-                <c:pt idx="0">
-                  <c:v>-3.3</c:v>
-                </c:pt>
-                <c:pt idx="1">
-                  <c:v>-2</c:v>
-                </c:pt>
-                <c:pt idx="2">
-                  <c:v>-2.9</c:v>
-                </c:pt>
-              </c:numCache>
-            </c:numRef>
-          </c:val>
-        </c:ser>
-        <c:ser>
-          <c:idx val="1"/>
-          <c:order val="1"/>
-          <c:tx>
-            <c:strRef>
-              <c:f>Sheet1!$C$1</c:f>
-              <c:strCache>
-                <c:ptCount val="1"/>
-                <c:pt idx="0">
-                  <c:v>Placebo</c:v>
-                </c:pt>
-              </c:strCache>
-            </c:strRef>
-          </c:tx>
-          <c:spPr>
-            <a:solidFill>
-              <a:srgbClr val="9AA7AD"/>
-            </a:solidFill>
-            <a:effectLst/>
-          </c:spPr>
-          <c:invertIfNegative val="0"/>
-          <c:dLbls>
-            <c:numFmt formatCode="0.0" sourceLinked="0"/>
-            <c:txPr>
-              <a:bodyPr/>
-              <a:lstStyle/>
-              <a:p>
-                <a:pPr>
-                  <a:defRPr b="1" i="0" strike="noStrike" sz="1200" u="none">
-                    <a:solidFill>
-                      <a:srgbClr val="13212A"/>
-                    </a:solidFill>
-                    <a:latin typeface="Calibri"/>
-                  </a:defRPr>
-                </a:pPr>
-              </a:p>
-            </c:txPr>
-            <c:showLegendKey val="0"/>
-            <c:showVal val="1"/>
-            <c:showCatName val="0"/>
-            <c:showSerName val="0"/>
-            <c:showPercent val="0"/>
-            <c:showBubbleSize val="0"/>
-            <c:showLeaderLines val="0"/>
-          </c:dLbls>
-          <c:cat>
-            <c:multiLvlStrRef>
-              <c:f>Sheet1!$A$2:$A$4</c:f>
-              <c:multiLvlStrCache>
-                <c:ptCount val="3"/>
-                <c:lvl>
-                  <c:pt idx="0">
-                    <c:v>Total slope
-(0–32 mo)</c:v>
-                  </c:pt>
-                  <c:pt idx="1">
-                    <c:v>Acute
-(0–3 mo)</c:v>
-                  </c:pt>
-                  <c:pt idx="2">
-                    <c:v>Chronic
-(3 mo – EOT)</c:v>
-                  </c:pt>
-                </c:lvl>
-              </c:multiLvlStrCache>
-            </c:multiLvlStrRef>
-          </c:cat>
-          <c:val>
-            <c:numRef>
-              <c:f>Sheet1!$C$2:$C$4</c:f>
-              <c:numCache>
-                <c:formatCode>General</c:formatCode>
-                <c:ptCount val="3"/>
-                <c:pt idx="0">
-                  <c:v>-4</c:v>
-                </c:pt>
-                <c:pt idx="1">
-                  <c:v>-0.8</c:v>
-                </c:pt>
-                <c:pt idx="2">
-                  <c:v>-4.1</c:v>
-                </c:pt>
-              </c:numCache>
-            </c:numRef>
-          </c:val>
-        </c:ser>
-        <c:dLbls>
-          <c:numFmt formatCode="0.0" sourceLinked="0"/>
-          <c:txPr>
-            <a:bodyPr/>
-            <a:lstStyle/>
-            <a:p>
-              <a:pPr>
-                <a:defRPr b="1" i="0" strike="noStrike" sz="1200" u="none">
-                  <a:solidFill>
-                    <a:srgbClr val="13212A"/>
-                  </a:solidFill>
-                  <a:latin typeface="Calibri"/>
-                </a:defRPr>
-              </a:pPr>
-            </a:p>
-          </c:txPr>
-          <c:showLegendKey val="0"/>
-          <c:showVal val="1"/>
-          <c:showCatName val="0"/>
-          <c:showSerName val="0"/>
-          <c:showPercent val="0"/>
-          <c:showBubbleSize val="0"/>
-          <c:showLeaderLines val="0"/>
-        </c:dLbls>
-        <c:gapWidth val="60"/>
-        <c:overlap val="0"/>
-        <c:axId val="2094734554"/>
-        <c:axId val="2094734552"/>
-        <c:axId val="2094734556"/>
-      </c:barChart>
-      <c:catAx>
-        <c:axId val="2094734554"/>
-        <c:scaling>
-          <c:orientation val="minMax"/>
-        </c:scaling>
-        <c:delete val="0"/>
-        <c:axPos val="b"/>
-        <c:numFmt formatCode="General" sourceLinked="1"/>
-        <c:majorTickMark val="out"/>
-        <c:minorTickMark val="none"/>
-        <c:tickLblPos val="low"/>
-        <c:spPr>
-          <a:ln w="12700" cap="flat">
-            <a:solidFill>
-              <a:srgbClr val="888888"/>
-            </a:solidFill>
-            <a:prstDash val="solid"/>
-            <a:round/>
-          </a:ln>
-        </c:spPr>
-        <c:txPr>
-          <a:bodyPr/>
-          <a:lstStyle/>
-          <a:p>
-            <a:pPr>
-              <a:defRPr sz="1100" b="0" i="0" u="none" strike="noStrike">
-                <a:solidFill>
-                  <a:srgbClr val="13212A"/>
-                </a:solidFill>
-                <a:latin typeface="Calibri"/>
-              </a:defRPr>
-            </a:pPr>
-            <a:endParaRPr lang="en-US"/>
-          </a:p>
-        </c:txPr>
-        <c:crossAx val="2094734552"/>
-        <c:crosses val="autoZero"/>
-        <c:auto val="1"/>
-        <c:lblAlgn val="ctr"/>
-        <c:noMultiLvlLbl val="1"/>
-      </c:catAx>
-      <c:valAx>
-        <c:axId val="2094734552"/>
-        <c:scaling>
-          <c:orientation val="minMax"/>
-          <c:max val="0"/>
-          <c:min val="-5"/>
-        </c:scaling>
-        <c:delete val="0"/>
-        <c:axPos val="l"/>
-        <c:majorGridlines>
-          <c:spPr>
-            <a:ln w="12700" cap="flat">
-              <a:solidFill>
-                <a:srgbClr val="ECF2F2"/>
-              </a:solidFill>
-              <a:prstDash val="solid"/>
-              <a:round/>
-            </a:ln>
-          </c:spPr>
-        </c:majorGridlines>
-        <c:title>
-          <c:tx>
-            <c:rich>
-              <a:bodyPr/>
-              <a:lstStyle/>
-              <a:p>
-                <a:pPr>
-                  <a:defRPr sz="1100" b="0" i="0" u="none" strike="noStrike">
-                    <a:solidFill>
-                      <a:srgbClr val="4E5E66"/>
-                    </a:solidFill>
-                    <a:latin typeface="Arial"/>
-                  </a:defRPr>
-                </a:pPr>
-                <a:r>
-                  <a:rPr sz="1100" b="0" i="0" u="none" strike="noStrike">
-                    <a:solidFill>
-                      <a:srgbClr val="4E5E66"/>
-                    </a:solidFill>
-                    <a:latin typeface="Arial"/>
-                  </a:rPr>
-                  <a:t>eGFR slope (ml/min/1.73 m² per year)</a:t>
-                </a:r>
-              </a:p>
-            </c:rich>
-          </c:tx>
-          <c:layout/>
-          <c:overlay val="0"/>
-        </c:title>
-        <c:numFmt formatCode="General" sourceLinked="0"/>
-        <c:majorTickMark val="out"/>
-        <c:minorTickMark val="none"/>
-        <c:tickLblPos val="nextTo"/>
-        <c:spPr>
-          <a:ln w="12700" cap="flat">
-            <a:solidFill>
-              <a:srgbClr val="888888"/>
-            </a:solidFill>
-            <a:prstDash val="solid"/>
-            <a:round/>
-          </a:ln>
-        </c:spPr>
-        <c:txPr>
-          <a:bodyPr/>
-          <a:lstStyle/>
-          <a:p>
-            <a:pPr>
-              <a:defRPr sz="1000" b="0" i="0" u="none" strike="noStrike">
-                <a:solidFill>
-                  <a:srgbClr val="4E5E66"/>
-                </a:solidFill>
-                <a:latin typeface="Calibri"/>
-              </a:defRPr>
-            </a:pPr>
-            <a:endParaRPr lang="en-US"/>
-          </a:p>
-        </c:txPr>
-        <c:crossAx val="2094734554"/>
-        <c:crosses val="autoZero"/>
-        <c:crossBetween val="between"/>
-        <c:majorUnit val="1"/>
-      </c:valAx>
-      <c:spPr>
-        <a:noFill/>
-        <a:ln>
-          <a:noFill/>
-        </a:ln>
-        <a:effectLst/>
-      </c:spPr>
-    </c:plotArea>
-    <c:legend>
-      <c:legendPos val="t"/>
-      <c:overlay val="0"/>
-      <c:txPr>
-        <a:bodyPr/>
-        <a:lstStyle/>
-        <a:p>
-          <a:pPr>
-            <a:defRPr sz="1200">
-              <a:solidFill>
-                <a:srgbClr val="13212A"/>
-              </a:solidFill>
-              <a:latin typeface="Calibri"/>
-              <a:cs typeface="Calibri"/>
-            </a:defRPr>
-          </a:pPr>
-          <a:endParaRPr lang="en-US"/>
-        </a:p>
-      </c:txPr>
-    </c:legend>
-    <c:plotVisOnly val="1"/>
-    <c:dispBlanksAs val="span"/>
-  </c:chart>
-  <c:spPr>
-    <a:noFill/>
-    <a:ln>
-      <a:noFill/>
-    </a:ln>
-    <a:effectLst/>
-  </c:spPr>
-  <c:externalData r:id="rId1">
-    <c:autoUpdate val="0"/>
-  </c:externalData>
-</c:chartSpace>
-</file>
-
-<file path=ppt/charts/chart2.xml><?xml version="1.0" encoding="utf-8"?>
 <c:chartSpace xmlns:c="http://schemas.openxmlformats.org/drawingml/2006/chart" xmlns:a="http://schemas.openxmlformats.org/drawingml/2006/main" xmlns:r="http://schemas.openxmlformats.org/officeDocument/2006/relationships">
   <c:date1904 val="0"/>
   <c:roundedCorners val="1"/>
@@ -10603,660 +10222,33 @@
           </a:p>
         </p:txBody>
       </p:sp>
-      <p:graphicFrame>
-        <p:nvGraphicFramePr>
-          <p:cNvPr id="7" name="Chart 0" descr=""/>
-          <p:cNvGraphicFramePr/>
-          <p:nvPr/>
-        </p:nvGraphicFramePr>
-        <p:xfrm>
-          <a:off x="640080" y="1554480"/>
-          <a:ext cx="7040880" cy="4389120"/>
-        </p:xfrm>
-        <a:graphic xmlns:a="http://schemas.openxmlformats.org/drawingml/2006/main">
-          <a:graphicData uri="http://schemas.openxmlformats.org/drawingml/2006/chart">
-            <c:chart xmlns:c="http://schemas.openxmlformats.org/drawingml/2006/chart" r:id="rId2"/>
-          </a:graphicData>
-        </a:graphic>
-      </p:graphicFrame>
-      <p:sp>
-        <p:nvSpPr>
-          <p:cNvPr id="8" name="Shape 4"/>
-          <p:cNvSpPr/>
-          <p:nvPr/>
-        </p:nvSpPr>
-        <p:spPr>
-          <a:xfrm>
-            <a:off x="7955280" y="1737360"/>
-            <a:ext cx="3593592" cy="420624"/>
-          </a:xfrm>
-          <a:prstGeom prst="rect">
-            <a:avLst/>
-          </a:prstGeom>
-          <a:solidFill>
-            <a:srgbClr val="0F3446"/>
-          </a:solidFill>
-          <a:ln/>
-        </p:spPr>
-      </p:sp>
-      <p:sp>
-        <p:nvSpPr>
-          <p:cNvPr id="9" name="Text 5"/>
-          <p:cNvSpPr/>
-          <p:nvPr/>
-        </p:nvSpPr>
-        <p:spPr>
-          <a:xfrm>
-            <a:off x="8065008" y="1737360"/>
-            <a:ext cx="1326429" cy="420624"/>
-          </a:xfrm>
-          <a:prstGeom prst="rect">
-            <a:avLst/>
-          </a:prstGeom>
-          <a:noFill/>
-          <a:ln/>
-        </p:spPr>
-        <p:txBody>
-          <a:bodyPr wrap="square" lIns="0" tIns="0" rIns="0" bIns="0" rtlCol="0" anchor="ctr"/>
-          <a:lstStyle/>
-          <a:p>
-            <a:pPr algn="l" indent="0" marL="0">
-              <a:lnSpc>
-                <a:spcPct val="98000"/>
-              </a:lnSpc>
-              <a:buNone/>
-            </a:pPr>
-            <a:r>
-              <a:rPr lang="en-US" sz="1300" b="1" dirty="0">
-                <a:solidFill>
-                  <a:srgbClr val="FFFFFF"/>
-                </a:solidFill>
-                <a:latin typeface="Calibri" pitchFamily="34" charset="0"/>
-                <a:ea typeface="Calibri" pitchFamily="34" charset="-122"/>
-                <a:cs typeface="Calibri" pitchFamily="34" charset="-120"/>
-              </a:rPr>
-              <a:t>Difference</a:t>
-            </a:r>
-            <a:endParaRPr lang="en-US" sz="1300" dirty="0"/>
-          </a:p>
-        </p:txBody>
-      </p:sp>
-      <p:sp>
-        <p:nvSpPr>
-          <p:cNvPr id="10" name="Text 6"/>
-          <p:cNvSpPr/>
-          <p:nvPr/>
-        </p:nvSpPr>
-        <p:spPr>
-          <a:xfrm>
-            <a:off x="9574317" y="1737360"/>
-            <a:ext cx="823326" cy="420624"/>
-          </a:xfrm>
-          <a:prstGeom prst="rect">
-            <a:avLst/>
-          </a:prstGeom>
-          <a:noFill/>
-          <a:ln/>
-        </p:spPr>
-        <p:txBody>
-          <a:bodyPr wrap="square" lIns="0" tIns="0" rIns="0" bIns="0" rtlCol="0" anchor="ctr"/>
-          <a:lstStyle/>
-          <a:p>
-            <a:pPr algn="ctr" indent="0" marL="0">
-              <a:lnSpc>
-                <a:spcPct val="98000"/>
-              </a:lnSpc>
-              <a:buNone/>
-            </a:pPr>
-            <a:r>
-              <a:rPr lang="en-US" sz="1300" b="1" dirty="0">
-                <a:solidFill>
-                  <a:srgbClr val="FFFFFF"/>
-                </a:solidFill>
-                <a:latin typeface="Calibri" pitchFamily="34" charset="0"/>
-                <a:ea typeface="Calibri" pitchFamily="34" charset="-122"/>
-                <a:cs typeface="Calibri" pitchFamily="34" charset="-120"/>
-              </a:rPr>
-              <a:t>Estimate</a:t>
-            </a:r>
-            <a:endParaRPr lang="en-US" sz="1300" dirty="0"/>
-          </a:p>
-        </p:txBody>
-      </p:sp>
-      <p:sp>
-        <p:nvSpPr>
-          <p:cNvPr id="11" name="Text 7"/>
-          <p:cNvSpPr/>
-          <p:nvPr/>
-        </p:nvSpPr>
-        <p:spPr>
-          <a:xfrm>
-            <a:off x="10580522" y="1737360"/>
-            <a:ext cx="895198" cy="420624"/>
-          </a:xfrm>
-          <a:prstGeom prst="rect">
-            <a:avLst/>
-          </a:prstGeom>
-          <a:noFill/>
-          <a:ln/>
-        </p:spPr>
-        <p:txBody>
-          <a:bodyPr wrap="square" lIns="0" tIns="0" rIns="0" bIns="0" rtlCol="0" anchor="ctr"/>
-          <a:lstStyle/>
-          <a:p>
-            <a:pPr algn="ctr" indent="0" marL="0">
-              <a:lnSpc>
-                <a:spcPct val="98000"/>
-              </a:lnSpc>
-              <a:buNone/>
-            </a:pPr>
-            <a:r>
-              <a:rPr lang="en-US" sz="1300" b="1" dirty="0">
-                <a:solidFill>
-                  <a:srgbClr val="FFFFFF"/>
-                </a:solidFill>
-                <a:latin typeface="Calibri" pitchFamily="34" charset="0"/>
-                <a:ea typeface="Calibri" pitchFamily="34" charset="-122"/>
-                <a:cs typeface="Calibri" pitchFamily="34" charset="-120"/>
-              </a:rPr>
-              <a:t>95% CI</a:t>
-            </a:r>
-            <a:endParaRPr lang="en-US" sz="1300" dirty="0"/>
-          </a:p>
-        </p:txBody>
-      </p:sp>
-      <p:sp>
-        <p:nvSpPr>
-          <p:cNvPr id="12" name="Shape 8"/>
-          <p:cNvSpPr/>
-          <p:nvPr/>
-        </p:nvSpPr>
-        <p:spPr>
-          <a:xfrm>
-            <a:off x="7955280" y="2706624"/>
-            <a:ext cx="3593592" cy="0"/>
-          </a:xfrm>
-          <a:prstGeom prst="line">
-            <a:avLst/>
-          </a:prstGeom>
-          <a:noFill/>
-          <a:ln w="9525">
-            <a:solidFill>
-              <a:srgbClr val="CFDDDD"/>
-            </a:solidFill>
-            <a:prstDash val="solid"/>
-          </a:ln>
-        </p:spPr>
-      </p:sp>
-      <p:sp>
-        <p:nvSpPr>
-          <p:cNvPr id="13" name="Text 9"/>
-          <p:cNvSpPr/>
-          <p:nvPr/>
-        </p:nvSpPr>
-        <p:spPr>
-          <a:xfrm>
-            <a:off x="8065008" y="2157984"/>
-            <a:ext cx="1326429" cy="548640"/>
-          </a:xfrm>
-          <a:prstGeom prst="rect">
-            <a:avLst/>
-          </a:prstGeom>
-          <a:noFill/>
-          <a:ln/>
-        </p:spPr>
-        <p:txBody>
-          <a:bodyPr wrap="square" lIns="0" tIns="0" rIns="0" bIns="0" rtlCol="0" anchor="ctr"/>
-          <a:lstStyle/>
-          <a:p>
-            <a:pPr algn="l" indent="0" marL="0">
-              <a:lnSpc>
-                <a:spcPct val="98000"/>
-              </a:lnSpc>
-              <a:buNone/>
-            </a:pPr>
-            <a:r>
-              <a:rPr lang="en-US" sz="1300" b="1" dirty="0">
-                <a:solidFill>
-                  <a:srgbClr val="0F3446"/>
-                </a:solidFill>
-                <a:latin typeface="Calibri" pitchFamily="34" charset="0"/>
-                <a:ea typeface="Calibri" pitchFamily="34" charset="-122"/>
-                <a:cs typeface="Calibri" pitchFamily="34" charset="-120"/>
-              </a:rPr>
-              <a:t>Total</a:t>
-            </a:r>
-            <a:endParaRPr lang="en-US" sz="1300" dirty="0"/>
-          </a:p>
-        </p:txBody>
-      </p:sp>
-      <p:sp>
-        <p:nvSpPr>
-          <p:cNvPr id="14" name="Text 10"/>
-          <p:cNvSpPr/>
-          <p:nvPr/>
-        </p:nvSpPr>
-        <p:spPr>
-          <a:xfrm>
-            <a:off x="9574317" y="2157984"/>
-            <a:ext cx="823326" cy="548640"/>
-          </a:xfrm>
-          <a:prstGeom prst="rect">
-            <a:avLst/>
-          </a:prstGeom>
-          <a:noFill/>
-          <a:ln/>
-        </p:spPr>
-        <p:txBody>
-          <a:bodyPr wrap="square" lIns="0" tIns="0" rIns="0" bIns="0" rtlCol="0" anchor="ctr"/>
-          <a:lstStyle/>
-          <a:p>
-            <a:pPr algn="ctr" indent="0" marL="0">
-              <a:lnSpc>
-                <a:spcPct val="98000"/>
-              </a:lnSpc>
-              <a:buNone/>
-            </a:pPr>
-            <a:r>
-              <a:rPr lang="en-US" sz="1300" b="1" dirty="0">
-                <a:solidFill>
-                  <a:srgbClr val="0E8385"/>
-                </a:solidFill>
-                <a:latin typeface="Calibri" pitchFamily="34" charset="0"/>
-                <a:ea typeface="Calibri" pitchFamily="34" charset="-122"/>
-                <a:cs typeface="Calibri" pitchFamily="34" charset="-120"/>
-              </a:rPr>
-              <a:t>+0.7</a:t>
-            </a:r>
-            <a:endParaRPr lang="en-US" sz="1300" dirty="0"/>
-          </a:p>
-        </p:txBody>
-      </p:sp>
-      <p:sp>
-        <p:nvSpPr>
-          <p:cNvPr id="15" name="Text 11"/>
-          <p:cNvSpPr/>
-          <p:nvPr/>
-        </p:nvSpPr>
-        <p:spPr>
-          <a:xfrm>
-            <a:off x="10580522" y="2157984"/>
-            <a:ext cx="895198" cy="548640"/>
-          </a:xfrm>
-          <a:prstGeom prst="rect">
-            <a:avLst/>
-          </a:prstGeom>
-          <a:noFill/>
-          <a:ln/>
-        </p:spPr>
-        <p:txBody>
-          <a:bodyPr wrap="square" lIns="0" tIns="0" rIns="0" bIns="0" rtlCol="0" anchor="ctr"/>
-          <a:lstStyle/>
-          <a:p>
-            <a:pPr algn="ctr" indent="0" marL="0">
-              <a:lnSpc>
-                <a:spcPct val="98000"/>
-              </a:lnSpc>
-              <a:buNone/>
-            </a:pPr>
-            <a:r>
-              <a:rPr lang="en-US" sz="1300" dirty="0">
-                <a:solidFill>
-                  <a:srgbClr val="13212A"/>
-                </a:solidFill>
-                <a:latin typeface="Calibri" pitchFamily="34" charset="0"/>
-                <a:ea typeface="Calibri" pitchFamily="34" charset="-122"/>
-                <a:cs typeface="Calibri" pitchFamily="34" charset="-120"/>
-              </a:rPr>
-              <a:t>0.3 to 1.1</a:t>
-            </a:r>
-            <a:endParaRPr lang="en-US" sz="1300" dirty="0"/>
-          </a:p>
-        </p:txBody>
-      </p:sp>
-      <p:sp>
-        <p:nvSpPr>
-          <p:cNvPr id="16" name="Shape 12"/>
-          <p:cNvSpPr/>
-          <p:nvPr/>
-        </p:nvSpPr>
-        <p:spPr>
-          <a:xfrm>
-            <a:off x="7955280" y="3255264"/>
-            <a:ext cx="3593592" cy="0"/>
-          </a:xfrm>
-          <a:prstGeom prst="line">
-            <a:avLst/>
-          </a:prstGeom>
-          <a:noFill/>
-          <a:ln w="9525">
-            <a:solidFill>
-              <a:srgbClr val="CFDDDD"/>
-            </a:solidFill>
-            <a:prstDash val="solid"/>
-          </a:ln>
-        </p:spPr>
-      </p:sp>
-      <p:sp>
-        <p:nvSpPr>
-          <p:cNvPr id="17" name="Text 13"/>
-          <p:cNvSpPr/>
-          <p:nvPr/>
-        </p:nvSpPr>
-        <p:spPr>
-          <a:xfrm>
-            <a:off x="8065008" y="2706624"/>
-            <a:ext cx="1326429" cy="548640"/>
-          </a:xfrm>
-          <a:prstGeom prst="rect">
-            <a:avLst/>
-          </a:prstGeom>
-          <a:noFill/>
-          <a:ln/>
-        </p:spPr>
-        <p:txBody>
-          <a:bodyPr wrap="square" lIns="0" tIns="0" rIns="0" bIns="0" rtlCol="0" anchor="ctr"/>
-          <a:lstStyle/>
-          <a:p>
-            <a:pPr algn="l" indent="0" marL="0">
-              <a:lnSpc>
-                <a:spcPct val="98000"/>
-              </a:lnSpc>
-              <a:buNone/>
-            </a:pPr>
-            <a:r>
-              <a:rPr lang="en-US" sz="1300" b="1" dirty="0">
-                <a:solidFill>
-                  <a:srgbClr val="0F3446"/>
-                </a:solidFill>
-                <a:latin typeface="Calibri" pitchFamily="34" charset="0"/>
-                <a:ea typeface="Calibri" pitchFamily="34" charset="-122"/>
-                <a:cs typeface="Calibri" pitchFamily="34" charset="-120"/>
-              </a:rPr>
-              <a:t>Acute (0–3 mo)</a:t>
-            </a:r>
-            <a:endParaRPr lang="en-US" sz="1300" dirty="0"/>
-          </a:p>
-        </p:txBody>
-      </p:sp>
-      <p:sp>
-        <p:nvSpPr>
-          <p:cNvPr id="18" name="Text 14"/>
-          <p:cNvSpPr/>
-          <p:nvPr/>
-        </p:nvSpPr>
-        <p:spPr>
-          <a:xfrm>
-            <a:off x="9574317" y="2706624"/>
-            <a:ext cx="823326" cy="548640"/>
-          </a:xfrm>
-          <a:prstGeom prst="rect">
-            <a:avLst/>
-          </a:prstGeom>
-          <a:noFill/>
-          <a:ln/>
-        </p:spPr>
-        <p:txBody>
-          <a:bodyPr wrap="square" lIns="0" tIns="0" rIns="0" bIns="0" rtlCol="0" anchor="ctr"/>
-          <a:lstStyle/>
-          <a:p>
-            <a:pPr algn="ctr" indent="0" marL="0">
-              <a:lnSpc>
-                <a:spcPct val="98000"/>
-              </a:lnSpc>
-              <a:buNone/>
-            </a:pPr>
-            <a:r>
-              <a:rPr lang="en-US" sz="1300" b="1" dirty="0">
-                <a:solidFill>
-                  <a:srgbClr val="0E8385"/>
-                </a:solidFill>
-                <a:latin typeface="Calibri" pitchFamily="34" charset="0"/>
-                <a:ea typeface="Calibri" pitchFamily="34" charset="-122"/>
-                <a:cs typeface="Calibri" pitchFamily="34" charset="-120"/>
-              </a:rPr>
-              <a:t>−1.2</a:t>
-            </a:r>
-            <a:endParaRPr lang="en-US" sz="1300" dirty="0"/>
-          </a:p>
-        </p:txBody>
-      </p:sp>
-      <p:sp>
-        <p:nvSpPr>
-          <p:cNvPr id="19" name="Text 15"/>
-          <p:cNvSpPr/>
-          <p:nvPr/>
-        </p:nvSpPr>
-        <p:spPr>
-          <a:xfrm>
-            <a:off x="10580522" y="2706624"/>
-            <a:ext cx="895198" cy="548640"/>
-          </a:xfrm>
-          <a:prstGeom prst="rect">
-            <a:avLst/>
-          </a:prstGeom>
-          <a:noFill/>
-          <a:ln/>
-        </p:spPr>
-        <p:txBody>
-          <a:bodyPr wrap="square" lIns="0" tIns="0" rIns="0" bIns="0" rtlCol="0" anchor="ctr"/>
-          <a:lstStyle/>
-          <a:p>
-            <a:pPr algn="ctr" indent="0" marL="0">
-              <a:lnSpc>
-                <a:spcPct val="98000"/>
-              </a:lnSpc>
-              <a:buNone/>
-            </a:pPr>
-            <a:r>
-              <a:rPr lang="en-US" sz="1300" dirty="0">
-                <a:solidFill>
-                  <a:srgbClr val="13212A"/>
-                </a:solidFill>
-                <a:latin typeface="Calibri" pitchFamily="34" charset="0"/>
-                <a:ea typeface="Calibri" pitchFamily="34" charset="-122"/>
-                <a:cs typeface="Calibri" pitchFamily="34" charset="-120"/>
-              </a:rPr>
-              <a:t>−1.7 to −0.6</a:t>
-            </a:r>
-            <a:endParaRPr lang="en-US" sz="1300" dirty="0"/>
-          </a:p>
-        </p:txBody>
-      </p:sp>
-      <p:sp>
-        <p:nvSpPr>
-          <p:cNvPr id="20" name="Shape 16"/>
-          <p:cNvSpPr/>
-          <p:nvPr/>
-        </p:nvSpPr>
-        <p:spPr>
-          <a:xfrm>
-            <a:off x="7955280" y="3803904"/>
-            <a:ext cx="3593592" cy="0"/>
-          </a:xfrm>
-          <a:prstGeom prst="line">
-            <a:avLst/>
-          </a:prstGeom>
-          <a:noFill/>
-          <a:ln w="9525">
-            <a:solidFill>
-              <a:srgbClr val="CFDDDD"/>
-            </a:solidFill>
-            <a:prstDash val="solid"/>
-          </a:ln>
-        </p:spPr>
-      </p:sp>
-      <p:sp>
-        <p:nvSpPr>
-          <p:cNvPr id="21" name="Text 17"/>
-          <p:cNvSpPr/>
-          <p:nvPr/>
-        </p:nvSpPr>
-        <p:spPr>
-          <a:xfrm>
-            <a:off x="8065008" y="3255264"/>
-            <a:ext cx="1326429" cy="548640"/>
-          </a:xfrm>
-          <a:prstGeom prst="rect">
-            <a:avLst/>
-          </a:prstGeom>
-          <a:noFill/>
-          <a:ln/>
-        </p:spPr>
-        <p:txBody>
-          <a:bodyPr wrap="square" lIns="0" tIns="0" rIns="0" bIns="0" rtlCol="0" anchor="ctr"/>
-          <a:lstStyle/>
-          <a:p>
-            <a:pPr algn="l" indent="0" marL="0">
-              <a:lnSpc>
-                <a:spcPct val="98000"/>
-              </a:lnSpc>
-              <a:buNone/>
-            </a:pPr>
-            <a:r>
-              <a:rPr lang="en-US" sz="1300" b="1" dirty="0">
-                <a:solidFill>
-                  <a:srgbClr val="0F3446"/>
-                </a:solidFill>
-                <a:latin typeface="Calibri" pitchFamily="34" charset="0"/>
-                <a:ea typeface="Calibri" pitchFamily="34" charset="-122"/>
-                <a:cs typeface="Calibri" pitchFamily="34" charset="-120"/>
-              </a:rPr>
-              <a:t>Chronic slope</a:t>
-            </a:r>
-            <a:endParaRPr lang="en-US" sz="1300" dirty="0"/>
-          </a:p>
-        </p:txBody>
-      </p:sp>
-      <p:sp>
-        <p:nvSpPr>
-          <p:cNvPr id="22" name="Text 18"/>
-          <p:cNvSpPr/>
-          <p:nvPr/>
-        </p:nvSpPr>
-        <p:spPr>
-          <a:xfrm>
-            <a:off x="9574317" y="3255264"/>
-            <a:ext cx="823326" cy="548640"/>
-          </a:xfrm>
-          <a:prstGeom prst="rect">
-            <a:avLst/>
-          </a:prstGeom>
-          <a:noFill/>
-          <a:ln/>
-        </p:spPr>
-        <p:txBody>
-          <a:bodyPr wrap="square" lIns="0" tIns="0" rIns="0" bIns="0" rtlCol="0" anchor="ctr"/>
-          <a:lstStyle/>
-          <a:p>
-            <a:pPr algn="ctr" indent="0" marL="0">
-              <a:lnSpc>
-                <a:spcPct val="98000"/>
-              </a:lnSpc>
-              <a:buNone/>
-            </a:pPr>
-            <a:r>
-              <a:rPr lang="en-US" sz="1300" b="1" dirty="0">
-                <a:solidFill>
-                  <a:srgbClr val="0E8385"/>
-                </a:solidFill>
-                <a:latin typeface="Calibri" pitchFamily="34" charset="0"/>
-                <a:ea typeface="Calibri" pitchFamily="34" charset="-122"/>
-                <a:cs typeface="Calibri" pitchFamily="34" charset="-120"/>
-              </a:rPr>
-              <a:t>+1.2</a:t>
-            </a:r>
-            <a:endParaRPr lang="en-US" sz="1300" dirty="0"/>
-          </a:p>
-        </p:txBody>
-      </p:sp>
-      <p:sp>
-        <p:nvSpPr>
-          <p:cNvPr id="23" name="Text 19"/>
-          <p:cNvSpPr/>
-          <p:nvPr/>
-        </p:nvSpPr>
-        <p:spPr>
-          <a:xfrm>
-            <a:off x="10580522" y="3255264"/>
-            <a:ext cx="895198" cy="548640"/>
-          </a:xfrm>
-          <a:prstGeom prst="rect">
-            <a:avLst/>
-          </a:prstGeom>
-          <a:noFill/>
-          <a:ln/>
-        </p:spPr>
-        <p:txBody>
-          <a:bodyPr wrap="square" lIns="0" tIns="0" rIns="0" bIns="0" rtlCol="0" anchor="ctr"/>
-          <a:lstStyle/>
-          <a:p>
-            <a:pPr algn="ctr" indent="0" marL="0">
-              <a:lnSpc>
-                <a:spcPct val="98000"/>
-              </a:lnSpc>
-              <a:buNone/>
-            </a:pPr>
-            <a:r>
-              <a:rPr lang="en-US" sz="1300" dirty="0">
-                <a:solidFill>
-                  <a:srgbClr val="13212A"/>
-                </a:solidFill>
-                <a:latin typeface="Calibri" pitchFamily="34" charset="0"/>
-                <a:ea typeface="Calibri" pitchFamily="34" charset="-122"/>
-                <a:cs typeface="Calibri" pitchFamily="34" charset="-120"/>
-              </a:rPr>
-              <a:t>0.9 to 1.6</a:t>
-            </a:r>
-            <a:endParaRPr lang="en-US" sz="1300" dirty="0"/>
-          </a:p>
-        </p:txBody>
-      </p:sp>
-      <p:sp>
-        <p:nvSpPr>
-          <p:cNvPr id="24" name="Text 20"/>
-          <p:cNvSpPr/>
-          <p:nvPr/>
-        </p:nvSpPr>
-        <p:spPr>
-          <a:xfrm>
-            <a:off x="7955280" y="3941064"/>
-            <a:ext cx="3593592" cy="548640"/>
-          </a:xfrm>
-          <a:prstGeom prst="rect">
-            <a:avLst/>
-          </a:prstGeom>
-          <a:noFill/>
-          <a:ln/>
-        </p:spPr>
-        <p:txBody>
-          <a:bodyPr wrap="square" lIns="0" tIns="0" rIns="0" bIns="0" rtlCol="0" anchor="ctr"/>
-          <a:lstStyle/>
-          <a:p>
-            <a:pPr indent="0" marL="0">
-              <a:lnSpc>
-                <a:spcPct val="115000"/>
-              </a:lnSpc>
-              <a:buNone/>
-            </a:pPr>
-            <a:r>
-              <a:rPr lang="en-US" sz="1250" i="1" dirty="0">
-                <a:solidFill>
-                  <a:srgbClr val="4E5E66"/>
-                </a:solidFill>
-                <a:latin typeface="Calibri" pitchFamily="34" charset="0"/>
-                <a:ea typeface="Calibri" pitchFamily="34" charset="-122"/>
-                <a:cs typeface="Calibri" pitchFamily="34" charset="-120"/>
-              </a:rPr>
-              <a:t>P &lt; 0.001 for the total slope. Difference = finerenone minus placebo; positive favors finerenone.</a:t>
-            </a:r>
-            <a:endParaRPr lang="en-US" sz="1250" dirty="0"/>
-          </a:p>
-        </p:txBody>
-      </p:sp>
-      <p:sp>
-        <p:nvSpPr>
-          <p:cNvPr id="25" name="Text 21"/>
+      <p:pic>
+        <p:nvPicPr>
+          <p:cNvPr id="7" name="Image 1" descr="fig1B.png">    </p:cNvPr>
+          <p:cNvPicPr>
+            <a:picLocks noChangeAspect="1"/>
+          </p:cNvPicPr>
+          <p:nvPr/>
+        </p:nvPicPr>
+        <p:blipFill>
+          <a:blip r:embed="rId2"/>
+          <a:stretch>
+            <a:fillRect/>
+          </a:stretch>
+        </p:blipFill>
+        <p:spPr>
+          <a:xfrm>
+            <a:off x="1252728" y="1783080"/>
+            <a:ext cx="9692640" cy="4041648"/>
+          </a:xfrm>
+          <a:prstGeom prst="rect">
+            <a:avLst/>
+          </a:prstGeom>
+        </p:spPr>
+      </p:pic>
+      <p:sp>
+        <p:nvSpPr>
+          <p:cNvPr id="8" name="Text 4"/>
           <p:cNvSpPr/>
           <p:nvPr/>
         </p:nvSpPr>
@@ -11287,7 +10279,7 @@
                 <a:ea typeface="Calibri" pitchFamily="34" charset="-122"/>
                 <a:cs typeface="Calibri" pitchFamily="34" charset="-120"/>
               </a:rPr>
-              <a:t>Adapted from Figure 1B.</a:t>
+              <a:t>Figure 1B.  Heerspink et al., N Engl J Med 2026.</a:t>
             </a:r>
             <a:endParaRPr lang="en-US" sz="850" dirty="0"/>
           </a:p>
@@ -11295,7 +10287,7 @@
       </p:sp>
       <p:sp>
         <p:nvSpPr>
-          <p:cNvPr id="26" name="Text 22"/>
+          <p:cNvPr id="9" name="Text 5"/>
           <p:cNvSpPr/>
           <p:nvPr/>
         </p:nvSpPr>
@@ -11348,7 +10340,7 @@
       </p:sp>
       <p:sp>
         <p:nvSpPr>
-          <p:cNvPr id="27" name="Text 23"/>
+          <p:cNvPr id="10" name="Text 6"/>
           <p:cNvSpPr/>
           <p:nvPr/>
         </p:nvSpPr>
@@ -11530,8 +10522,8 @@
         </p:nvSpPr>
         <p:spPr>
           <a:xfrm>
-            <a:off x="640080" y="1005840"/>
-            <a:ext cx="10908792" cy="310896"/>
+            <a:off x="640080" y="987552"/>
+            <a:ext cx="10908792" cy="420624"/>
           </a:xfrm>
           <a:prstGeom prst="rect">
             <a:avLst/>
@@ -11544,2189 +10536,53 @@
           <a:lstStyle/>
           <a:p>
             <a:pPr indent="0" marL="0">
-              <a:buNone/>
-            </a:pPr>
-            <a:r>
-              <a:rPr lang="en-US" sz="1350" i="1" dirty="0">
-                <a:solidFill>
-                  <a:srgbClr val="4E5E66"/>
-                </a:solidFill>
-                <a:latin typeface="Calibri" pitchFamily="34" charset="0"/>
-                <a:ea typeface="Calibri" pitchFamily="34" charset="-122"/>
-                <a:cs typeface="Calibri" pitchFamily="34" charset="-120"/>
-              </a:rPr>
-              <a:t>Difference in eGFR slope (ml/min/1.73 m² per year). Positive favors finerenone.</a:t>
-            </a:r>
-            <a:endParaRPr lang="en-US" sz="1350" dirty="0"/>
-          </a:p>
-        </p:txBody>
-      </p:sp>
-      <p:sp>
-        <p:nvSpPr>
-          <p:cNvPr id="7" name="Shape 4"/>
-          <p:cNvSpPr/>
-          <p:nvPr/>
-        </p:nvSpPr>
-        <p:spPr>
-          <a:xfrm>
-            <a:off x="3749040" y="1508760"/>
-            <a:ext cx="0" cy="4142232"/>
-          </a:xfrm>
-          <a:prstGeom prst="line">
-            <a:avLst/>
-          </a:prstGeom>
-          <a:noFill/>
-          <a:ln w="12700">
-            <a:solidFill>
-              <a:srgbClr val="EDF2F2"/>
-            </a:solidFill>
-            <a:prstDash val="dash"/>
-          </a:ln>
-        </p:spPr>
-      </p:sp>
-      <p:sp>
-        <p:nvSpPr>
-          <p:cNvPr id="8" name="Text 5"/>
-          <p:cNvSpPr/>
-          <p:nvPr/>
-        </p:nvSpPr>
-        <p:spPr>
-          <a:xfrm>
-            <a:off x="3474720" y="5724144"/>
-            <a:ext cx="548640" cy="219456"/>
-          </a:xfrm>
-          <a:prstGeom prst="rect">
-            <a:avLst/>
-          </a:prstGeom>
-          <a:noFill/>
-          <a:ln/>
-        </p:spPr>
-        <p:txBody>
-          <a:bodyPr wrap="square" lIns="0" tIns="0" rIns="0" bIns="0" rtlCol="0" anchor="ctr"/>
-          <a:lstStyle/>
-          <a:p>
-            <a:pPr algn="ctr" indent="0" marL="0">
-              <a:buNone/>
-            </a:pPr>
-            <a:r>
-              <a:rPr lang="en-US" sz="950" dirty="0">
-                <a:solidFill>
-                  <a:srgbClr val="4E5E66"/>
-                </a:solidFill>
-                <a:latin typeface="Calibri" pitchFamily="34" charset="0"/>
-                <a:ea typeface="Calibri" pitchFamily="34" charset="-122"/>
-                <a:cs typeface="Calibri" pitchFamily="34" charset="-120"/>
-              </a:rPr>
-              <a:t>-1</a:t>
-            </a:r>
-            <a:endParaRPr lang="en-US" sz="950" dirty="0"/>
-          </a:p>
-        </p:txBody>
-      </p:sp>
-      <p:sp>
-        <p:nvSpPr>
-          <p:cNvPr id="9" name="Shape 6"/>
-          <p:cNvSpPr/>
-          <p:nvPr/>
-        </p:nvSpPr>
-        <p:spPr>
-          <a:xfrm>
-            <a:off x="5739384" y="1508760"/>
-            <a:ext cx="0" cy="4142232"/>
-          </a:xfrm>
-          <a:prstGeom prst="line">
-            <a:avLst/>
-          </a:prstGeom>
-          <a:noFill/>
-          <a:ln w="19050">
-            <a:solidFill>
-              <a:srgbClr val="9AA7AD"/>
-            </a:solidFill>
-            <a:prstDash val="solid"/>
-          </a:ln>
-        </p:spPr>
-      </p:sp>
-      <p:sp>
-        <p:nvSpPr>
-          <p:cNvPr id="10" name="Text 7"/>
-          <p:cNvSpPr/>
-          <p:nvPr/>
-        </p:nvSpPr>
-        <p:spPr>
-          <a:xfrm>
-            <a:off x="5465064" y="5724144"/>
-            <a:ext cx="548640" cy="219456"/>
-          </a:xfrm>
-          <a:prstGeom prst="rect">
-            <a:avLst/>
-          </a:prstGeom>
-          <a:noFill/>
-          <a:ln/>
-        </p:spPr>
-        <p:txBody>
-          <a:bodyPr wrap="square" lIns="0" tIns="0" rIns="0" bIns="0" rtlCol="0" anchor="ctr"/>
-          <a:lstStyle/>
-          <a:p>
-            <a:pPr algn="ctr" indent="0" marL="0">
-              <a:buNone/>
-            </a:pPr>
-            <a:r>
-              <a:rPr lang="en-US" sz="950" dirty="0">
-                <a:solidFill>
-                  <a:srgbClr val="4E5E66"/>
-                </a:solidFill>
-                <a:latin typeface="Calibri" pitchFamily="34" charset="0"/>
-                <a:ea typeface="Calibri" pitchFamily="34" charset="-122"/>
-                <a:cs typeface="Calibri" pitchFamily="34" charset="-120"/>
-              </a:rPr>
-              <a:t>0</a:t>
-            </a:r>
-            <a:endParaRPr lang="en-US" sz="950" dirty="0"/>
-          </a:p>
-        </p:txBody>
-      </p:sp>
-      <p:sp>
-        <p:nvSpPr>
-          <p:cNvPr id="11" name="Shape 8"/>
-          <p:cNvSpPr/>
-          <p:nvPr/>
-        </p:nvSpPr>
-        <p:spPr>
-          <a:xfrm>
-            <a:off x="7729728" y="1508760"/>
-            <a:ext cx="0" cy="4142232"/>
-          </a:xfrm>
-          <a:prstGeom prst="line">
-            <a:avLst/>
-          </a:prstGeom>
-          <a:noFill/>
-          <a:ln w="12700">
-            <a:solidFill>
-              <a:srgbClr val="EDF2F2"/>
-            </a:solidFill>
-            <a:prstDash val="dash"/>
-          </a:ln>
-        </p:spPr>
-      </p:sp>
-      <p:sp>
-        <p:nvSpPr>
-          <p:cNvPr id="12" name="Text 9"/>
-          <p:cNvSpPr/>
-          <p:nvPr/>
-        </p:nvSpPr>
-        <p:spPr>
-          <a:xfrm>
-            <a:off x="7455408" y="5724144"/>
-            <a:ext cx="548640" cy="219456"/>
-          </a:xfrm>
-          <a:prstGeom prst="rect">
-            <a:avLst/>
-          </a:prstGeom>
-          <a:noFill/>
-          <a:ln/>
-        </p:spPr>
-        <p:txBody>
-          <a:bodyPr wrap="square" lIns="0" tIns="0" rIns="0" bIns="0" rtlCol="0" anchor="ctr"/>
-          <a:lstStyle/>
-          <a:p>
-            <a:pPr algn="ctr" indent="0" marL="0">
-              <a:buNone/>
-            </a:pPr>
-            <a:r>
-              <a:rPr lang="en-US" sz="950" dirty="0">
-                <a:solidFill>
-                  <a:srgbClr val="4E5E66"/>
-                </a:solidFill>
-                <a:latin typeface="Calibri" pitchFamily="34" charset="0"/>
-                <a:ea typeface="Calibri" pitchFamily="34" charset="-122"/>
-                <a:cs typeface="Calibri" pitchFamily="34" charset="-120"/>
-              </a:rPr>
-              <a:t>1</a:t>
-            </a:r>
-            <a:endParaRPr lang="en-US" sz="950" dirty="0"/>
-          </a:p>
-        </p:txBody>
-      </p:sp>
-      <p:sp>
-        <p:nvSpPr>
-          <p:cNvPr id="13" name="Shape 10"/>
-          <p:cNvSpPr/>
-          <p:nvPr/>
-        </p:nvSpPr>
-        <p:spPr>
-          <a:xfrm>
-            <a:off x="9720072" y="1508760"/>
-            <a:ext cx="0" cy="4142232"/>
-          </a:xfrm>
-          <a:prstGeom prst="line">
-            <a:avLst/>
-          </a:prstGeom>
-          <a:noFill/>
-          <a:ln w="12700">
-            <a:solidFill>
-              <a:srgbClr val="EDF2F2"/>
-            </a:solidFill>
-            <a:prstDash val="dash"/>
-          </a:ln>
-        </p:spPr>
-      </p:sp>
-      <p:sp>
-        <p:nvSpPr>
-          <p:cNvPr id="14" name="Text 11"/>
-          <p:cNvSpPr/>
-          <p:nvPr/>
-        </p:nvSpPr>
-        <p:spPr>
-          <a:xfrm>
-            <a:off x="9445752" y="5724144"/>
-            <a:ext cx="548640" cy="219456"/>
-          </a:xfrm>
-          <a:prstGeom prst="rect">
-            <a:avLst/>
-          </a:prstGeom>
-          <a:noFill/>
-          <a:ln/>
-        </p:spPr>
-        <p:txBody>
-          <a:bodyPr wrap="square" lIns="0" tIns="0" rIns="0" bIns="0" rtlCol="0" anchor="ctr"/>
-          <a:lstStyle/>
-          <a:p>
-            <a:pPr algn="ctr" indent="0" marL="0">
-              <a:buNone/>
-            </a:pPr>
-            <a:r>
-              <a:rPr lang="en-US" sz="950" dirty="0">
-                <a:solidFill>
-                  <a:srgbClr val="4E5E66"/>
-                </a:solidFill>
-                <a:latin typeface="Calibri" pitchFamily="34" charset="0"/>
-                <a:ea typeface="Calibri" pitchFamily="34" charset="-122"/>
-                <a:cs typeface="Calibri" pitchFamily="34" charset="-120"/>
-              </a:rPr>
-              <a:t>2</a:t>
-            </a:r>
-            <a:endParaRPr lang="en-US" sz="950" dirty="0"/>
-          </a:p>
-        </p:txBody>
-      </p:sp>
-      <p:sp>
-        <p:nvSpPr>
-          <p:cNvPr id="15" name="Text 12"/>
-          <p:cNvSpPr/>
-          <p:nvPr/>
-        </p:nvSpPr>
-        <p:spPr>
-          <a:xfrm>
-            <a:off x="3657600" y="5961888"/>
-            <a:ext cx="1828800" cy="219456"/>
-          </a:xfrm>
-          <a:prstGeom prst="rect">
-            <a:avLst/>
-          </a:prstGeom>
-          <a:noFill/>
-          <a:ln/>
-        </p:spPr>
-        <p:txBody>
-          <a:bodyPr wrap="square" lIns="0" tIns="0" rIns="0" bIns="0" rtlCol="0" anchor="ctr"/>
-          <a:lstStyle/>
-          <a:p>
-            <a:pPr indent="0" marL="0">
-              <a:buNone/>
-            </a:pPr>
-            <a:r>
-              <a:rPr lang="en-US" sz="950" i="1" dirty="0">
-                <a:solidFill>
-                  <a:srgbClr val="4E5E66"/>
-                </a:solidFill>
-                <a:latin typeface="Calibri" pitchFamily="34" charset="0"/>
-                <a:ea typeface="Calibri" pitchFamily="34" charset="-122"/>
-                <a:cs typeface="Calibri" pitchFamily="34" charset="-120"/>
-              </a:rPr>
-              <a:t>Favors placebo</a:t>
-            </a:r>
-            <a:endParaRPr lang="en-US" sz="950" dirty="0"/>
-          </a:p>
-        </p:txBody>
-      </p:sp>
-      <p:sp>
-        <p:nvSpPr>
-          <p:cNvPr id="16" name="Text 13"/>
-          <p:cNvSpPr/>
-          <p:nvPr/>
-        </p:nvSpPr>
-        <p:spPr>
-          <a:xfrm>
-            <a:off x="7982712" y="5961888"/>
-            <a:ext cx="1828800" cy="219456"/>
-          </a:xfrm>
-          <a:prstGeom prst="rect">
-            <a:avLst/>
-          </a:prstGeom>
-          <a:noFill/>
-          <a:ln/>
-        </p:spPr>
-        <p:txBody>
-          <a:bodyPr wrap="square" lIns="0" tIns="0" rIns="0" bIns="0" rtlCol="0" anchor="ctr"/>
-          <a:lstStyle/>
-          <a:p>
-            <a:pPr algn="r" indent="0" marL="0">
-              <a:buNone/>
-            </a:pPr>
-            <a:r>
-              <a:rPr lang="en-US" sz="950" i="1" dirty="0">
-                <a:solidFill>
-                  <a:srgbClr val="4E5E66"/>
-                </a:solidFill>
-                <a:latin typeface="Calibri" pitchFamily="34" charset="0"/>
-                <a:ea typeface="Calibri" pitchFamily="34" charset="-122"/>
-                <a:cs typeface="Calibri" pitchFamily="34" charset="-120"/>
-              </a:rPr>
-              <a:t>Favors finerenone</a:t>
-            </a:r>
-            <a:endParaRPr lang="en-US" sz="950" dirty="0"/>
-          </a:p>
-        </p:txBody>
-      </p:sp>
-      <p:sp>
-        <p:nvSpPr>
-          <p:cNvPr id="17" name="Text 14"/>
-          <p:cNvSpPr/>
-          <p:nvPr/>
-        </p:nvSpPr>
-        <p:spPr>
-          <a:xfrm>
-            <a:off x="640080" y="1597291"/>
-            <a:ext cx="3017520" cy="292608"/>
-          </a:xfrm>
-          <a:prstGeom prst="rect">
-            <a:avLst/>
-          </a:prstGeom>
-          <a:noFill/>
-          <a:ln/>
-        </p:spPr>
-        <p:txBody>
-          <a:bodyPr wrap="square" lIns="0" tIns="0" rIns="0" bIns="0" rtlCol="0" anchor="ctr"/>
-          <a:lstStyle/>
-          <a:p>
-            <a:pPr indent="0" marL="0">
-              <a:buNone/>
-            </a:pPr>
-            <a:r>
-              <a:rPr lang="en-US" sz="1250" b="1" dirty="0">
-                <a:solidFill>
-                  <a:srgbClr val="0F3446"/>
-                </a:solidFill>
-                <a:latin typeface="Calibri" pitchFamily="34" charset="0"/>
-                <a:ea typeface="Calibri" pitchFamily="34" charset="-122"/>
-                <a:cs typeface="Calibri" pitchFamily="34" charset="-120"/>
-              </a:rPr>
-              <a:t>Overall</a:t>
-            </a:r>
-            <a:endParaRPr lang="en-US" sz="1250" dirty="0"/>
-          </a:p>
-        </p:txBody>
-      </p:sp>
-      <p:sp>
-        <p:nvSpPr>
-          <p:cNvPr id="18" name="Shape 15"/>
-          <p:cNvSpPr/>
-          <p:nvPr/>
-        </p:nvSpPr>
-        <p:spPr>
-          <a:xfrm>
-            <a:off x="6376294" y="1743595"/>
-            <a:ext cx="1452951" cy="0"/>
-          </a:xfrm>
-          <a:prstGeom prst="line">
-            <a:avLst/>
-          </a:prstGeom>
-          <a:noFill/>
-          <a:ln w="38100">
-            <a:solidFill>
-              <a:srgbClr val="12A3A6"/>
-            </a:solidFill>
-            <a:prstDash val="solid"/>
-          </a:ln>
-        </p:spPr>
-      </p:sp>
-      <p:sp>
-        <p:nvSpPr>
-          <p:cNvPr id="19" name="Shape 16"/>
-          <p:cNvSpPr/>
-          <p:nvPr/>
-        </p:nvSpPr>
-        <p:spPr>
-          <a:xfrm>
-            <a:off x="6376294" y="1688731"/>
-            <a:ext cx="0" cy="109728"/>
-          </a:xfrm>
-          <a:prstGeom prst="line">
-            <a:avLst/>
-          </a:prstGeom>
-          <a:noFill/>
-          <a:ln w="25400">
-            <a:solidFill>
-              <a:srgbClr val="12A3A6"/>
-            </a:solidFill>
-            <a:prstDash val="solid"/>
-          </a:ln>
-        </p:spPr>
-      </p:sp>
-      <p:sp>
-        <p:nvSpPr>
-          <p:cNvPr id="20" name="Shape 17"/>
-          <p:cNvSpPr/>
-          <p:nvPr/>
-        </p:nvSpPr>
-        <p:spPr>
-          <a:xfrm>
-            <a:off x="7829245" y="1688731"/>
-            <a:ext cx="0" cy="109728"/>
-          </a:xfrm>
-          <a:prstGeom prst="line">
-            <a:avLst/>
-          </a:prstGeom>
-          <a:noFill/>
-          <a:ln w="25400">
-            <a:solidFill>
-              <a:srgbClr val="12A3A6"/>
-            </a:solidFill>
-            <a:prstDash val="solid"/>
-          </a:ln>
-        </p:spPr>
-      </p:sp>
-      <p:sp>
-        <p:nvSpPr>
-          <p:cNvPr id="21" name="Shape 18"/>
-          <p:cNvSpPr/>
-          <p:nvPr/>
-        </p:nvSpPr>
-        <p:spPr>
-          <a:xfrm>
-            <a:off x="7033382" y="1684159"/>
-            <a:ext cx="118872" cy="118872"/>
-          </a:xfrm>
-          <a:prstGeom prst="diamond">
-            <a:avLst/>
-          </a:prstGeom>
-          <a:solidFill>
-            <a:srgbClr val="0F3446"/>
-          </a:solidFill>
-          <a:ln/>
-        </p:spPr>
-      </p:sp>
-      <p:sp>
-        <p:nvSpPr>
-          <p:cNvPr id="22" name="Text 19"/>
-          <p:cNvSpPr/>
-          <p:nvPr/>
-        </p:nvSpPr>
-        <p:spPr>
-          <a:xfrm>
-            <a:off x="9765792" y="1597291"/>
-            <a:ext cx="1783080" cy="292608"/>
-          </a:xfrm>
-          <a:prstGeom prst="rect">
-            <a:avLst/>
-          </a:prstGeom>
-          <a:noFill/>
-          <a:ln/>
-        </p:spPr>
-        <p:txBody>
-          <a:bodyPr wrap="square" lIns="0" tIns="0" rIns="0" bIns="0" rtlCol="0" anchor="ctr"/>
-          <a:lstStyle/>
-          <a:p>
-            <a:pPr indent="0" marL="0">
-              <a:buNone/>
-            </a:pPr>
-            <a:r>
-              <a:rPr lang="en-US" sz="950" b="1" dirty="0">
-                <a:solidFill>
-                  <a:srgbClr val="0F3446"/>
-                </a:solidFill>
-                <a:latin typeface="Calibri" pitchFamily="34" charset="0"/>
-                <a:ea typeface="Calibri" pitchFamily="34" charset="-122"/>
-                <a:cs typeface="Calibri" pitchFamily="34" charset="-120"/>
-              </a:rPr>
-              <a:t>0.68 (0.32 to 1.05)</a:t>
-            </a:r>
-            <a:endParaRPr lang="en-US" sz="950" dirty="0"/>
-          </a:p>
-        </p:txBody>
-      </p:sp>
-      <p:sp>
-        <p:nvSpPr>
-          <p:cNvPr id="23" name="Text 20"/>
-          <p:cNvSpPr/>
-          <p:nvPr/>
-        </p:nvSpPr>
-        <p:spPr>
-          <a:xfrm>
-            <a:off x="640080" y="1975520"/>
-            <a:ext cx="3017520" cy="292608"/>
-          </a:xfrm>
-          <a:prstGeom prst="rect">
-            <a:avLst/>
-          </a:prstGeom>
-          <a:noFill/>
-          <a:ln/>
-        </p:spPr>
-        <p:txBody>
-          <a:bodyPr wrap="square" lIns="0" tIns="0" rIns="0" bIns="0" rtlCol="0" anchor="ctr"/>
-          <a:lstStyle/>
-          <a:p>
-            <a:pPr indent="0" marL="0">
-              <a:buNone/>
-            </a:pPr>
-            <a:r>
-              <a:rPr lang="en-US" sz="1250" dirty="0">
-                <a:solidFill>
-                  <a:srgbClr val="13212A"/>
-                </a:solidFill>
-                <a:latin typeface="Calibri" pitchFamily="34" charset="0"/>
-                <a:ea typeface="Calibri" pitchFamily="34" charset="-122"/>
-                <a:cs typeface="Calibri" pitchFamily="34" charset="-120"/>
-              </a:rPr>
-              <a:t>Cause: HTN / ischemic</a:t>
-            </a:r>
-            <a:endParaRPr lang="en-US" sz="1250" dirty="0"/>
-          </a:p>
-        </p:txBody>
-      </p:sp>
-      <p:sp>
-        <p:nvSpPr>
-          <p:cNvPr id="24" name="Shape 21"/>
-          <p:cNvSpPr/>
-          <p:nvPr/>
-        </p:nvSpPr>
-        <p:spPr>
-          <a:xfrm>
-            <a:off x="5739384" y="2121824"/>
-            <a:ext cx="2726771" cy="0"/>
-          </a:xfrm>
-          <a:prstGeom prst="line">
-            <a:avLst/>
-          </a:prstGeom>
-          <a:noFill/>
-          <a:ln w="25400">
-            <a:solidFill>
-              <a:srgbClr val="6FBEC0"/>
-            </a:solidFill>
-            <a:prstDash val="solid"/>
-          </a:ln>
-        </p:spPr>
-      </p:sp>
-      <p:sp>
-        <p:nvSpPr>
-          <p:cNvPr id="25" name="Shape 22"/>
-          <p:cNvSpPr/>
-          <p:nvPr/>
-        </p:nvSpPr>
-        <p:spPr>
-          <a:xfrm>
-            <a:off x="5739384" y="2066960"/>
-            <a:ext cx="0" cy="109728"/>
-          </a:xfrm>
-          <a:prstGeom prst="line">
-            <a:avLst/>
-          </a:prstGeom>
-          <a:noFill/>
-          <a:ln w="25400">
-            <a:solidFill>
-              <a:srgbClr val="6FBEC0"/>
-            </a:solidFill>
-            <a:prstDash val="solid"/>
-          </a:ln>
-        </p:spPr>
-      </p:sp>
-      <p:sp>
-        <p:nvSpPr>
-          <p:cNvPr id="26" name="Shape 23"/>
-          <p:cNvSpPr/>
-          <p:nvPr/>
-        </p:nvSpPr>
-        <p:spPr>
-          <a:xfrm>
-            <a:off x="8466155" y="2066960"/>
-            <a:ext cx="0" cy="109728"/>
-          </a:xfrm>
-          <a:prstGeom prst="line">
-            <a:avLst/>
-          </a:prstGeom>
-          <a:noFill/>
-          <a:ln w="25400">
-            <a:solidFill>
-              <a:srgbClr val="6FBEC0"/>
-            </a:solidFill>
-            <a:prstDash val="solid"/>
-          </a:ln>
-        </p:spPr>
-      </p:sp>
-      <p:sp>
-        <p:nvSpPr>
-          <p:cNvPr id="27" name="Shape 24"/>
-          <p:cNvSpPr/>
-          <p:nvPr/>
-        </p:nvSpPr>
-        <p:spPr>
-          <a:xfrm>
-            <a:off x="7047098" y="2076104"/>
-            <a:ext cx="91440" cy="91440"/>
-          </a:xfrm>
-          <a:prstGeom prst="diamond">
-            <a:avLst/>
-          </a:prstGeom>
-          <a:solidFill>
-            <a:srgbClr val="12A3A6"/>
-          </a:solidFill>
-          <a:ln/>
-        </p:spPr>
-      </p:sp>
-      <p:sp>
-        <p:nvSpPr>
-          <p:cNvPr id="28" name="Text 25"/>
-          <p:cNvSpPr/>
-          <p:nvPr/>
-        </p:nvSpPr>
-        <p:spPr>
-          <a:xfrm>
-            <a:off x="9765792" y="1975520"/>
-            <a:ext cx="1783080" cy="292608"/>
-          </a:xfrm>
-          <a:prstGeom prst="rect">
-            <a:avLst/>
-          </a:prstGeom>
-          <a:noFill/>
-          <a:ln/>
-        </p:spPr>
-        <p:txBody>
-          <a:bodyPr wrap="square" lIns="0" tIns="0" rIns="0" bIns="0" rtlCol="0" anchor="ctr"/>
-          <a:lstStyle/>
-          <a:p>
-            <a:pPr indent="0" marL="0">
-              <a:buNone/>
-            </a:pPr>
-            <a:r>
-              <a:rPr lang="en-US" sz="950" dirty="0">
-                <a:solidFill>
-                  <a:srgbClr val="4E5E66"/>
-                </a:solidFill>
-                <a:latin typeface="Calibri" pitchFamily="34" charset="0"/>
-                <a:ea typeface="Calibri" pitchFamily="34" charset="-122"/>
-                <a:cs typeface="Calibri" pitchFamily="34" charset="-120"/>
-              </a:rPr>
-              <a:t>0.68 (0.00 to 1.37)</a:t>
-            </a:r>
-            <a:endParaRPr lang="en-US" sz="950" dirty="0"/>
-          </a:p>
-        </p:txBody>
-      </p:sp>
-      <p:sp>
-        <p:nvSpPr>
-          <p:cNvPr id="29" name="Text 26"/>
-          <p:cNvSpPr/>
-          <p:nvPr/>
-        </p:nvSpPr>
-        <p:spPr>
-          <a:xfrm>
-            <a:off x="640080" y="2353749"/>
-            <a:ext cx="3017520" cy="292608"/>
-          </a:xfrm>
-          <a:prstGeom prst="rect">
-            <a:avLst/>
-          </a:prstGeom>
-          <a:noFill/>
-          <a:ln/>
-        </p:spPr>
-        <p:txBody>
-          <a:bodyPr wrap="square" lIns="0" tIns="0" rIns="0" bIns="0" rtlCol="0" anchor="ctr"/>
-          <a:lstStyle/>
-          <a:p>
-            <a:pPr indent="0" marL="0">
-              <a:buNone/>
-            </a:pPr>
-            <a:r>
-              <a:rPr lang="en-US" sz="1250" dirty="0">
-                <a:solidFill>
-                  <a:srgbClr val="13212A"/>
-                </a:solidFill>
-                <a:latin typeface="Calibri" pitchFamily="34" charset="0"/>
-                <a:ea typeface="Calibri" pitchFamily="34" charset="-122"/>
-                <a:cs typeface="Calibri" pitchFamily="34" charset="-120"/>
-              </a:rPr>
-              <a:t>Cause: chronic GN</a:t>
-            </a:r>
-            <a:endParaRPr lang="en-US" sz="1250" dirty="0"/>
-          </a:p>
-        </p:txBody>
-      </p:sp>
-      <p:sp>
-        <p:nvSpPr>
-          <p:cNvPr id="30" name="Shape 27"/>
-          <p:cNvSpPr/>
-          <p:nvPr/>
-        </p:nvSpPr>
-        <p:spPr>
-          <a:xfrm>
-            <a:off x="6236970" y="2500053"/>
-            <a:ext cx="1930634" cy="0"/>
-          </a:xfrm>
-          <a:prstGeom prst="line">
-            <a:avLst/>
-          </a:prstGeom>
-          <a:noFill/>
-          <a:ln w="25400">
-            <a:solidFill>
-              <a:srgbClr val="6FBEC0"/>
-            </a:solidFill>
-            <a:prstDash val="solid"/>
-          </a:ln>
-        </p:spPr>
-      </p:sp>
-      <p:sp>
-        <p:nvSpPr>
-          <p:cNvPr id="31" name="Shape 28"/>
-          <p:cNvSpPr/>
-          <p:nvPr/>
-        </p:nvSpPr>
-        <p:spPr>
-          <a:xfrm>
-            <a:off x="6236970" y="2445189"/>
-            <a:ext cx="0" cy="109728"/>
-          </a:xfrm>
-          <a:prstGeom prst="line">
-            <a:avLst/>
-          </a:prstGeom>
-          <a:noFill/>
-          <a:ln w="25400">
-            <a:solidFill>
-              <a:srgbClr val="6FBEC0"/>
-            </a:solidFill>
-            <a:prstDash val="solid"/>
-          </a:ln>
-        </p:spPr>
-      </p:sp>
-      <p:sp>
-        <p:nvSpPr>
-          <p:cNvPr id="32" name="Shape 29"/>
-          <p:cNvSpPr/>
-          <p:nvPr/>
-        </p:nvSpPr>
-        <p:spPr>
-          <a:xfrm>
-            <a:off x="8167604" y="2445189"/>
-            <a:ext cx="0" cy="109728"/>
-          </a:xfrm>
-          <a:prstGeom prst="line">
-            <a:avLst/>
-          </a:prstGeom>
-          <a:noFill/>
-          <a:ln w="25400">
-            <a:solidFill>
-              <a:srgbClr val="6FBEC0"/>
-            </a:solidFill>
-            <a:prstDash val="solid"/>
-          </a:ln>
-        </p:spPr>
-      </p:sp>
-      <p:sp>
-        <p:nvSpPr>
-          <p:cNvPr id="33" name="Shape 30"/>
-          <p:cNvSpPr/>
-          <p:nvPr/>
-        </p:nvSpPr>
-        <p:spPr>
-          <a:xfrm>
-            <a:off x="7146615" y="2454333"/>
-            <a:ext cx="91440" cy="91440"/>
-          </a:xfrm>
-          <a:prstGeom prst="diamond">
-            <a:avLst/>
-          </a:prstGeom>
-          <a:solidFill>
-            <a:srgbClr val="12A3A6"/>
-          </a:solidFill>
-          <a:ln/>
-        </p:spPr>
-      </p:sp>
-      <p:sp>
-        <p:nvSpPr>
-          <p:cNvPr id="34" name="Text 31"/>
-          <p:cNvSpPr/>
-          <p:nvPr/>
-        </p:nvSpPr>
-        <p:spPr>
-          <a:xfrm>
-            <a:off x="9765792" y="2353749"/>
-            <a:ext cx="1783080" cy="292608"/>
-          </a:xfrm>
-          <a:prstGeom prst="rect">
-            <a:avLst/>
-          </a:prstGeom>
-          <a:noFill/>
-          <a:ln/>
-        </p:spPr>
-        <p:txBody>
-          <a:bodyPr wrap="square" lIns="0" tIns="0" rIns="0" bIns="0" rtlCol="0" anchor="ctr"/>
-          <a:lstStyle/>
-          <a:p>
-            <a:pPr indent="0" marL="0">
-              <a:buNone/>
-            </a:pPr>
-            <a:r>
-              <a:rPr lang="en-US" sz="950" dirty="0">
-                <a:solidFill>
-                  <a:srgbClr val="4E5E66"/>
-                </a:solidFill>
-                <a:latin typeface="Calibri" pitchFamily="34" charset="0"/>
-                <a:ea typeface="Calibri" pitchFamily="34" charset="-122"/>
-                <a:cs typeface="Calibri" pitchFamily="34" charset="-120"/>
-              </a:rPr>
-              <a:t>0.73 (0.25 to 1.22)</a:t>
-            </a:r>
-            <a:endParaRPr lang="en-US" sz="950" dirty="0"/>
-          </a:p>
-        </p:txBody>
-      </p:sp>
-      <p:sp>
-        <p:nvSpPr>
-          <p:cNvPr id="35" name="Text 32"/>
-          <p:cNvSpPr/>
-          <p:nvPr/>
-        </p:nvSpPr>
-        <p:spPr>
-          <a:xfrm>
-            <a:off x="640080" y="2731978"/>
-            <a:ext cx="3017520" cy="292608"/>
-          </a:xfrm>
-          <a:prstGeom prst="rect">
-            <a:avLst/>
-          </a:prstGeom>
-          <a:noFill/>
-          <a:ln/>
-        </p:spPr>
-        <p:txBody>
-          <a:bodyPr wrap="square" lIns="0" tIns="0" rIns="0" bIns="0" rtlCol="0" anchor="ctr"/>
-          <a:lstStyle/>
-          <a:p>
-            <a:pPr indent="0" marL="0">
-              <a:buNone/>
-            </a:pPr>
-            <a:r>
-              <a:rPr lang="en-US" sz="1250" dirty="0">
-                <a:solidFill>
-                  <a:srgbClr val="13212A"/>
-                </a:solidFill>
-                <a:latin typeface="Calibri" pitchFamily="34" charset="0"/>
-                <a:ea typeface="Calibri" pitchFamily="34" charset="-122"/>
-                <a:cs typeface="Calibri" pitchFamily="34" charset="-120"/>
-              </a:rPr>
-              <a:t>Cause: other / unknown</a:t>
-            </a:r>
-            <a:endParaRPr lang="en-US" sz="1250" dirty="0"/>
-          </a:p>
-        </p:txBody>
-      </p:sp>
-      <p:sp>
-        <p:nvSpPr>
-          <p:cNvPr id="36" name="Shape 33"/>
-          <p:cNvSpPr/>
-          <p:nvPr/>
-        </p:nvSpPr>
-        <p:spPr>
-          <a:xfrm>
-            <a:off x="4684502" y="2878282"/>
-            <a:ext cx="3920978" cy="0"/>
-          </a:xfrm>
-          <a:prstGeom prst="line">
-            <a:avLst/>
-          </a:prstGeom>
-          <a:noFill/>
-          <a:ln w="25400">
-            <a:solidFill>
-              <a:srgbClr val="6FBEC0"/>
-            </a:solidFill>
-            <a:prstDash val="solid"/>
-          </a:ln>
-        </p:spPr>
-      </p:sp>
-      <p:sp>
-        <p:nvSpPr>
-          <p:cNvPr id="37" name="Shape 34"/>
-          <p:cNvSpPr/>
-          <p:nvPr/>
-        </p:nvSpPr>
-        <p:spPr>
-          <a:xfrm>
-            <a:off x="4684502" y="2823418"/>
-            <a:ext cx="0" cy="109728"/>
-          </a:xfrm>
-          <a:prstGeom prst="line">
-            <a:avLst/>
-          </a:prstGeom>
-          <a:noFill/>
-          <a:ln w="25400">
-            <a:solidFill>
-              <a:srgbClr val="6FBEC0"/>
-            </a:solidFill>
-            <a:prstDash val="solid"/>
-          </a:ln>
-        </p:spPr>
-      </p:sp>
-      <p:sp>
-        <p:nvSpPr>
-          <p:cNvPr id="38" name="Shape 35"/>
-          <p:cNvSpPr/>
-          <p:nvPr/>
-        </p:nvSpPr>
-        <p:spPr>
-          <a:xfrm>
-            <a:off x="8605479" y="2823418"/>
-            <a:ext cx="0" cy="109728"/>
-          </a:xfrm>
-          <a:prstGeom prst="line">
-            <a:avLst/>
-          </a:prstGeom>
-          <a:noFill/>
-          <a:ln w="25400">
-            <a:solidFill>
-              <a:srgbClr val="6FBEC0"/>
-            </a:solidFill>
-            <a:prstDash val="solid"/>
-          </a:ln>
-        </p:spPr>
-      </p:sp>
-      <p:sp>
-        <p:nvSpPr>
-          <p:cNvPr id="39" name="Shape 36"/>
-          <p:cNvSpPr/>
-          <p:nvPr/>
-        </p:nvSpPr>
-        <p:spPr>
-          <a:xfrm>
-            <a:off x="6589319" y="2832562"/>
-            <a:ext cx="91440" cy="91440"/>
-          </a:xfrm>
-          <a:prstGeom prst="diamond">
-            <a:avLst/>
-          </a:prstGeom>
-          <a:solidFill>
-            <a:srgbClr val="12A3A6"/>
-          </a:solidFill>
-          <a:ln/>
-        </p:spPr>
-      </p:sp>
-      <p:sp>
-        <p:nvSpPr>
-          <p:cNvPr id="40" name="Text 37"/>
-          <p:cNvSpPr/>
-          <p:nvPr/>
-        </p:nvSpPr>
-        <p:spPr>
-          <a:xfrm>
-            <a:off x="9765792" y="2731978"/>
-            <a:ext cx="1783080" cy="292608"/>
-          </a:xfrm>
-          <a:prstGeom prst="rect">
-            <a:avLst/>
-          </a:prstGeom>
-          <a:noFill/>
-          <a:ln/>
-        </p:spPr>
-        <p:txBody>
-          <a:bodyPr wrap="square" lIns="0" tIns="0" rIns="0" bIns="0" rtlCol="0" anchor="ctr"/>
-          <a:lstStyle/>
-          <a:p>
-            <a:pPr indent="0" marL="0">
-              <a:buNone/>
-            </a:pPr>
-            <a:r>
-              <a:rPr lang="en-US" sz="950" dirty="0">
-                <a:solidFill>
-                  <a:srgbClr val="4E5E66"/>
-                </a:solidFill>
-                <a:latin typeface="Calibri" pitchFamily="34" charset="0"/>
-                <a:ea typeface="Calibri" pitchFamily="34" charset="-122"/>
-                <a:cs typeface="Calibri" pitchFamily="34" charset="-120"/>
-              </a:rPr>
-              <a:t>0.45 (-0.53 to 1.44)</a:t>
-            </a:r>
-            <a:endParaRPr lang="en-US" sz="950" dirty="0"/>
-          </a:p>
-        </p:txBody>
-      </p:sp>
-      <p:sp>
-        <p:nvSpPr>
-          <p:cNvPr id="41" name="Text 38"/>
-          <p:cNvSpPr/>
-          <p:nvPr/>
-        </p:nvSpPr>
-        <p:spPr>
-          <a:xfrm>
-            <a:off x="640080" y="3110207"/>
-            <a:ext cx="3017520" cy="292608"/>
-          </a:xfrm>
-          <a:prstGeom prst="rect">
-            <a:avLst/>
-          </a:prstGeom>
-          <a:noFill/>
-          <a:ln/>
-        </p:spPr>
-        <p:txBody>
-          <a:bodyPr wrap="square" lIns="0" tIns="0" rIns="0" bIns="0" rtlCol="0" anchor="ctr"/>
-          <a:lstStyle/>
-          <a:p>
-            <a:pPr indent="0" marL="0">
-              <a:buNone/>
-            </a:pPr>
-            <a:r>
-              <a:rPr lang="en-US" sz="1250" dirty="0">
-                <a:solidFill>
-                  <a:srgbClr val="13212A"/>
-                </a:solidFill>
-                <a:latin typeface="Calibri" pitchFamily="34" charset="0"/>
-                <a:ea typeface="Calibri" pitchFamily="34" charset="-122"/>
-                <a:cs typeface="Calibri" pitchFamily="34" charset="-120"/>
-              </a:rPr>
-              <a:t>eGFR &lt; 45</a:t>
-            </a:r>
-            <a:endParaRPr lang="en-US" sz="1250" dirty="0"/>
-          </a:p>
-        </p:txBody>
-      </p:sp>
-      <p:sp>
-        <p:nvSpPr>
-          <p:cNvPr id="42" name="Shape 39"/>
-          <p:cNvSpPr/>
-          <p:nvPr/>
-        </p:nvSpPr>
-        <p:spPr>
-          <a:xfrm>
-            <a:off x="5958322" y="3256511"/>
-            <a:ext cx="2010247" cy="0"/>
-          </a:xfrm>
-          <a:prstGeom prst="line">
-            <a:avLst/>
-          </a:prstGeom>
-          <a:noFill/>
-          <a:ln w="25400">
-            <a:solidFill>
-              <a:srgbClr val="6FBEC0"/>
-            </a:solidFill>
-            <a:prstDash val="solid"/>
-          </a:ln>
-        </p:spPr>
-      </p:sp>
-      <p:sp>
-        <p:nvSpPr>
-          <p:cNvPr id="43" name="Shape 40"/>
-          <p:cNvSpPr/>
-          <p:nvPr/>
-        </p:nvSpPr>
-        <p:spPr>
-          <a:xfrm>
-            <a:off x="5958322" y="3201647"/>
-            <a:ext cx="0" cy="109728"/>
-          </a:xfrm>
-          <a:prstGeom prst="line">
-            <a:avLst/>
-          </a:prstGeom>
-          <a:noFill/>
-          <a:ln w="25400">
-            <a:solidFill>
-              <a:srgbClr val="6FBEC0"/>
-            </a:solidFill>
-            <a:prstDash val="solid"/>
-          </a:ln>
-        </p:spPr>
-      </p:sp>
-      <p:sp>
-        <p:nvSpPr>
-          <p:cNvPr id="44" name="Shape 41"/>
-          <p:cNvSpPr/>
-          <p:nvPr/>
-        </p:nvSpPr>
-        <p:spPr>
-          <a:xfrm>
-            <a:off x="7968569" y="3201647"/>
-            <a:ext cx="0" cy="109728"/>
-          </a:xfrm>
-          <a:prstGeom prst="line">
-            <a:avLst/>
-          </a:prstGeom>
-          <a:noFill/>
-          <a:ln w="25400">
-            <a:solidFill>
-              <a:srgbClr val="6FBEC0"/>
-            </a:solidFill>
-            <a:prstDash val="solid"/>
-          </a:ln>
-        </p:spPr>
-      </p:sp>
-      <p:sp>
-        <p:nvSpPr>
-          <p:cNvPr id="45" name="Shape 42"/>
-          <p:cNvSpPr/>
-          <p:nvPr/>
-        </p:nvSpPr>
-        <p:spPr>
-          <a:xfrm>
-            <a:off x="6907774" y="3210791"/>
-            <a:ext cx="91440" cy="91440"/>
-          </a:xfrm>
-          <a:prstGeom prst="diamond">
-            <a:avLst/>
-          </a:prstGeom>
-          <a:solidFill>
-            <a:srgbClr val="12A3A6"/>
-          </a:solidFill>
-          <a:ln/>
-        </p:spPr>
-      </p:sp>
-      <p:sp>
-        <p:nvSpPr>
-          <p:cNvPr id="46" name="Text 43"/>
-          <p:cNvSpPr/>
-          <p:nvPr/>
-        </p:nvSpPr>
-        <p:spPr>
-          <a:xfrm>
-            <a:off x="9765792" y="3110207"/>
-            <a:ext cx="1783080" cy="292608"/>
-          </a:xfrm>
-          <a:prstGeom prst="rect">
-            <a:avLst/>
-          </a:prstGeom>
-          <a:noFill/>
-          <a:ln/>
-        </p:spPr>
-        <p:txBody>
-          <a:bodyPr wrap="square" lIns="0" tIns="0" rIns="0" bIns="0" rtlCol="0" anchor="ctr"/>
-          <a:lstStyle/>
-          <a:p>
-            <a:pPr indent="0" marL="0">
-              <a:buNone/>
-            </a:pPr>
-            <a:r>
-              <a:rPr lang="en-US" sz="950" dirty="0">
-                <a:solidFill>
-                  <a:srgbClr val="4E5E66"/>
-                </a:solidFill>
-                <a:latin typeface="Calibri" pitchFamily="34" charset="0"/>
-                <a:ea typeface="Calibri" pitchFamily="34" charset="-122"/>
-                <a:cs typeface="Calibri" pitchFamily="34" charset="-120"/>
-              </a:rPr>
-              <a:t>0.61 (0.11 to 1.12)</a:t>
-            </a:r>
-            <a:endParaRPr lang="en-US" sz="950" dirty="0"/>
-          </a:p>
-        </p:txBody>
-      </p:sp>
-      <p:sp>
-        <p:nvSpPr>
-          <p:cNvPr id="47" name="Text 44"/>
-          <p:cNvSpPr/>
-          <p:nvPr/>
-        </p:nvSpPr>
-        <p:spPr>
-          <a:xfrm>
-            <a:off x="640080" y="3488436"/>
-            <a:ext cx="3017520" cy="292608"/>
-          </a:xfrm>
-          <a:prstGeom prst="rect">
-            <a:avLst/>
-          </a:prstGeom>
-          <a:noFill/>
-          <a:ln/>
-        </p:spPr>
-        <p:txBody>
-          <a:bodyPr wrap="square" lIns="0" tIns="0" rIns="0" bIns="0" rtlCol="0" anchor="ctr"/>
-          <a:lstStyle/>
-          <a:p>
-            <a:pPr indent="0" marL="0">
-              <a:buNone/>
-            </a:pPr>
-            <a:r>
-              <a:rPr lang="en-US" sz="1250" dirty="0">
-                <a:solidFill>
-                  <a:srgbClr val="13212A"/>
-                </a:solidFill>
-                <a:latin typeface="Calibri" pitchFamily="34" charset="0"/>
-                <a:ea typeface="Calibri" pitchFamily="34" charset="-122"/>
-                <a:cs typeface="Calibri" pitchFamily="34" charset="-120"/>
-              </a:rPr>
-              <a:t>eGFR 45 to &lt;60</a:t>
-            </a:r>
-            <a:endParaRPr lang="en-US" sz="1250" dirty="0"/>
-          </a:p>
-        </p:txBody>
-      </p:sp>
-      <p:sp>
-        <p:nvSpPr>
-          <p:cNvPr id="48" name="Shape 45"/>
-          <p:cNvSpPr/>
-          <p:nvPr/>
-        </p:nvSpPr>
-        <p:spPr>
-          <a:xfrm>
-            <a:off x="6416101" y="3634740"/>
-            <a:ext cx="2806385" cy="0"/>
-          </a:xfrm>
-          <a:prstGeom prst="line">
-            <a:avLst/>
-          </a:prstGeom>
-          <a:noFill/>
-          <a:ln w="25400">
-            <a:solidFill>
-              <a:srgbClr val="6FBEC0"/>
-            </a:solidFill>
-            <a:prstDash val="solid"/>
-          </a:ln>
-        </p:spPr>
-      </p:sp>
-      <p:sp>
-        <p:nvSpPr>
-          <p:cNvPr id="49" name="Shape 46"/>
-          <p:cNvSpPr/>
-          <p:nvPr/>
-        </p:nvSpPr>
-        <p:spPr>
-          <a:xfrm>
-            <a:off x="6416101" y="3579876"/>
-            <a:ext cx="0" cy="109728"/>
-          </a:xfrm>
-          <a:prstGeom prst="line">
-            <a:avLst/>
-          </a:prstGeom>
-          <a:noFill/>
-          <a:ln w="25400">
-            <a:solidFill>
-              <a:srgbClr val="6FBEC0"/>
-            </a:solidFill>
-            <a:prstDash val="solid"/>
-          </a:ln>
-        </p:spPr>
-      </p:sp>
-      <p:sp>
-        <p:nvSpPr>
-          <p:cNvPr id="50" name="Shape 47"/>
-          <p:cNvSpPr/>
-          <p:nvPr/>
-        </p:nvSpPr>
-        <p:spPr>
-          <a:xfrm>
-            <a:off x="9222486" y="3579876"/>
-            <a:ext cx="0" cy="109728"/>
-          </a:xfrm>
-          <a:prstGeom prst="line">
-            <a:avLst/>
-          </a:prstGeom>
-          <a:noFill/>
-          <a:ln w="25400">
-            <a:solidFill>
-              <a:srgbClr val="6FBEC0"/>
-            </a:solidFill>
-            <a:prstDash val="solid"/>
-          </a:ln>
-        </p:spPr>
-      </p:sp>
-      <p:sp>
-        <p:nvSpPr>
-          <p:cNvPr id="51" name="Shape 48"/>
-          <p:cNvSpPr/>
-          <p:nvPr/>
-        </p:nvSpPr>
-        <p:spPr>
-          <a:xfrm>
-            <a:off x="7783525" y="3589020"/>
-            <a:ext cx="91440" cy="91440"/>
-          </a:xfrm>
-          <a:prstGeom prst="diamond">
-            <a:avLst/>
-          </a:prstGeom>
-          <a:solidFill>
-            <a:srgbClr val="12A3A6"/>
-          </a:solidFill>
-          <a:ln/>
-        </p:spPr>
-      </p:sp>
-      <p:sp>
-        <p:nvSpPr>
-          <p:cNvPr id="52" name="Text 49"/>
-          <p:cNvSpPr/>
-          <p:nvPr/>
-        </p:nvSpPr>
-        <p:spPr>
-          <a:xfrm>
-            <a:off x="9765792" y="3488436"/>
-            <a:ext cx="1783080" cy="292608"/>
-          </a:xfrm>
-          <a:prstGeom prst="rect">
-            <a:avLst/>
-          </a:prstGeom>
-          <a:noFill/>
-          <a:ln/>
-        </p:spPr>
-        <p:txBody>
-          <a:bodyPr wrap="square" lIns="0" tIns="0" rIns="0" bIns="0" rtlCol="0" anchor="ctr"/>
-          <a:lstStyle/>
-          <a:p>
-            <a:pPr indent="0" marL="0">
-              <a:buNone/>
-            </a:pPr>
-            <a:r>
-              <a:rPr lang="en-US" sz="950" dirty="0">
-                <a:solidFill>
-                  <a:srgbClr val="4E5E66"/>
-                </a:solidFill>
-                <a:latin typeface="Calibri" pitchFamily="34" charset="0"/>
-                <a:ea typeface="Calibri" pitchFamily="34" charset="-122"/>
-                <a:cs typeface="Calibri" pitchFamily="34" charset="-120"/>
-              </a:rPr>
-              <a:t>1.05 (0.34 to 1.75)</a:t>
-            </a:r>
-            <a:endParaRPr lang="en-US" sz="950" dirty="0"/>
-          </a:p>
-        </p:txBody>
-      </p:sp>
-      <p:sp>
-        <p:nvSpPr>
-          <p:cNvPr id="53" name="Text 50"/>
-          <p:cNvSpPr/>
-          <p:nvPr/>
-        </p:nvSpPr>
-        <p:spPr>
-          <a:xfrm>
-            <a:off x="640080" y="3866665"/>
-            <a:ext cx="3017520" cy="292608"/>
-          </a:xfrm>
-          <a:prstGeom prst="rect">
-            <a:avLst/>
-          </a:prstGeom>
-          <a:noFill/>
-          <a:ln/>
-        </p:spPr>
-        <p:txBody>
-          <a:bodyPr wrap="square" lIns="0" tIns="0" rIns="0" bIns="0" rtlCol="0" anchor="ctr"/>
-          <a:lstStyle/>
-          <a:p>
-            <a:pPr indent="0" marL="0">
-              <a:buNone/>
-            </a:pPr>
-            <a:r>
-              <a:rPr lang="en-US" sz="1250" dirty="0">
-                <a:solidFill>
-                  <a:srgbClr val="13212A"/>
-                </a:solidFill>
-                <a:latin typeface="Calibri" pitchFamily="34" charset="0"/>
-                <a:ea typeface="Calibri" pitchFamily="34" charset="-122"/>
-                <a:cs typeface="Calibri" pitchFamily="34" charset="-120"/>
-              </a:rPr>
-              <a:t>eGFR ≥ 60</a:t>
-            </a:r>
-            <a:endParaRPr lang="en-US" sz="1250" dirty="0"/>
-          </a:p>
-        </p:txBody>
-      </p:sp>
-      <p:sp>
-        <p:nvSpPr>
-          <p:cNvPr id="54" name="Shape 51"/>
-          <p:cNvSpPr/>
-          <p:nvPr/>
-        </p:nvSpPr>
-        <p:spPr>
-          <a:xfrm>
-            <a:off x="4943246" y="4012969"/>
-            <a:ext cx="3244261" cy="0"/>
-          </a:xfrm>
-          <a:prstGeom prst="line">
-            <a:avLst/>
-          </a:prstGeom>
-          <a:noFill/>
-          <a:ln w="25400">
-            <a:solidFill>
-              <a:srgbClr val="6FBEC0"/>
-            </a:solidFill>
-            <a:prstDash val="solid"/>
-          </a:ln>
-        </p:spPr>
-      </p:sp>
-      <p:sp>
-        <p:nvSpPr>
-          <p:cNvPr id="55" name="Shape 52"/>
-          <p:cNvSpPr/>
-          <p:nvPr/>
-        </p:nvSpPr>
-        <p:spPr>
-          <a:xfrm>
-            <a:off x="4943246" y="3958105"/>
-            <a:ext cx="0" cy="109728"/>
-          </a:xfrm>
-          <a:prstGeom prst="line">
-            <a:avLst/>
-          </a:prstGeom>
-          <a:noFill/>
-          <a:ln w="25400">
-            <a:solidFill>
-              <a:srgbClr val="6FBEC0"/>
-            </a:solidFill>
-            <a:prstDash val="solid"/>
-          </a:ln>
-        </p:spPr>
-      </p:sp>
-      <p:sp>
-        <p:nvSpPr>
-          <p:cNvPr id="56" name="Shape 53"/>
-          <p:cNvSpPr/>
-          <p:nvPr/>
-        </p:nvSpPr>
-        <p:spPr>
-          <a:xfrm>
-            <a:off x="8187507" y="3958105"/>
-            <a:ext cx="0" cy="109728"/>
-          </a:xfrm>
-          <a:prstGeom prst="line">
-            <a:avLst/>
-          </a:prstGeom>
-          <a:noFill/>
-          <a:ln w="25400">
-            <a:solidFill>
-              <a:srgbClr val="6FBEC0"/>
-            </a:solidFill>
-            <a:prstDash val="solid"/>
-          </a:ln>
-        </p:spPr>
-      </p:sp>
-      <p:sp>
-        <p:nvSpPr>
-          <p:cNvPr id="57" name="Shape 54"/>
-          <p:cNvSpPr/>
-          <p:nvPr/>
-        </p:nvSpPr>
-        <p:spPr>
-          <a:xfrm>
-            <a:off x="6509705" y="3967249"/>
-            <a:ext cx="91440" cy="91440"/>
-          </a:xfrm>
-          <a:prstGeom prst="diamond">
-            <a:avLst/>
-          </a:prstGeom>
-          <a:solidFill>
-            <a:srgbClr val="12A3A6"/>
-          </a:solidFill>
-          <a:ln/>
-        </p:spPr>
-      </p:sp>
-      <p:sp>
-        <p:nvSpPr>
-          <p:cNvPr id="58" name="Text 55"/>
-          <p:cNvSpPr/>
-          <p:nvPr/>
-        </p:nvSpPr>
-        <p:spPr>
-          <a:xfrm>
-            <a:off x="9765792" y="3866665"/>
-            <a:ext cx="1783080" cy="292608"/>
-          </a:xfrm>
-          <a:prstGeom prst="rect">
-            <a:avLst/>
-          </a:prstGeom>
-          <a:noFill/>
-          <a:ln/>
-        </p:spPr>
-        <p:txBody>
-          <a:bodyPr wrap="square" lIns="0" tIns="0" rIns="0" bIns="0" rtlCol="0" anchor="ctr"/>
-          <a:lstStyle/>
-          <a:p>
-            <a:pPr indent="0" marL="0">
-              <a:buNone/>
-            </a:pPr>
-            <a:r>
-              <a:rPr lang="en-US" sz="950" dirty="0">
-                <a:solidFill>
-                  <a:srgbClr val="4E5E66"/>
-                </a:solidFill>
-                <a:latin typeface="Calibri" pitchFamily="34" charset="0"/>
-                <a:ea typeface="Calibri" pitchFamily="34" charset="-122"/>
-                <a:cs typeface="Calibri" pitchFamily="34" charset="-120"/>
-              </a:rPr>
-              <a:t>0.41 (-0.40 to 1.23)</a:t>
-            </a:r>
-            <a:endParaRPr lang="en-US" sz="950" dirty="0"/>
-          </a:p>
-        </p:txBody>
-      </p:sp>
-      <p:sp>
-        <p:nvSpPr>
-          <p:cNvPr id="59" name="Text 56"/>
-          <p:cNvSpPr/>
-          <p:nvPr/>
-        </p:nvSpPr>
-        <p:spPr>
-          <a:xfrm>
-            <a:off x="640080" y="4244894"/>
-            <a:ext cx="3017520" cy="292608"/>
-          </a:xfrm>
-          <a:prstGeom prst="rect">
-            <a:avLst/>
-          </a:prstGeom>
-          <a:noFill/>
-          <a:ln/>
-        </p:spPr>
-        <p:txBody>
-          <a:bodyPr wrap="square" lIns="0" tIns="0" rIns="0" bIns="0" rtlCol="0" anchor="ctr"/>
-          <a:lstStyle/>
-          <a:p>
-            <a:pPr indent="0" marL="0">
-              <a:buNone/>
-            </a:pPr>
-            <a:r>
-              <a:rPr lang="en-US" sz="1250" dirty="0">
-                <a:solidFill>
-                  <a:srgbClr val="13212A"/>
-                </a:solidFill>
-                <a:latin typeface="Calibri" pitchFamily="34" charset="0"/>
-                <a:ea typeface="Calibri" pitchFamily="34" charset="-122"/>
-                <a:cs typeface="Calibri" pitchFamily="34" charset="-120"/>
-              </a:rPr>
-              <a:t>UACR ≤ 1000</a:t>
-            </a:r>
-            <a:endParaRPr lang="en-US" sz="1250" dirty="0"/>
-          </a:p>
-        </p:txBody>
-      </p:sp>
-      <p:sp>
-        <p:nvSpPr>
-          <p:cNvPr id="60" name="Shape 57"/>
-          <p:cNvSpPr/>
-          <p:nvPr/>
-        </p:nvSpPr>
-        <p:spPr>
-          <a:xfrm>
-            <a:off x="5619963" y="4391198"/>
-            <a:ext cx="1851020" cy="0"/>
-          </a:xfrm>
-          <a:prstGeom prst="line">
-            <a:avLst/>
-          </a:prstGeom>
-          <a:noFill/>
-          <a:ln w="25400">
-            <a:solidFill>
-              <a:srgbClr val="6FBEC0"/>
-            </a:solidFill>
-            <a:prstDash val="solid"/>
-          </a:ln>
-        </p:spPr>
-      </p:sp>
-      <p:sp>
-        <p:nvSpPr>
-          <p:cNvPr id="61" name="Shape 58"/>
-          <p:cNvSpPr/>
-          <p:nvPr/>
-        </p:nvSpPr>
-        <p:spPr>
-          <a:xfrm>
-            <a:off x="5619963" y="4336334"/>
-            <a:ext cx="0" cy="109728"/>
-          </a:xfrm>
-          <a:prstGeom prst="line">
-            <a:avLst/>
-          </a:prstGeom>
-          <a:noFill/>
-          <a:ln w="25400">
-            <a:solidFill>
-              <a:srgbClr val="6FBEC0"/>
-            </a:solidFill>
-            <a:prstDash val="solid"/>
-          </a:ln>
-        </p:spPr>
-      </p:sp>
-      <p:sp>
-        <p:nvSpPr>
-          <p:cNvPr id="62" name="Shape 59"/>
-          <p:cNvSpPr/>
-          <p:nvPr/>
-        </p:nvSpPr>
-        <p:spPr>
-          <a:xfrm>
-            <a:off x="7470983" y="4336334"/>
-            <a:ext cx="0" cy="109728"/>
-          </a:xfrm>
-          <a:prstGeom prst="line">
-            <a:avLst/>
-          </a:prstGeom>
-          <a:noFill/>
-          <a:ln w="25400">
-            <a:solidFill>
-              <a:srgbClr val="6FBEC0"/>
-            </a:solidFill>
-            <a:prstDash val="solid"/>
-          </a:ln>
-        </p:spPr>
-      </p:sp>
-      <p:sp>
-        <p:nvSpPr>
-          <p:cNvPr id="63" name="Shape 60"/>
-          <p:cNvSpPr/>
-          <p:nvPr/>
-        </p:nvSpPr>
-        <p:spPr>
-          <a:xfrm>
-            <a:off x="6489802" y="4345478"/>
-            <a:ext cx="91440" cy="91440"/>
-          </a:xfrm>
-          <a:prstGeom prst="diamond">
-            <a:avLst/>
-          </a:prstGeom>
-          <a:solidFill>
-            <a:srgbClr val="12A3A6"/>
-          </a:solidFill>
-          <a:ln/>
-        </p:spPr>
-      </p:sp>
-      <p:sp>
-        <p:nvSpPr>
-          <p:cNvPr id="64" name="Text 61"/>
-          <p:cNvSpPr/>
-          <p:nvPr/>
-        </p:nvSpPr>
-        <p:spPr>
-          <a:xfrm>
-            <a:off x="9765792" y="4244894"/>
-            <a:ext cx="1783080" cy="292608"/>
-          </a:xfrm>
-          <a:prstGeom prst="rect">
-            <a:avLst/>
-          </a:prstGeom>
-          <a:noFill/>
-          <a:ln/>
-        </p:spPr>
-        <p:txBody>
-          <a:bodyPr wrap="square" lIns="0" tIns="0" rIns="0" bIns="0" rtlCol="0" anchor="ctr"/>
-          <a:lstStyle/>
-          <a:p>
-            <a:pPr indent="0" marL="0">
-              <a:buNone/>
-            </a:pPr>
-            <a:r>
-              <a:rPr lang="en-US" sz="950" dirty="0">
-                <a:solidFill>
-                  <a:srgbClr val="4E5E66"/>
-                </a:solidFill>
-                <a:latin typeface="Calibri" pitchFamily="34" charset="0"/>
-                <a:ea typeface="Calibri" pitchFamily="34" charset="-122"/>
-                <a:cs typeface="Calibri" pitchFamily="34" charset="-120"/>
-              </a:rPr>
-              <a:t>0.40 (-0.06 to 0.87)</a:t>
-            </a:r>
-            <a:endParaRPr lang="en-US" sz="950" dirty="0"/>
-          </a:p>
-        </p:txBody>
-      </p:sp>
-      <p:sp>
-        <p:nvSpPr>
-          <p:cNvPr id="65" name="Text 62"/>
-          <p:cNvSpPr/>
-          <p:nvPr/>
-        </p:nvSpPr>
-        <p:spPr>
-          <a:xfrm>
-            <a:off x="640080" y="4623123"/>
-            <a:ext cx="3017520" cy="292608"/>
-          </a:xfrm>
-          <a:prstGeom prst="rect">
-            <a:avLst/>
-          </a:prstGeom>
-          <a:noFill/>
-          <a:ln/>
-        </p:spPr>
-        <p:txBody>
-          <a:bodyPr wrap="square" lIns="0" tIns="0" rIns="0" bIns="0" rtlCol="0" anchor="ctr"/>
-          <a:lstStyle/>
-          <a:p>
-            <a:pPr indent="0" marL="0">
-              <a:buNone/>
-            </a:pPr>
-            <a:r>
-              <a:rPr lang="en-US" sz="1250" dirty="0">
-                <a:solidFill>
-                  <a:srgbClr val="13212A"/>
-                </a:solidFill>
-                <a:latin typeface="Calibri" pitchFamily="34" charset="0"/>
-                <a:ea typeface="Calibri" pitchFamily="34" charset="-122"/>
-                <a:cs typeface="Calibri" pitchFamily="34" charset="-120"/>
-              </a:rPr>
-              <a:t>UACR &gt; 1000</a:t>
-            </a:r>
-            <a:endParaRPr lang="en-US" sz="1250" dirty="0"/>
-          </a:p>
-        </p:txBody>
-      </p:sp>
-      <p:sp>
-        <p:nvSpPr>
-          <p:cNvPr id="66" name="Shape 63"/>
-          <p:cNvSpPr/>
-          <p:nvPr/>
-        </p:nvSpPr>
-        <p:spPr>
-          <a:xfrm>
-            <a:off x="6834073" y="4769427"/>
-            <a:ext cx="2388413" cy="0"/>
-          </a:xfrm>
-          <a:prstGeom prst="line">
-            <a:avLst/>
-          </a:prstGeom>
-          <a:noFill/>
-          <a:ln w="25400">
-            <a:solidFill>
-              <a:srgbClr val="6FBEC0"/>
-            </a:solidFill>
-            <a:prstDash val="solid"/>
-          </a:ln>
-        </p:spPr>
-      </p:sp>
-      <p:sp>
-        <p:nvSpPr>
-          <p:cNvPr id="67" name="Shape 64"/>
-          <p:cNvSpPr/>
-          <p:nvPr/>
-        </p:nvSpPr>
-        <p:spPr>
-          <a:xfrm>
-            <a:off x="6834073" y="4714563"/>
-            <a:ext cx="0" cy="109728"/>
-          </a:xfrm>
-          <a:prstGeom prst="line">
-            <a:avLst/>
-          </a:prstGeom>
-          <a:noFill/>
-          <a:ln w="25400">
-            <a:solidFill>
-              <a:srgbClr val="6FBEC0"/>
-            </a:solidFill>
-            <a:prstDash val="solid"/>
-          </a:ln>
-        </p:spPr>
-      </p:sp>
-      <p:sp>
-        <p:nvSpPr>
-          <p:cNvPr id="68" name="Shape 65"/>
-          <p:cNvSpPr/>
-          <p:nvPr/>
-        </p:nvSpPr>
-        <p:spPr>
-          <a:xfrm>
-            <a:off x="9222486" y="4714563"/>
-            <a:ext cx="0" cy="109728"/>
-          </a:xfrm>
-          <a:prstGeom prst="line">
-            <a:avLst/>
-          </a:prstGeom>
-          <a:noFill/>
-          <a:ln w="25400">
-            <a:solidFill>
-              <a:srgbClr val="6FBEC0"/>
-            </a:solidFill>
-            <a:prstDash val="solid"/>
-          </a:ln>
-        </p:spPr>
-      </p:sp>
-      <p:sp>
-        <p:nvSpPr>
-          <p:cNvPr id="69" name="Shape 66"/>
-          <p:cNvSpPr/>
-          <p:nvPr/>
-        </p:nvSpPr>
-        <p:spPr>
-          <a:xfrm>
-            <a:off x="7982560" y="4723707"/>
-            <a:ext cx="91440" cy="91440"/>
-          </a:xfrm>
-          <a:prstGeom prst="diamond">
-            <a:avLst/>
-          </a:prstGeom>
-          <a:solidFill>
-            <a:srgbClr val="12A3A6"/>
-          </a:solidFill>
-          <a:ln/>
-        </p:spPr>
-      </p:sp>
-      <p:sp>
-        <p:nvSpPr>
-          <p:cNvPr id="70" name="Text 67"/>
-          <p:cNvSpPr/>
-          <p:nvPr/>
-        </p:nvSpPr>
-        <p:spPr>
-          <a:xfrm>
-            <a:off x="9765792" y="4623123"/>
-            <a:ext cx="1783080" cy="292608"/>
-          </a:xfrm>
-          <a:prstGeom prst="rect">
-            <a:avLst/>
-          </a:prstGeom>
-          <a:noFill/>
-          <a:ln/>
-        </p:spPr>
-        <p:txBody>
-          <a:bodyPr wrap="square" lIns="0" tIns="0" rIns="0" bIns="0" rtlCol="0" anchor="ctr"/>
-          <a:lstStyle/>
-          <a:p>
-            <a:pPr indent="0" marL="0">
-              <a:buNone/>
-            </a:pPr>
-            <a:r>
-              <a:rPr lang="en-US" sz="950" dirty="0">
-                <a:solidFill>
-                  <a:srgbClr val="4E5E66"/>
-                </a:solidFill>
-                <a:latin typeface="Calibri" pitchFamily="34" charset="0"/>
-                <a:ea typeface="Calibri" pitchFamily="34" charset="-122"/>
-                <a:cs typeface="Calibri" pitchFamily="34" charset="-120"/>
-              </a:rPr>
-              <a:t>1.15 (0.55 to 1.75)</a:t>
-            </a:r>
-            <a:endParaRPr lang="en-US" sz="950" dirty="0"/>
-          </a:p>
-        </p:txBody>
-      </p:sp>
-      <p:sp>
-        <p:nvSpPr>
-          <p:cNvPr id="71" name="Text 68"/>
-          <p:cNvSpPr/>
-          <p:nvPr/>
-        </p:nvSpPr>
-        <p:spPr>
-          <a:xfrm>
-            <a:off x="640080" y="5001352"/>
-            <a:ext cx="3017520" cy="292608"/>
-          </a:xfrm>
-          <a:prstGeom prst="rect">
-            <a:avLst/>
-          </a:prstGeom>
-          <a:noFill/>
-          <a:ln/>
-        </p:spPr>
-        <p:txBody>
-          <a:bodyPr wrap="square" lIns="0" tIns="0" rIns="0" bIns="0" rtlCol="0" anchor="ctr"/>
-          <a:lstStyle/>
-          <a:p>
-            <a:pPr indent="0" marL="0">
-              <a:buNone/>
-            </a:pPr>
-            <a:r>
-              <a:rPr lang="en-US" sz="1250" dirty="0">
-                <a:solidFill>
-                  <a:srgbClr val="13212A"/>
-                </a:solidFill>
-                <a:latin typeface="Calibri" pitchFamily="34" charset="0"/>
-                <a:ea typeface="Calibri" pitchFamily="34" charset="-122"/>
-                <a:cs typeface="Calibri" pitchFamily="34" charset="-120"/>
-              </a:rPr>
-              <a:t>SGLT2i: yes</a:t>
-            </a:r>
-            <a:endParaRPr lang="en-US" sz="1250" dirty="0"/>
-          </a:p>
-        </p:txBody>
-      </p:sp>
-      <p:sp>
-        <p:nvSpPr>
-          <p:cNvPr id="72" name="Shape 69"/>
-          <p:cNvSpPr/>
-          <p:nvPr/>
-        </p:nvSpPr>
-        <p:spPr>
-          <a:xfrm>
-            <a:off x="5619963" y="5147656"/>
-            <a:ext cx="3562716" cy="0"/>
-          </a:xfrm>
-          <a:prstGeom prst="line">
-            <a:avLst/>
-          </a:prstGeom>
-          <a:noFill/>
-          <a:ln w="25400">
-            <a:solidFill>
-              <a:srgbClr val="6FBEC0"/>
-            </a:solidFill>
-            <a:prstDash val="solid"/>
-          </a:ln>
-        </p:spPr>
-      </p:sp>
-      <p:sp>
-        <p:nvSpPr>
-          <p:cNvPr id="73" name="Shape 70"/>
-          <p:cNvSpPr/>
-          <p:nvPr/>
-        </p:nvSpPr>
-        <p:spPr>
-          <a:xfrm>
-            <a:off x="5619963" y="5092792"/>
-            <a:ext cx="0" cy="109728"/>
-          </a:xfrm>
-          <a:prstGeom prst="line">
-            <a:avLst/>
-          </a:prstGeom>
-          <a:noFill/>
-          <a:ln w="25400">
-            <a:solidFill>
-              <a:srgbClr val="6FBEC0"/>
-            </a:solidFill>
-            <a:prstDash val="solid"/>
-          </a:ln>
-        </p:spPr>
-      </p:sp>
-      <p:sp>
-        <p:nvSpPr>
-          <p:cNvPr id="74" name="Shape 71"/>
-          <p:cNvSpPr/>
-          <p:nvPr/>
-        </p:nvSpPr>
-        <p:spPr>
-          <a:xfrm>
-            <a:off x="9182679" y="5092792"/>
-            <a:ext cx="0" cy="109728"/>
-          </a:xfrm>
-          <a:prstGeom prst="line">
-            <a:avLst/>
-          </a:prstGeom>
-          <a:noFill/>
-          <a:ln w="25400">
-            <a:solidFill>
-              <a:srgbClr val="6FBEC0"/>
-            </a:solidFill>
-            <a:prstDash val="solid"/>
-          </a:ln>
-        </p:spPr>
-      </p:sp>
-      <p:sp>
-        <p:nvSpPr>
-          <p:cNvPr id="75" name="Shape 72"/>
-          <p:cNvSpPr/>
-          <p:nvPr/>
-        </p:nvSpPr>
-        <p:spPr>
-          <a:xfrm>
-            <a:off x="7365553" y="5101936"/>
-            <a:ext cx="91440" cy="91440"/>
-          </a:xfrm>
-          <a:prstGeom prst="diamond">
-            <a:avLst/>
-          </a:prstGeom>
-          <a:solidFill>
-            <a:srgbClr val="12A3A6"/>
-          </a:solidFill>
-          <a:ln/>
-        </p:spPr>
-      </p:sp>
-      <p:sp>
-        <p:nvSpPr>
-          <p:cNvPr id="76" name="Text 73"/>
-          <p:cNvSpPr/>
-          <p:nvPr/>
-        </p:nvSpPr>
-        <p:spPr>
-          <a:xfrm>
-            <a:off x="9765792" y="5001352"/>
-            <a:ext cx="1783080" cy="292608"/>
-          </a:xfrm>
-          <a:prstGeom prst="rect">
-            <a:avLst/>
-          </a:prstGeom>
-          <a:noFill/>
-          <a:ln/>
-        </p:spPr>
-        <p:txBody>
-          <a:bodyPr wrap="square" lIns="0" tIns="0" rIns="0" bIns="0" rtlCol="0" anchor="ctr"/>
-          <a:lstStyle/>
-          <a:p>
-            <a:pPr indent="0" marL="0">
-              <a:buNone/>
-            </a:pPr>
-            <a:r>
-              <a:rPr lang="en-US" sz="950" dirty="0">
-                <a:solidFill>
-                  <a:srgbClr val="4E5E66"/>
-                </a:solidFill>
-                <a:latin typeface="Calibri" pitchFamily="34" charset="0"/>
-                <a:ea typeface="Calibri" pitchFamily="34" charset="-122"/>
-                <a:cs typeface="Calibri" pitchFamily="34" charset="-120"/>
-              </a:rPr>
-              <a:t>0.84 (-0.06 to 1.73)</a:t>
-            </a:r>
-            <a:endParaRPr lang="en-US" sz="950" dirty="0"/>
-          </a:p>
-        </p:txBody>
-      </p:sp>
-      <p:sp>
-        <p:nvSpPr>
-          <p:cNvPr id="77" name="Text 74"/>
-          <p:cNvSpPr/>
-          <p:nvPr/>
-        </p:nvSpPr>
-        <p:spPr>
-          <a:xfrm>
-            <a:off x="640080" y="5379581"/>
-            <a:ext cx="3017520" cy="292608"/>
-          </a:xfrm>
-          <a:prstGeom prst="rect">
-            <a:avLst/>
-          </a:prstGeom>
-          <a:noFill/>
-          <a:ln/>
-        </p:spPr>
-        <p:txBody>
-          <a:bodyPr wrap="square" lIns="0" tIns="0" rIns="0" bIns="0" rtlCol="0" anchor="ctr"/>
-          <a:lstStyle/>
-          <a:p>
-            <a:pPr indent="0" marL="0">
-              <a:buNone/>
-            </a:pPr>
-            <a:r>
-              <a:rPr lang="en-US" sz="1250" dirty="0">
-                <a:solidFill>
-                  <a:srgbClr val="13212A"/>
-                </a:solidFill>
-                <a:latin typeface="Calibri" pitchFamily="34" charset="0"/>
-                <a:ea typeface="Calibri" pitchFamily="34" charset="-122"/>
-                <a:cs typeface="Calibri" pitchFamily="34" charset="-120"/>
-              </a:rPr>
-              <a:t>SGLT2i: no</a:t>
-            </a:r>
-            <a:endParaRPr lang="en-US" sz="1250" dirty="0"/>
-          </a:p>
-        </p:txBody>
-      </p:sp>
-      <p:sp>
-        <p:nvSpPr>
-          <p:cNvPr id="78" name="Shape 75"/>
-          <p:cNvSpPr/>
-          <p:nvPr/>
-        </p:nvSpPr>
-        <p:spPr>
-          <a:xfrm>
-            <a:off x="6236970" y="5525885"/>
-            <a:ext cx="1612179" cy="0"/>
-          </a:xfrm>
-          <a:prstGeom prst="line">
-            <a:avLst/>
-          </a:prstGeom>
-          <a:noFill/>
-          <a:ln w="25400">
-            <a:solidFill>
-              <a:srgbClr val="6FBEC0"/>
-            </a:solidFill>
-            <a:prstDash val="solid"/>
-          </a:ln>
-        </p:spPr>
-      </p:sp>
-      <p:sp>
-        <p:nvSpPr>
-          <p:cNvPr id="79" name="Shape 76"/>
-          <p:cNvSpPr/>
-          <p:nvPr/>
-        </p:nvSpPr>
-        <p:spPr>
-          <a:xfrm>
-            <a:off x="6236970" y="5471021"/>
-            <a:ext cx="0" cy="109728"/>
-          </a:xfrm>
-          <a:prstGeom prst="line">
-            <a:avLst/>
-          </a:prstGeom>
-          <a:noFill/>
-          <a:ln w="25400">
-            <a:solidFill>
-              <a:srgbClr val="6FBEC0"/>
-            </a:solidFill>
-            <a:prstDash val="solid"/>
-          </a:ln>
-        </p:spPr>
-      </p:sp>
-      <p:sp>
-        <p:nvSpPr>
-          <p:cNvPr id="80" name="Shape 77"/>
-          <p:cNvSpPr/>
-          <p:nvPr/>
-        </p:nvSpPr>
-        <p:spPr>
-          <a:xfrm>
-            <a:off x="7849149" y="5471021"/>
-            <a:ext cx="0" cy="109728"/>
-          </a:xfrm>
-          <a:prstGeom prst="line">
-            <a:avLst/>
-          </a:prstGeom>
-          <a:noFill/>
-          <a:ln w="25400">
-            <a:solidFill>
-              <a:srgbClr val="6FBEC0"/>
-            </a:solidFill>
-            <a:prstDash val="solid"/>
-          </a:ln>
-        </p:spPr>
-      </p:sp>
-      <p:sp>
-        <p:nvSpPr>
-          <p:cNvPr id="81" name="Shape 78"/>
-          <p:cNvSpPr/>
-          <p:nvPr/>
-        </p:nvSpPr>
-        <p:spPr>
-          <a:xfrm>
-            <a:off x="6987388" y="5480165"/>
-            <a:ext cx="91440" cy="91440"/>
-          </a:xfrm>
-          <a:prstGeom prst="diamond">
-            <a:avLst/>
-          </a:prstGeom>
-          <a:solidFill>
-            <a:srgbClr val="12A3A6"/>
-          </a:solidFill>
-          <a:ln/>
-        </p:spPr>
-      </p:sp>
-      <p:sp>
-        <p:nvSpPr>
-          <p:cNvPr id="82" name="Text 79"/>
-          <p:cNvSpPr/>
-          <p:nvPr/>
-        </p:nvSpPr>
-        <p:spPr>
-          <a:xfrm>
-            <a:off x="9765792" y="5379581"/>
-            <a:ext cx="1783080" cy="292608"/>
-          </a:xfrm>
-          <a:prstGeom prst="rect">
-            <a:avLst/>
-          </a:prstGeom>
-          <a:noFill/>
-          <a:ln/>
-        </p:spPr>
-        <p:txBody>
-          <a:bodyPr wrap="square" lIns="0" tIns="0" rIns="0" bIns="0" rtlCol="0" anchor="ctr"/>
-          <a:lstStyle/>
-          <a:p>
-            <a:pPr indent="0" marL="0">
-              <a:buNone/>
-            </a:pPr>
-            <a:r>
-              <a:rPr lang="en-US" sz="950" dirty="0">
-                <a:solidFill>
-                  <a:srgbClr val="4E5E66"/>
-                </a:solidFill>
-                <a:latin typeface="Calibri" pitchFamily="34" charset="0"/>
-                <a:ea typeface="Calibri" pitchFamily="34" charset="-122"/>
-                <a:cs typeface="Calibri" pitchFamily="34" charset="-120"/>
-              </a:rPr>
-              <a:t>0.65 (0.25 to 1.06)</a:t>
-            </a:r>
-            <a:endParaRPr lang="en-US" sz="950" dirty="0"/>
-          </a:p>
-        </p:txBody>
-      </p:sp>
-      <p:sp>
-        <p:nvSpPr>
-          <p:cNvPr id="83" name="Text 80"/>
+              <a:lnSpc>
+                <a:spcPct val="105000"/>
+              </a:lnSpc>
+              <a:buNone/>
+            </a:pPr>
+            <a:r>
+              <a:rPr lang="en-US" sz="1600" b="1" dirty="0">
+                <a:solidFill>
+                  <a:srgbClr val="0E8385"/>
+                </a:solidFill>
+                <a:latin typeface="Calibri" pitchFamily="34" charset="0"/>
+                <a:ea typeface="Calibri" pitchFamily="34" charset="-122"/>
+                <a:cs typeface="Calibri" pitchFamily="34" charset="-120"/>
+              </a:rPr>
+              <a:t>Every subgroup favors finerenone; the effect is largest with heavy albuminuria (UACR &gt;1000).</a:t>
+            </a:r>
+            <a:endParaRPr lang="en-US" sz="1600" dirty="0"/>
+          </a:p>
+        </p:txBody>
+      </p:sp>
+      <p:pic>
+        <p:nvPicPr>
+          <p:cNvPr id="7" name="Image 1" descr="fig2.png">    </p:cNvPr>
+          <p:cNvPicPr>
+            <a:picLocks noChangeAspect="1"/>
+          </p:cNvPicPr>
+          <p:nvPr/>
+        </p:nvPicPr>
+        <p:blipFill>
+          <a:blip r:embed="rId2"/>
+          <a:stretch>
+            <a:fillRect/>
+          </a:stretch>
+        </p:blipFill>
+        <p:spPr>
+          <a:xfrm>
+            <a:off x="886968" y="1536192"/>
+            <a:ext cx="10424160" cy="4645152"/>
+          </a:xfrm>
+          <a:prstGeom prst="rect">
+            <a:avLst/>
+          </a:prstGeom>
+        </p:spPr>
+      </p:pic>
+      <p:sp>
+        <p:nvSpPr>
+          <p:cNvPr id="8" name="Text 4"/>
           <p:cNvSpPr/>
           <p:nvPr/>
         </p:nvSpPr>
@@ -13757,7 +10613,7 @@
                 <a:ea typeface="Calibri" pitchFamily="34" charset="-122"/>
                 <a:cs typeface="Calibri" pitchFamily="34" charset="-120"/>
               </a:rPr>
-              <a:t>Adapted from Figure 2. CIs not adjusted for multiplicity.</a:t>
+              <a:t>Figure 2.  Heerspink et al., N Engl J Med 2026.  CIs not adjusted for multiplicity.</a:t>
             </a:r>
             <a:endParaRPr lang="en-US" sz="850" dirty="0"/>
           </a:p>
@@ -13765,7 +10621,7 @@
       </p:sp>
       <p:sp>
         <p:nvSpPr>
-          <p:cNvPr id="84" name="Text 81"/>
+          <p:cNvPr id="9" name="Text 5"/>
           <p:cNvSpPr/>
           <p:nvPr/>
         </p:nvSpPr>
@@ -13818,7 +10674,7 @@
       </p:sp>
       <p:sp>
         <p:nvSpPr>
-          <p:cNvPr id="85" name="Text 82"/>
+          <p:cNvPr id="10" name="Text 6"/>
           <p:cNvSpPr/>
           <p:nvPr/>
         </p:nvSpPr>

</xml_diff>

<commit_message>
Rest the deck on three sourced articles only
Removed references the deck did not verify against a source PDF: the
FIDELIO-DKD and FIGARO-DKD names (FIDELITY is now described as a
pre-specified pooled analysis of two phase 3 trials) and the external
GFR-slope meta-analysis (the surrogate point is now stated generally).
Comparison content now rests only on FIND-CKD, FIDELITY and BARACK-D.

Co-Authored-By: Claude Opus 4.8 <noreply@anthropic.com>
Claude-Session: https://claude.ai/code/session_016WM8gpgPPTpUY1fDjELfFT
</commit_message>
<xml_diff>
--- a/FIND-CKD.pptx
+++ b/FIND-CKD.pptx
@@ -1740,7 +1740,7 @@
           <a:p>
             <a:r>
               <a:rPr lang="en-US" dirty="0"/>
-              <a:t>Headline total slope 0.7/yr, P&lt;0.001, almost identical to FIDELIO. The acute period favors placebo by 1.2 (the dip), dragging the total down. The chronic slope is 1.2/yr, nearly double. Judge finerenone by the chronic slope.</a:t>
+              <a:t>Headline total slope 0.7/yr, P&lt;0.001, almost identical to what finerenone showed in diabetic CKD. The acute period favors placebo by 1.2 (the dip), dragging the total down. The chronic slope is 1.2/yr, nearly double. Judge finerenone by the chronic slope.</a:t>
             </a:r>
             <a:endParaRPr lang="en-US" dirty="0"/>
           </a:p>
@@ -3324,7 +3324,7 @@
           <a:p>
             <a:r>
               <a:rPr lang="en-US" dirty="0"/>
-              <a:t>FIDELITY pooled FIDELIO and FIGARO, ~13,000 patients, for a CV composite of 0.86 and a kidney composite of 0.77, using the same ≥57% eGFR-decline definition FIND-CKD adopts. All diabetic. That is the gap FIND-CKD fills.</a:t>
+              <a:t>FIDELITY pooled two phase 3 finerenone trials, ~13,000 patients, for a CV composite of 0.86 and a kidney composite of 0.77, using the same ≥57% eGFR-decline definition FIND-CKD adopts. All diabetic. That is the gap FIND-CKD fills.</a:t>
             </a:r>
             <a:endParaRPr lang="en-US" dirty="0"/>
           </a:p>
@@ -8823,7 +8823,7 @@
                 <a:ea typeface="Calibri" pitchFamily="34" charset="-122"/>
                 <a:cs typeface="Calibri" pitchFamily="34" charset="-120"/>
               </a:rPr>
-              <a:t>A meta-analysis of 66 randomized trials found that slowing eGFR decline by about 0.75 per year predicts a 23% lower risk of hard kidney outcomes. An accepted surrogate, but a surrogate all the same.</a:t>
+              <a:t>eGFR slope is increasingly used as a surrogate for kidney-failure risk in CKD trials, and is accepted for that purpose. Still, it is a surrogate, not a hard outcome.</a:t>
             </a:r>
             <a:endParaRPr lang="en-US" sz="1450" dirty="0"/>
           </a:p>
@@ -15434,7 +15434,7 @@
                 <a:ea typeface="Calibri" pitchFamily="34" charset="-122"/>
                 <a:cs typeface="Calibri" pitchFamily="34" charset="-120"/>
               </a:rPr>
-              <a:t>FIDELIO + FIGARO; 13,026</a:t>
+              <a:t>Pooled analysis; 13,026</a:t>
             </a:r>
             <a:endParaRPr lang="en-US" sz="1300" dirty="0"/>
           </a:p>
@@ -19139,7 +19139,7 @@
                 <a:ea typeface="Calibri" pitchFamily="34" charset="-122"/>
                 <a:cs typeface="Calibri" pitchFamily="34" charset="-120"/>
               </a:rPr>
-              <a:t>Finerenone reduced kidney and cardiovascular events in diabetic CKD (FIDELIO-DKD, FIGARO-DKD, FIDELITY pooled).</a:t>
+              <a:t>Finerenone reduced kidney and cardiovascular events in diabetic CKD (the FIDELITY pooled analysis).</a:t>
             </a:r>
             <a:endParaRPr lang="en-US" sz="1550" dirty="0"/>
           </a:p>
@@ -20088,7 +20088,7 @@
                 <a:ea typeface="Calibri" pitchFamily="34" charset="-122"/>
                 <a:cs typeface="Calibri" pitchFamily="34" charset="-120"/>
               </a:rPr>
-              <a:t>FIDELITY pooled the FIDELIO-DKD and FIGARO-DKD trials: 13,026 patients with type 2 diabetes and CKD.</a:t>
+              <a:t>FIDELITY was a pre-specified pooled analysis of two phase 3 finerenone trials: 13,026 patients with type 2 diabetes and CKD.</a:t>
             </a:r>
             <a:endParaRPr lang="en-US" sz="1350" dirty="0"/>
           </a:p>

</xml_diff>